<commit_message>
slides(vol-10): split テーマ解説 into 2 pages with actual flow screenshots
スライド8(テーマ解説) を実際に組んだフローの内容に合わせて2分割:
- 8 (1/2): Forms「新しい応答」→「応答の詳細を取得」→「作成(Compose)」
- 9 (2/2): SP「項目の作成」→「開始して承認を待機」→ 条件分岐(承認/却下) → SP更新+Teams通知

各ページにPA Studioから撮ったフロー実物のスクショを配置。

Co-Authored-By: Claude Opus 4.7 (1M context) <noreply@anthropic.com>
</commit_message>
<xml_diff>
--- a/assets/pa45/P010_PA45_BizReview_20260514.pptx
+++ b/assets/pa45/P010_PA45_BizReview_20260514.pptx
@@ -16,6 +16,7 @@
     <p:sldId id="271" r:id="rId7"/>
     <p:sldId id="261" r:id="rId8"/>
     <p:sldId id="280" r:id="rId9"/>
+    <p:sldId id="291" r:id="rId26"/>
     <p:sldId id="289" r:id="rId10"/>
     <p:sldId id="290" r:id="rId11"/>
     <p:sldId id="286" r:id="rId12"/>
@@ -2642,7 +2643,7 @@
         </p:nvSpPr>
         <p:spPr>
           <a:xfrm>
-            <a:off x="0" y="0"/>
+            <a:off x="305" y="-9144"/>
             <a:ext cx="12191695" cy="1485900"/>
           </a:xfrm>
           <a:prstGeom prst="rect">
@@ -2742,8 +2743,8 @@
         </p:nvSpPr>
         <p:spPr>
           <a:xfrm>
-            <a:off x="457200" y="533095"/>
-            <a:ext cx="7781544" cy="715061"/>
+            <a:off x="322110" y="628650"/>
+            <a:ext cx="9601200" cy="715061"/>
           </a:xfrm>
           <a:prstGeom prst="rect">
             <a:avLst/>
@@ -2759,7 +2760,7 @@
               <a:buNone/>
             </a:pPr>
             <a:r>
-              <a:rPr lang="en-US" sz="3200" b="1" dirty="0">
+              <a:rPr lang="en-US" sz="3600" b="1" dirty="0">
                 <a:solidFill>
                   <a:srgbClr val="1F2937"/>
                 </a:solidFill>
@@ -2767,9 +2768,9 @@
                 <a:ea typeface="Noto Sans JP" pitchFamily="34" charset="-122"/>
                 <a:cs typeface="Noto Sans JP" pitchFamily="34" charset="-120"/>
               </a:rPr>
-              <a:t>事前準備 ②  SharePointリストを作る</a:t>
-            </a:r>
-            <a:endParaRPr lang="en-US" sz="3200" dirty="0"/>
+              <a:t>事前準備 ①  Formsの設問を作る</a:t>
+            </a:r>
+            <a:endParaRPr lang="en-US" sz="3600" dirty="0"/>
           </a:p>
         </p:txBody>
       </p:sp>
@@ -2854,7 +2855,7 @@
         </p:nvSpPr>
         <p:spPr>
           <a:xfrm>
-            <a:off x="-37948" y="1494313"/>
+            <a:off x="305" y="1485900"/>
             <a:ext cx="12191695" cy="4914900"/>
           </a:xfrm>
           <a:prstGeom prst="rect">
@@ -3259,8 +3260,8 @@
         </p:nvSpPr>
         <p:spPr>
           <a:xfrm>
-            <a:off x="265580" y="1714500"/>
-            <a:ext cx="6971243" cy="4428037"/>
+            <a:off x="204620" y="1781251"/>
+            <a:ext cx="6544523" cy="3947047"/>
           </a:xfrm>
           <a:prstGeom prst="rect">
             <a:avLst/>
@@ -3284,7 +3285,7 @@
                 <a:ea typeface="Noto Sans JP" pitchFamily="34" charset="-122"/>
                 <a:cs typeface="Noto Sans JP" pitchFamily="34" charset="-120"/>
               </a:rPr>
-              <a:t>🎯 目的：申請データを蓄積して、</a:t>
+              <a:t>🎯 目的：申請者がスマホからも入力できる</a:t>
             </a:r>
             <a:endParaRPr lang="en-US" altLang="ja-JP" sz="2000">
               <a:solidFill>
@@ -3299,17 +3300,6 @@
             <a:pPr marL="0" indent="0" algn="l">
               <a:buNone/>
             </a:pPr>
-            <a:r>
-              <a:rPr lang="ja-JP" altLang="en-US" sz="2000">
-                <a:solidFill>
-                  <a:srgbClr val="1F2937"/>
-                </a:solidFill>
-                <a:latin typeface="Noto Sans JP" pitchFamily="34" charset="0"/>
-                <a:ea typeface="Noto Sans JP" pitchFamily="34" charset="-122"/>
-                <a:cs typeface="Noto Sans JP" pitchFamily="34" charset="-120"/>
-              </a:rPr>
-              <a:t>上司も経理もあとから見返せる「台帳」にする</a:t>
-            </a:r>
             <a:endParaRPr lang="en-US" altLang="ja-JP" sz="2000">
               <a:solidFill>
                 <a:srgbClr val="1F2937"/>
@@ -3323,6 +3313,29 @@
             <a:pPr marL="0" indent="0" algn="l">
               <a:buNone/>
             </a:pPr>
+            <a:r>
+              <a:rPr lang="ja-JP" altLang="en-US" sz="2000">
+                <a:solidFill>
+                  <a:srgbClr val="1F2937"/>
+                </a:solidFill>
+                <a:latin typeface="Noto Sans JP" pitchFamily="34" charset="0"/>
+                <a:ea typeface="Noto Sans JP" pitchFamily="34" charset="-122"/>
+                <a:cs typeface="Noto Sans JP" pitchFamily="34" charset="-120"/>
+                <a:hlinkClick r:id="rId2"/>
+              </a:rPr>
+              <a:t>「経費申請フォーム」</a:t>
+            </a:r>
+            <a:r>
+              <a:rPr lang="ja-JP" altLang="en-US" sz="2000">
+                <a:solidFill>
+                  <a:srgbClr val="1F2937"/>
+                </a:solidFill>
+                <a:latin typeface="Noto Sans JP" pitchFamily="34" charset="0"/>
+                <a:ea typeface="Noto Sans JP" pitchFamily="34" charset="-122"/>
+                <a:cs typeface="Noto Sans JP" pitchFamily="34" charset="-120"/>
+              </a:rPr>
+              <a:t>を用意する</a:t>
+            </a:r>
             <a:endParaRPr lang="en-US" altLang="ja-JP" sz="2000">
               <a:solidFill>
                 <a:srgbClr val="1F2937"/>
@@ -3336,17 +3349,6 @@
             <a:pPr marL="0" indent="0" algn="l">
               <a:buNone/>
             </a:pPr>
-            <a:r>
-              <a:rPr lang="ja-JP" altLang="en-US" sz="2000">
-                <a:solidFill>
-                  <a:srgbClr val="1F2937"/>
-                </a:solidFill>
-                <a:latin typeface="Noto Sans JP" pitchFamily="34" charset="0"/>
-                <a:ea typeface="Noto Sans JP" pitchFamily="34" charset="-122"/>
-                <a:cs typeface="Noto Sans JP" pitchFamily="34" charset="-120"/>
-              </a:rPr>
-              <a:t>・SharePointサイト &gt; 新規 &gt; リスト &gt; 空のリストを選択</a:t>
-            </a:r>
             <a:endParaRPr lang="en-US" altLang="ja-JP" sz="2000">
               <a:solidFill>
                 <a:srgbClr val="1F2937"/>
@@ -3360,6 +3362,17 @@
             <a:pPr marL="0" indent="0" algn="l">
               <a:buNone/>
             </a:pPr>
+            <a:r>
+              <a:rPr lang="ja-JP" altLang="en-US" sz="2000">
+                <a:solidFill>
+                  <a:srgbClr val="1F2937"/>
+                </a:solidFill>
+                <a:latin typeface="Noto Sans JP" pitchFamily="34" charset="0"/>
+                <a:ea typeface="Noto Sans JP" pitchFamily="34" charset="-122"/>
+                <a:cs typeface="Noto Sans JP" pitchFamily="34" charset="-120"/>
+              </a:rPr>
+              <a:t>・新しいFormsを作成（タイトル：経費申請）</a:t>
+            </a:r>
             <a:endParaRPr lang="en-US" altLang="ja-JP" sz="2000">
               <a:solidFill>
                 <a:srgbClr val="1F2937"/>
@@ -3374,14 +3387,8 @@
               <a:buNone/>
             </a:pPr>
             <a:r>
-              <a:t>・リスト名：経費申請</a:t>
-            </a:r>
-            <a:endParaRPr lang="en-US"/>
-          </a:p>
-          <a:p>
-            <a:pPr marL="0" indent="0" algn="l">
-              <a:buNone/>
-            </a:pPr>
+              <a:t>・設問は次の4つだけでOK</a:t>
+            </a:r>
             <a:endParaRPr lang="ja-JP" altLang="en-US" sz="2000">
               <a:solidFill>
                 <a:srgbClr val="1F2937"/>
@@ -3404,28 +3411,15 @@
                 <a:ea typeface="Noto Sans JP" pitchFamily="34" charset="-122"/>
                 <a:cs typeface="Noto Sans JP" pitchFamily="34" charset="-120"/>
               </a:rPr>
-              <a:t>・列を3つ追加（Title列は最初からあるのでそのまま使用）</a:t>
-            </a:r>
-          </a:p>
-          <a:p>
-            <a:pPr marL="0" indent="0" algn="l">
-              <a:buNone/>
-            </a:pPr>
-            <a:r>
-              <a:t>　① Title（テキスト・既定）　申請の見出し</a:t>
-            </a:r>
-            <a:endParaRPr lang="en-US"/>
-          </a:p>
-          <a:p>
-            <a:pPr marL="0" indent="0" algn="l">
-              <a:buNone/>
-            </a:pPr>
-            <a:r>
-              <a:rPr lang="ja-JP" altLang="en-US"/>
-              <a:t>　　</a:t>
-            </a:r>
-            <a:r>
-              <a:t>（フローでサマリ文を入れる）</a:t>
+              <a:t>　① お名前（テキスト・短答／必須）</a:t>
+            </a:r>
+          </a:p>
+          <a:p>
+            <a:pPr marL="0" indent="0" algn="l">
+              <a:buNone/>
+            </a:pPr>
+            <a:r>
+              <a:t>　② 金額（数値・必須／オプションで「0以上の数値」制限）</a:t>
             </a:r>
             <a:endParaRPr lang="en-US" altLang="ja-JP" sz="2000">
               <a:solidFill>
@@ -3449,7 +3443,7 @@
                 <a:ea typeface="Noto Sans JP" pitchFamily="34" charset="-122"/>
                 <a:cs typeface="Noto Sans JP" pitchFamily="34" charset="-120"/>
               </a:rPr>
-              <a:t>　② Detail（複数行テキスト）　Formsの「詳細」を保存</a:t>
+              <a:t>　③ 用途（テキスト・短答／必須）　</a:t>
             </a:r>
             <a:endParaRPr lang="en-US" altLang="ja-JP" sz="2000">
               <a:solidFill>
@@ -3465,7 +3459,31 @@
               <a:buNone/>
             </a:pPr>
             <a:r>
-              <a:t>　③ Status（選択肢）　「申請中」「承認済」「却下」の3択</a:t>
+              <a:rPr lang="ja-JP" altLang="en-US" sz="2000">
+                <a:solidFill>
+                  <a:srgbClr val="1F2937"/>
+                </a:solidFill>
+                <a:latin typeface="Noto Sans JP" pitchFamily="34" charset="0"/>
+                <a:ea typeface="Noto Sans JP" pitchFamily="34" charset="-122"/>
+                <a:cs typeface="Noto Sans JP" pitchFamily="34" charset="-120"/>
+              </a:rPr>
+              <a:t>　　例：会議費、消耗品など</a:t>
+            </a:r>
+            <a:endParaRPr lang="en-US" altLang="ja-JP" sz="2000">
+              <a:solidFill>
+                <a:srgbClr val="1F2937"/>
+              </a:solidFill>
+              <a:latin typeface="Noto Sans JP" pitchFamily="34" charset="0"/>
+              <a:ea typeface="Noto Sans JP" pitchFamily="34" charset="-122"/>
+              <a:cs typeface="Noto Sans JP" pitchFamily="34" charset="-120"/>
+            </a:endParaRPr>
+          </a:p>
+          <a:p>
+            <a:pPr marL="0" indent="0" algn="l">
+              <a:buNone/>
+            </a:pPr>
+            <a:r>
+              <a:t>　④ 詳細（テキスト・長答／任意）　申請理由を自由記述</a:t>
             </a:r>
             <a:endParaRPr lang="ja-JP" altLang="en-US" sz="2000">
               <a:solidFill>
@@ -3481,7 +3499,7 @@
               <a:buNone/>
             </a:pPr>
             <a:r>
-              <a:t>・既定値：Status =「申請中」にしておくと安心</a:t>
+              <a:t>・「回答の収集」でリンクをコピーしておく → 後で社内に共有</a:t>
             </a:r>
             <a:endParaRPr lang="ja-JP" altLang="en-US" sz="2000">
               <a:solidFill>
@@ -3496,7 +3514,7 @@
             <a:pPr marL="0" indent="0" algn="l">
               <a:buNone/>
             </a:pPr>
-            <a:endParaRPr lang="ja-JP" altLang="en-US" sz="2000" b="1" dirty="0">
+            <a:endParaRPr lang="ja-JP" altLang="en-US" sz="2000" dirty="0">
               <a:solidFill>
                 <a:srgbClr val="1F2937"/>
               </a:solidFill>
@@ -3509,10 +3527,10 @@
       </p:sp>
       <p:pic>
         <p:nvPicPr>
-          <p:cNvPr id="14" name="図 13" descr="No10 Expense Claim List&#10;&#10;AI 生成コンテンツは誤りを含む可能性があります。">
+          <p:cNvPr id="15" name="図 14" descr="The image shows a form with two proposals, a section for personal names, a field for monetary values, a section for purposes, and a field for additional details.&#10;&#10;AI 生成コンテンツは誤りを含む可能性があります。">
             <a:extLst>
               <a:ext uri="{FF2B5EF4-FFF2-40B4-BE49-F238E27FC236}">
-                <a16:creationId xmlns:a16="http://schemas.microsoft.com/office/drawing/2014/main" id="{C2EF7902-2BBE-0FB4-C1D1-D35830F898C7}"/>
+                <a16:creationId xmlns:a16="http://schemas.microsoft.com/office/drawing/2014/main" id="{689B1446-4E1D-9168-07ED-183171FE5DDA}"/>
               </a:ext>
             </a:extLst>
           </p:cNvPr>
@@ -3522,15 +3540,15 @@
           <p:nvPr/>
         </p:nvPicPr>
         <p:blipFill>
-          <a:blip r:embed="rId2"/>
+          <a:blip r:embed="rId3"/>
           <a:stretch>
             <a:fillRect/>
           </a:stretch>
         </p:blipFill>
         <p:spPr>
           <a:xfrm>
-            <a:off x="7009653" y="1864303"/>
-            <a:ext cx="4810796" cy="3915321"/>
+            <a:off x="7537497" y="644768"/>
+            <a:ext cx="3520006" cy="5457141"/>
           </a:xfrm>
           <a:prstGeom prst="rect">
             <a:avLst/>
@@ -3772,7 +3790,7 @@
               <a:buNone/>
             </a:pPr>
             <a:r>
-              <a:rPr lang="en-US" sz="2400" b="1" dirty="0">
+              <a:rPr lang="en-US" sz="3200" b="1" dirty="0">
                 <a:solidFill>
                   <a:srgbClr val="1F2937"/>
                 </a:solidFill>
@@ -3780,9 +3798,9 @@
                 <a:ea typeface="Noto Sans JP" pitchFamily="34" charset="-122"/>
                 <a:cs typeface="Noto Sans JP" pitchFamily="34" charset="-120"/>
               </a:rPr>
-              <a:t>フロー解説 ①  申請を受け取る</a:t>
-            </a:r>
-            <a:endParaRPr lang="en-US" sz="2400" dirty="0"/>
+              <a:t>事前準備 ②  SharePointリストを作る</a:t>
+            </a:r>
+            <a:endParaRPr lang="en-US" sz="3200" dirty="0"/>
           </a:p>
         </p:txBody>
       </p:sp>
@@ -3867,7 +3885,7 @@
         </p:nvSpPr>
         <p:spPr>
           <a:xfrm>
-            <a:off x="305" y="1485900"/>
+            <a:off x="-37948" y="1494313"/>
             <a:ext cx="12191695" cy="4914900"/>
           </a:xfrm>
           <a:prstGeom prst="rect">
@@ -4272,8 +4290,8 @@
         </p:nvSpPr>
         <p:spPr>
           <a:xfrm>
-            <a:off x="126243" y="1705357"/>
-            <a:ext cx="7058328" cy="4260686"/>
+            <a:off x="265580" y="1714500"/>
+            <a:ext cx="6971243" cy="4428037"/>
           </a:xfrm>
           <a:prstGeom prst="rect">
             <a:avLst/>
@@ -4289,7 +4307,7 @@
               <a:buNone/>
             </a:pPr>
             <a:r>
-              <a:rPr lang="ja-JP" altLang="en-US">
+              <a:rPr lang="ja-JP" altLang="en-US" sz="2000">
                 <a:solidFill>
                   <a:srgbClr val="1F2937"/>
                 </a:solidFill>
@@ -4297,9 +4315,9 @@
                 <a:ea typeface="Noto Sans JP" pitchFamily="34" charset="-122"/>
                 <a:cs typeface="Noto Sans JP" pitchFamily="34" charset="-120"/>
               </a:rPr>
-              <a:t>🎯 目的：紙やメールで来る申請を、</a:t>
-            </a:r>
-            <a:endParaRPr lang="en-US" altLang="ja-JP">
+              <a:t>🎯 目的：申請データを蓄積して、</a:t>
+            </a:r>
+            <a:endParaRPr lang="en-US" altLang="ja-JP" sz="2000">
               <a:solidFill>
                 <a:srgbClr val="1F2937"/>
               </a:solidFill>
@@ -4313,7 +4331,7 @@
               <a:buNone/>
             </a:pPr>
             <a:r>
-              <a:rPr lang="ja-JP" altLang="en-US">
+              <a:rPr lang="ja-JP" altLang="en-US" sz="2000">
                 <a:solidFill>
                   <a:srgbClr val="1F2937"/>
                 </a:solidFill>
@@ -4321,9 +4339,9 @@
                 <a:ea typeface="Noto Sans JP" pitchFamily="34" charset="-122"/>
                 <a:cs typeface="Noto Sans JP" pitchFamily="34" charset="-120"/>
               </a:rPr>
-              <a:t>　自動で受け取れるようにする</a:t>
-            </a:r>
-            <a:endParaRPr lang="en-US" altLang="ja-JP">
+              <a:t>上司も経理もあとから見返せる「台帳」にする</a:t>
+            </a:r>
+            <a:endParaRPr lang="en-US" altLang="ja-JP" sz="2000">
               <a:solidFill>
                 <a:srgbClr val="1F2937"/>
               </a:solidFill>
@@ -4336,7 +4354,7 @@
             <a:pPr marL="0" indent="0" algn="l">
               <a:buNone/>
             </a:pPr>
-            <a:endParaRPr lang="en-US" altLang="ja-JP">
+            <a:endParaRPr lang="en-US" altLang="ja-JP" sz="2000">
               <a:solidFill>
                 <a:srgbClr val="1F2937"/>
               </a:solidFill>
@@ -4350,15 +4368,17 @@
               <a:buNone/>
             </a:pPr>
             <a:r>
-              <a:t>・Forms「新しい応答が送信されるとき」でフロー起動</a:t>
-            </a:r>
-            <a:endParaRPr lang="en-US"/>
-          </a:p>
-          <a:p>
-            <a:pPr marL="0" indent="0" algn="l">
-              <a:buNone/>
-            </a:pPr>
-            <a:endParaRPr lang="en-US" altLang="ja-JP">
+              <a:rPr lang="ja-JP" altLang="en-US" sz="2000">
+                <a:solidFill>
+                  <a:srgbClr val="1F2937"/>
+                </a:solidFill>
+                <a:latin typeface="Noto Sans JP" pitchFamily="34" charset="0"/>
+                <a:ea typeface="Noto Sans JP" pitchFamily="34" charset="-122"/>
+                <a:cs typeface="Noto Sans JP" pitchFamily="34" charset="-120"/>
+              </a:rPr>
+              <a:t>・SharePointサイト &gt; 新規 &gt; リスト &gt; 空のリストを選択</a:t>
+            </a:r>
+            <a:endParaRPr lang="en-US" altLang="ja-JP" sz="2000">
               <a:solidFill>
                 <a:srgbClr val="1F2937"/>
               </a:solidFill>
@@ -4371,17 +4391,7 @@
             <a:pPr marL="0" indent="0" algn="l">
               <a:buNone/>
             </a:pPr>
-            <a:r>
-              <a:rPr sz="1600"/>
-              <a:t>・「応答の詳細を取得」で 名前 / 金額 / 用途 を抜き出す</a:t>
-            </a:r>
-            <a:endParaRPr lang="en-US" sz="1600"/>
-          </a:p>
-          <a:p>
-            <a:pPr marL="0" indent="0" algn="l">
-              <a:buNone/>
-            </a:pPr>
-            <a:endParaRPr lang="ja-JP" altLang="en-US">
+            <a:endParaRPr lang="en-US" altLang="ja-JP" sz="2000">
               <a:solidFill>
                 <a:srgbClr val="1F2937"/>
               </a:solidFill>
@@ -4395,17 +4405,15 @@
               <a:buNone/>
             </a:pPr>
             <a:r>
-              <a:rPr lang="ja-JP" altLang="en-US">
-                <a:solidFill>
-                  <a:srgbClr val="1F2937"/>
-                </a:solidFill>
-                <a:latin typeface="Noto Sans JP" pitchFamily="34" charset="0"/>
-                <a:ea typeface="Noto Sans JP" pitchFamily="34" charset="-122"/>
-                <a:cs typeface="Noto Sans JP" pitchFamily="34" charset="-120"/>
-              </a:rPr>
-              <a:t>・「作成（Compose）」で1行サマリにまとめる</a:t>
-            </a:r>
-            <a:endParaRPr lang="en-US" altLang="ja-JP">
+              <a:t>・リスト名：経費申請</a:t>
+            </a:r>
+            <a:endParaRPr lang="en-US"/>
+          </a:p>
+          <a:p>
+            <a:pPr marL="0" indent="0" algn="l">
+              <a:buNone/>
+            </a:pPr>
+            <a:endParaRPr lang="ja-JP" altLang="en-US" sz="2000">
               <a:solidFill>
                 <a:srgbClr val="1F2937"/>
               </a:solidFill>
@@ -4419,7 +4427,7 @@
               <a:buNone/>
             </a:pPr>
             <a:r>
-              <a:rPr lang="ja-JP" altLang="en-US">
+              <a:rPr lang="ja-JP" altLang="en-US" sz="2000">
                 <a:solidFill>
                   <a:srgbClr val="1F2937"/>
                 </a:solidFill>
@@ -4427,9 +4435,30 @@
                 <a:ea typeface="Noto Sans JP" pitchFamily="34" charset="-122"/>
                 <a:cs typeface="Noto Sans JP" pitchFamily="34" charset="-120"/>
               </a:rPr>
-              <a:t>　（例：山田太郎 様 / 会議費 / ¥3,500）</a:t>
-            </a:r>
-            <a:endParaRPr lang="en-US" altLang="ja-JP">
+              <a:t>・列を3つ追加（Title列は最初からあるのでそのまま使用）</a:t>
+            </a:r>
+          </a:p>
+          <a:p>
+            <a:pPr marL="0" indent="0" algn="l">
+              <a:buNone/>
+            </a:pPr>
+            <a:r>
+              <a:t>　① Title（テキスト・既定）　申請の見出し</a:t>
+            </a:r>
+            <a:endParaRPr lang="en-US"/>
+          </a:p>
+          <a:p>
+            <a:pPr marL="0" indent="0" algn="l">
+              <a:buNone/>
+            </a:pPr>
+            <a:r>
+              <a:rPr lang="ja-JP" altLang="en-US"/>
+              <a:t>　　</a:t>
+            </a:r>
+            <a:r>
+              <a:t>（フローでサマリ文を入れる）</a:t>
+            </a:r>
+            <a:endParaRPr lang="en-US" altLang="ja-JP" sz="2000">
               <a:solidFill>
                 <a:srgbClr val="1F2937"/>
               </a:solidFill>
@@ -4442,7 +4471,18 @@
             <a:pPr marL="0" indent="0" algn="l">
               <a:buNone/>
             </a:pPr>
-            <a:endParaRPr lang="ja-JP" altLang="en-US">
+            <a:r>
+              <a:rPr lang="ja-JP" altLang="en-US" sz="2000">
+                <a:solidFill>
+                  <a:srgbClr val="1F2937"/>
+                </a:solidFill>
+                <a:latin typeface="Noto Sans JP" pitchFamily="34" charset="0"/>
+                <a:ea typeface="Noto Sans JP" pitchFamily="34" charset="-122"/>
+                <a:cs typeface="Noto Sans JP" pitchFamily="34" charset="-120"/>
+              </a:rPr>
+              <a:t>　② Detail（複数行テキスト）　Formsの「詳細」を保存</a:t>
+            </a:r>
+            <a:endParaRPr lang="en-US" altLang="ja-JP" sz="2000">
               <a:solidFill>
                 <a:srgbClr val="1F2937"/>
               </a:solidFill>
@@ -4456,9 +4496,9 @@
               <a:buNone/>
             </a:pPr>
             <a:r>
-              <a:t>　→ あとでSPタイトルや承認カードに使い回せて便利</a:t>
-            </a:r>
-            <a:endParaRPr lang="en-US" altLang="ja-JP">
+              <a:t>　③ Status（選択肢）　「申請中」「承認済」「却下」の3択</a:t>
+            </a:r>
+            <a:endParaRPr lang="ja-JP" altLang="en-US" sz="2000">
               <a:solidFill>
                 <a:srgbClr val="1F2937"/>
               </a:solidFill>
@@ -4471,7 +4511,10 @@
             <a:pPr marL="0" indent="0" algn="l">
               <a:buNone/>
             </a:pPr>
-            <a:endParaRPr lang="en-US" altLang="ja-JP" b="1">
+            <a:r>
+              <a:t>・既定値：Status =「申請中」にしておくと安心</a:t>
+            </a:r>
+            <a:endParaRPr lang="ja-JP" altLang="en-US" sz="2000">
               <a:solidFill>
                 <a:srgbClr val="1F2937"/>
               </a:solidFill>
@@ -4484,7 +4527,7 @@
             <a:pPr marL="0" indent="0" algn="l">
               <a:buNone/>
             </a:pPr>
-            <a:endParaRPr lang="ja-JP" altLang="en-US" b="1">
+            <a:endParaRPr lang="ja-JP" altLang="en-US" sz="2000" b="1" dirty="0">
               <a:solidFill>
                 <a:srgbClr val="1F2937"/>
               </a:solidFill>
@@ -4493,40 +4536,14 @@
               <a:cs typeface="Noto Sans JP" pitchFamily="34" charset="-120"/>
             </a:endParaRPr>
           </a:p>
-          <a:p>
-            <a:pPr marL="0" indent="0" algn="l">
-              <a:buNone/>
-            </a:pPr>
-            <a:endParaRPr lang="ja-JP" altLang="en-US" b="1">
-              <a:solidFill>
-                <a:srgbClr val="1F2937"/>
-              </a:solidFill>
-              <a:latin typeface="Noto Sans JP" pitchFamily="34" charset="0"/>
-              <a:ea typeface="Noto Sans JP" pitchFamily="34" charset="-122"/>
-              <a:cs typeface="Noto Sans JP" pitchFamily="34" charset="-120"/>
-            </a:endParaRPr>
-          </a:p>
-          <a:p>
-            <a:pPr marL="0" indent="0" algn="l">
-              <a:buNone/>
-            </a:pPr>
-            <a:endParaRPr lang="ja-JP" altLang="en-US" b="1" dirty="0">
-              <a:solidFill>
-                <a:srgbClr val="1F2937"/>
-              </a:solidFill>
-              <a:latin typeface="Noto Sans JP" pitchFamily="34" charset="0"/>
-              <a:ea typeface="Noto Sans JP" pitchFamily="34" charset="-122"/>
-              <a:cs typeface="Noto Sans JP" pitchFamily="34" charset="-120"/>
-            </a:endParaRPr>
-          </a:p>
         </p:txBody>
       </p:sp>
       <p:pic>
         <p:nvPicPr>
-          <p:cNvPr id="11" name="図 10" descr="The image depicts a user interface with two sections, each containing a text field for inputting responses, with instructions to retrieve and summarize application details.&#10;&#10;AI 生成コンテンツは誤りを含む可能性があります。">
+          <p:cNvPr id="14" name="図 13" descr="No10 Expense Claim List&#10;&#10;AI 生成コンテンツは誤りを含む可能性があります。">
             <a:extLst>
               <a:ext uri="{FF2B5EF4-FFF2-40B4-BE49-F238E27FC236}">
-                <a16:creationId xmlns:a16="http://schemas.microsoft.com/office/drawing/2014/main" id="{E3F313C9-ADB6-6A37-504D-0DE5F3B6BA73}"/>
+                <a16:creationId xmlns:a16="http://schemas.microsoft.com/office/drawing/2014/main" id="{C2EF7902-2BBE-0FB4-C1D1-D35830F898C7}"/>
               </a:ext>
             </a:extLst>
           </p:cNvPr>
@@ -4543,8 +4560,8 @@
         </p:blipFill>
         <p:spPr>
           <a:xfrm>
-            <a:off x="6959252" y="674831"/>
-            <a:ext cx="3488397" cy="5357469"/>
+            <a:off x="7009653" y="1864303"/>
+            <a:ext cx="4810796" cy="3915321"/>
           </a:xfrm>
           <a:prstGeom prst="rect">
             <a:avLst/>
@@ -4559,36 +4576,6 @@
               </a:srgbClr>
             </a:outerShdw>
           </a:effectLst>
-        </p:spPr>
-      </p:pic>
-      <p:pic>
-        <p:nvPicPr>
-          <p:cNvPr id="14" name="図 13" descr="A child in green clothing is depicted sitting on the floor, relaxing with a laptop open and on, while lying down.&#10;&#10;AI 生成コンテンツは誤りを含む可能性があります。">
-            <a:extLst>
-              <a:ext uri="{FF2B5EF4-FFF2-40B4-BE49-F238E27FC236}">
-                <a16:creationId xmlns:a16="http://schemas.microsoft.com/office/drawing/2014/main" id="{49EE4930-6C21-6EBF-82EA-02FB98532560}"/>
-              </a:ext>
-            </a:extLst>
-          </p:cNvPr>
-          <p:cNvPicPr>
-            <a:picLocks noChangeAspect="1"/>
-          </p:cNvPicPr>
-          <p:nvPr/>
-        </p:nvPicPr>
-        <p:blipFill>
-          <a:blip r:embed="rId3"/>
-          <a:stretch>
-            <a:fillRect/>
-          </a:stretch>
-        </p:blipFill>
-        <p:spPr>
-          <a:xfrm>
-            <a:off x="9869707" y="3353565"/>
-            <a:ext cx="2106190" cy="1441570"/>
-          </a:xfrm>
-          <a:prstGeom prst="rect">
-            <a:avLst/>
-          </a:prstGeom>
         </p:spPr>
       </p:pic>
     </p:spTree>
@@ -4800,7 +4787,7 @@
         <p:spPr>
           <a:xfrm>
             <a:off x="457200" y="533095"/>
-            <a:ext cx="11038114" cy="715061"/>
+            <a:ext cx="7781544" cy="715061"/>
           </a:xfrm>
           <a:prstGeom prst="rect">
             <a:avLst/>
@@ -4816,7 +4803,7 @@
               <a:buNone/>
             </a:pPr>
             <a:r>
-              <a:rPr lang="en-US" sz="3200" b="1" dirty="0">
+              <a:rPr lang="en-US" sz="2400" b="1" dirty="0">
                 <a:solidFill>
                   <a:srgbClr val="1F2937"/>
                 </a:solidFill>
@@ -4824,9 +4811,9 @@
                 <a:ea typeface="Noto Sans JP" pitchFamily="34" charset="-122"/>
                 <a:cs typeface="Noto Sans JP" pitchFamily="34" charset="-120"/>
               </a:rPr>
-              <a:t>フロー解説 ②  登録 → 承認待ち</a:t>
-            </a:r>
-            <a:endParaRPr lang="en-US" sz="3200" dirty="0"/>
+              <a:t>フロー解説 ①  申請を受け取る</a:t>
+            </a:r>
+            <a:endParaRPr lang="en-US" sz="2400" dirty="0"/>
           </a:p>
         </p:txBody>
       </p:sp>
@@ -5316,8 +5303,8 @@
         </p:nvSpPr>
         <p:spPr>
           <a:xfrm>
-            <a:off x="265580" y="2195490"/>
-            <a:ext cx="7380546" cy="3947047"/>
+            <a:off x="126243" y="1705357"/>
+            <a:ext cx="7058328" cy="4260686"/>
           </a:xfrm>
           <a:prstGeom prst="rect">
             <a:avLst/>
@@ -5341,7 +5328,7 @@
                 <a:ea typeface="Noto Sans JP" pitchFamily="34" charset="-122"/>
                 <a:cs typeface="Noto Sans JP" pitchFamily="34" charset="-120"/>
               </a:rPr>
-              <a:t>🎯 目的：申請をデータとして残しつつ、上司の判断を仰ぐ</a:t>
+              <a:t>🎯 目的：紙やメールで来る申請を、</a:t>
             </a:r>
             <a:endParaRPr lang="en-US" altLang="ja-JP">
               <a:solidFill>
@@ -5356,6 +5343,17 @@
             <a:pPr marL="0" indent="0" algn="l">
               <a:buNone/>
             </a:pPr>
+            <a:r>
+              <a:rPr lang="ja-JP" altLang="en-US">
+                <a:solidFill>
+                  <a:srgbClr val="1F2937"/>
+                </a:solidFill>
+                <a:latin typeface="Noto Sans JP" pitchFamily="34" charset="0"/>
+                <a:ea typeface="Noto Sans JP" pitchFamily="34" charset="-122"/>
+                <a:cs typeface="Noto Sans JP" pitchFamily="34" charset="-120"/>
+              </a:rPr>
+              <a:t>　自動で受け取れるようにする</a:t>
+            </a:r>
             <a:endParaRPr lang="en-US" altLang="ja-JP">
               <a:solidFill>
                 <a:srgbClr val="1F2937"/>
@@ -5369,9 +5367,6 @@
             <a:pPr marL="0" indent="0" algn="l">
               <a:buNone/>
             </a:pPr>
-            <a:r>
-              <a:t>・「項目の作成」でSP「経費申請」リストに登録</a:t>
-            </a:r>
             <a:endParaRPr lang="en-US" altLang="ja-JP">
               <a:solidFill>
                 <a:srgbClr val="1F2937"/>
@@ -5386,8 +5381,37 @@
               <a:buNone/>
             </a:pPr>
             <a:r>
-              <a:t>　Title=サマリ / Detail=詳細 / Status=申請中</a:t>
-            </a:r>
+              <a:t>・Forms「新しい応答が送信されるとき」でフロー起動</a:t>
+            </a:r>
+            <a:endParaRPr lang="en-US"/>
+          </a:p>
+          <a:p>
+            <a:pPr marL="0" indent="0" algn="l">
+              <a:buNone/>
+            </a:pPr>
+            <a:endParaRPr lang="en-US" altLang="ja-JP">
+              <a:solidFill>
+                <a:srgbClr val="1F2937"/>
+              </a:solidFill>
+              <a:latin typeface="Noto Sans JP" pitchFamily="34" charset="0"/>
+              <a:ea typeface="Noto Sans JP" pitchFamily="34" charset="-122"/>
+              <a:cs typeface="Noto Sans JP" pitchFamily="34" charset="-120"/>
+            </a:endParaRPr>
+          </a:p>
+          <a:p>
+            <a:pPr marL="0" indent="0" algn="l">
+              <a:buNone/>
+            </a:pPr>
+            <a:r>
+              <a:rPr sz="1600"/>
+              <a:t>・「応答の詳細を取得」で 名前 / 金額 / 用途 を抜き出す</a:t>
+            </a:r>
+            <a:endParaRPr lang="en-US" sz="1600"/>
+          </a:p>
+          <a:p>
+            <a:pPr marL="0" indent="0" algn="l">
+              <a:buNone/>
+            </a:pPr>
             <a:endParaRPr lang="ja-JP" altLang="en-US">
               <a:solidFill>
                 <a:srgbClr val="1F2937"/>
@@ -5410,7 +5434,7 @@
                 <a:ea typeface="Noto Sans JP" pitchFamily="34" charset="-122"/>
                 <a:cs typeface="Noto Sans JP" pitchFamily="34" charset="-120"/>
               </a:rPr>
-              <a:t>　→ 全社の申請が1か所に蓄積される</a:t>
+              <a:t>・「作成（Compose）」で1行サマリにまとめる</a:t>
             </a:r>
             <a:endParaRPr lang="en-US" altLang="ja-JP">
               <a:solidFill>
@@ -5425,6 +5449,30 @@
             <a:pPr marL="0" indent="0" algn="l">
               <a:buNone/>
             </a:pPr>
+            <a:r>
+              <a:rPr lang="ja-JP" altLang="en-US">
+                <a:solidFill>
+                  <a:srgbClr val="1F2937"/>
+                </a:solidFill>
+                <a:latin typeface="Noto Sans JP" pitchFamily="34" charset="0"/>
+                <a:ea typeface="Noto Sans JP" pitchFamily="34" charset="-122"/>
+                <a:cs typeface="Noto Sans JP" pitchFamily="34" charset="-120"/>
+              </a:rPr>
+              <a:t>　（例：山田太郎 様 / 会議費 / ¥3,500）</a:t>
+            </a:r>
+            <a:endParaRPr lang="en-US" altLang="ja-JP">
+              <a:solidFill>
+                <a:srgbClr val="1F2937"/>
+              </a:solidFill>
+              <a:latin typeface="Noto Sans JP" pitchFamily="34" charset="0"/>
+              <a:ea typeface="Noto Sans JP" pitchFamily="34" charset="-122"/>
+              <a:cs typeface="Noto Sans JP" pitchFamily="34" charset="-120"/>
+            </a:endParaRPr>
+          </a:p>
+          <a:p>
+            <a:pPr marL="0" indent="0" algn="l">
+              <a:buNone/>
+            </a:pPr>
             <a:endParaRPr lang="ja-JP" altLang="en-US">
               <a:solidFill>
                 <a:srgbClr val="1F2937"/>
@@ -5439,7 +5487,7 @@
               <a:buNone/>
             </a:pPr>
             <a:r>
-              <a:t>・「開始して承認を待機」で上司にTeams承認カード送信</a:t>
+              <a:t>　→ あとでSPタイトルや承認カードに使い回せて便利</a:t>
             </a:r>
             <a:endParaRPr lang="en-US" altLang="ja-JP">
               <a:solidFill>
@@ -5454,18 +5502,7 @@
             <a:pPr marL="0" indent="0" algn="l">
               <a:buNone/>
             </a:pPr>
-            <a:r>
-              <a:rPr lang="ja-JP" altLang="en-US">
-                <a:solidFill>
-                  <a:srgbClr val="1F2937"/>
-                </a:solidFill>
-                <a:latin typeface="Noto Sans JP" pitchFamily="34" charset="0"/>
-                <a:ea typeface="Noto Sans JP" pitchFamily="34" charset="-122"/>
-                <a:cs typeface="Noto Sans JP" pitchFamily="34" charset="-120"/>
-              </a:rPr>
-              <a:t>　→ フローは上司が押すまでじっと待機</a:t>
-            </a:r>
-            <a:endParaRPr lang="en-US" altLang="ja-JP">
+            <a:endParaRPr lang="en-US" altLang="ja-JP" b="1">
               <a:solidFill>
                 <a:srgbClr val="1F2937"/>
               </a:solidFill>
@@ -5491,6 +5528,19 @@
             <a:pPr marL="0" indent="0" algn="l">
               <a:buNone/>
             </a:pPr>
+            <a:endParaRPr lang="ja-JP" altLang="en-US" b="1">
+              <a:solidFill>
+                <a:srgbClr val="1F2937"/>
+              </a:solidFill>
+              <a:latin typeface="Noto Sans JP" pitchFamily="34" charset="0"/>
+              <a:ea typeface="Noto Sans JP" pitchFamily="34" charset="-122"/>
+              <a:cs typeface="Noto Sans JP" pitchFamily="34" charset="-120"/>
+            </a:endParaRPr>
+          </a:p>
+          <a:p>
+            <a:pPr marL="0" indent="0" algn="l">
+              <a:buNone/>
+            </a:pPr>
             <a:endParaRPr lang="ja-JP" altLang="en-US" b="1" dirty="0">
               <a:solidFill>
                 <a:srgbClr val="1F2937"/>
@@ -5504,10 +5554,10 @@
       </p:sp>
       <p:pic>
         <p:nvPicPr>
-          <p:cNvPr id="11" name="図 10" descr="Submitted&#10;&#10;AI 生成コンテンツは誤りを含む可能性があります。">
+          <p:cNvPr id="11" name="図 10" descr="The image depicts a user interface with two sections, each containing a text field for inputting responses, with instructions to retrieve and summarize application details.&#10;&#10;AI 生成コンテンツは誤りを含む可能性があります。">
             <a:extLst>
               <a:ext uri="{FF2B5EF4-FFF2-40B4-BE49-F238E27FC236}">
-                <a16:creationId xmlns:a16="http://schemas.microsoft.com/office/drawing/2014/main" id="{0DD0D0D2-FD45-AE74-8E14-81FC75DD9F8F}"/>
+                <a16:creationId xmlns:a16="http://schemas.microsoft.com/office/drawing/2014/main" id="{E3F313C9-ADB6-6A37-504D-0DE5F3B6BA73}"/>
               </a:ext>
             </a:extLst>
           </p:cNvPr>
@@ -5524,8 +5574,8 @@
         </p:blipFill>
         <p:spPr>
           <a:xfrm>
-            <a:off x="7007936" y="1794289"/>
-            <a:ext cx="4115374" cy="4210638"/>
+            <a:off x="6959252" y="674831"/>
+            <a:ext cx="3488397" cy="5357469"/>
           </a:xfrm>
           <a:prstGeom prst="rect">
             <a:avLst/>
@@ -5544,10 +5594,10 @@
       </p:pic>
       <p:pic>
         <p:nvPicPr>
-          <p:cNvPr id="14" name="図 13" descr="A hand holding a document with Japanese characters and a form with checkboxes and numbers.&#10;&#10;AI 生成コンテンツは誤りを含む可能性があります。">
+          <p:cNvPr id="14" name="図 13" descr="A child in green clothing is depicted sitting on the floor, relaxing with a laptop open and on, while lying down.&#10;&#10;AI 生成コンテンツは誤りを含む可能性があります。">
             <a:extLst>
               <a:ext uri="{FF2B5EF4-FFF2-40B4-BE49-F238E27FC236}">
-                <a16:creationId xmlns:a16="http://schemas.microsoft.com/office/drawing/2014/main" id="{59479EB1-0E7C-C3B6-9DC4-512C3E02CC01}"/>
+                <a16:creationId xmlns:a16="http://schemas.microsoft.com/office/drawing/2014/main" id="{49EE4930-6C21-6EBF-82EA-02FB98532560}"/>
               </a:ext>
             </a:extLst>
           </p:cNvPr>
@@ -5564,38 +5614,8 @@
         </p:blipFill>
         <p:spPr>
           <a:xfrm>
-            <a:off x="10490911" y="3675016"/>
-            <a:ext cx="1639567" cy="1490184"/>
-          </a:xfrm>
-          <a:prstGeom prst="rect">
-            <a:avLst/>
-          </a:prstGeom>
-        </p:spPr>
-      </p:pic>
-      <p:pic>
-        <p:nvPicPr>
-          <p:cNvPr id="16" name="図 15" descr="The image depicts a child in a blue shirt, sitting at a desk, looking confused and holding a smartphone, with an open email notification and a question mark above his head.&#10;&#10;AI 生成コンテンツは誤りを含む可能性があります。">
-            <a:extLst>
-              <a:ext uri="{FF2B5EF4-FFF2-40B4-BE49-F238E27FC236}">
-                <a16:creationId xmlns:a16="http://schemas.microsoft.com/office/drawing/2014/main" id="{F06833EB-62C0-688B-7E01-15829AD707AB}"/>
-              </a:ext>
-            </a:extLst>
-          </p:cNvPr>
-          <p:cNvPicPr>
-            <a:picLocks noChangeAspect="1"/>
-          </p:cNvPicPr>
-          <p:nvPr/>
-        </p:nvPicPr>
-        <p:blipFill>
-          <a:blip r:embed="rId4"/>
-          <a:stretch>
-            <a:fillRect/>
-          </a:stretch>
-        </p:blipFill>
-        <p:spPr>
-          <a:xfrm>
-            <a:off x="10494656" y="4994690"/>
-            <a:ext cx="1490185" cy="1490185"/>
+            <a:off x="9869707" y="3353565"/>
+            <a:ext cx="2106190" cy="1441570"/>
           </a:xfrm>
           <a:prstGeom prst="rect">
             <a:avLst/>
@@ -5810,8 +5830,8 @@
         </p:nvSpPr>
         <p:spPr>
           <a:xfrm>
-            <a:off x="457199" y="533095"/>
-            <a:ext cx="10837817" cy="715061"/>
+            <a:off x="457200" y="533095"/>
+            <a:ext cx="11038114" cy="715061"/>
           </a:xfrm>
           <a:prstGeom prst="rect">
             <a:avLst/>
@@ -5827,7 +5847,7 @@
               <a:buNone/>
             </a:pPr>
             <a:r>
-              <a:rPr lang="en-US" sz="2800" b="1" dirty="0">
+              <a:rPr lang="en-US" sz="3200" b="1" dirty="0">
                 <a:solidFill>
                   <a:srgbClr val="1F2937"/>
                 </a:solidFill>
@@ -5835,9 +5855,9 @@
                 <a:ea typeface="Noto Sans JP" pitchFamily="34" charset="-122"/>
                 <a:cs typeface="Noto Sans JP" pitchFamily="34" charset="-120"/>
               </a:rPr>
-              <a:t>フロー解説 ③  結果で更新＆通知</a:t>
-            </a:r>
-            <a:endParaRPr lang="en-US" sz="2800" dirty="0"/>
+              <a:t>フロー解説 ②  登録 → 承認待ち</a:t>
+            </a:r>
+            <a:endParaRPr lang="en-US" sz="3200" dirty="0"/>
           </a:p>
         </p:txBody>
       </p:sp>
@@ -5922,8 +5942,8 @@
         </p:nvSpPr>
         <p:spPr>
           <a:xfrm>
-            <a:off x="0" y="1523390"/>
-            <a:ext cx="11975897" cy="4914900"/>
+            <a:off x="305" y="1485900"/>
+            <a:ext cx="12191695" cy="4914900"/>
           </a:xfrm>
           <a:prstGeom prst="rect">
             <a:avLst/>
@@ -6327,6 +6347,1017 @@
         </p:nvSpPr>
         <p:spPr>
           <a:xfrm>
+            <a:off x="265580" y="2195490"/>
+            <a:ext cx="7380546" cy="3947047"/>
+          </a:xfrm>
+          <a:prstGeom prst="rect">
+            <a:avLst/>
+          </a:prstGeom>
+          <a:noFill/>
+          <a:ln/>
+        </p:spPr>
+        <p:txBody>
+          <a:bodyPr wrap="square" lIns="0" tIns="0" rIns="0" bIns="0" rtlCol="0" anchor="ctr"/>
+          <a:lstStyle/>
+          <a:p>
+            <a:pPr marL="0" indent="0" algn="l">
+              <a:buNone/>
+            </a:pPr>
+            <a:r>
+              <a:rPr lang="ja-JP" altLang="en-US">
+                <a:solidFill>
+                  <a:srgbClr val="1F2937"/>
+                </a:solidFill>
+                <a:latin typeface="Noto Sans JP" pitchFamily="34" charset="0"/>
+                <a:ea typeface="Noto Sans JP" pitchFamily="34" charset="-122"/>
+                <a:cs typeface="Noto Sans JP" pitchFamily="34" charset="-120"/>
+              </a:rPr>
+              <a:t>🎯 目的：申請をデータとして残しつつ、上司の判断を仰ぐ</a:t>
+            </a:r>
+            <a:endParaRPr lang="en-US" altLang="ja-JP">
+              <a:solidFill>
+                <a:srgbClr val="1F2937"/>
+              </a:solidFill>
+              <a:latin typeface="Noto Sans JP" pitchFamily="34" charset="0"/>
+              <a:ea typeface="Noto Sans JP" pitchFamily="34" charset="-122"/>
+              <a:cs typeface="Noto Sans JP" pitchFamily="34" charset="-120"/>
+            </a:endParaRPr>
+          </a:p>
+          <a:p>
+            <a:pPr marL="0" indent="0" algn="l">
+              <a:buNone/>
+            </a:pPr>
+            <a:endParaRPr lang="en-US" altLang="ja-JP">
+              <a:solidFill>
+                <a:srgbClr val="1F2937"/>
+              </a:solidFill>
+              <a:latin typeface="Noto Sans JP" pitchFamily="34" charset="0"/>
+              <a:ea typeface="Noto Sans JP" pitchFamily="34" charset="-122"/>
+              <a:cs typeface="Noto Sans JP" pitchFamily="34" charset="-120"/>
+            </a:endParaRPr>
+          </a:p>
+          <a:p>
+            <a:pPr marL="0" indent="0" algn="l">
+              <a:buNone/>
+            </a:pPr>
+            <a:r>
+              <a:t>・「項目の作成」でSP「経費申請」リストに登録</a:t>
+            </a:r>
+            <a:endParaRPr lang="en-US" altLang="ja-JP">
+              <a:solidFill>
+                <a:srgbClr val="1F2937"/>
+              </a:solidFill>
+              <a:latin typeface="Noto Sans JP" pitchFamily="34" charset="0"/>
+              <a:ea typeface="Noto Sans JP" pitchFamily="34" charset="-122"/>
+              <a:cs typeface="Noto Sans JP" pitchFamily="34" charset="-120"/>
+            </a:endParaRPr>
+          </a:p>
+          <a:p>
+            <a:pPr marL="0" indent="0" algn="l">
+              <a:buNone/>
+            </a:pPr>
+            <a:r>
+              <a:t>　Title=サマリ / Detail=詳細 / Status=申請中</a:t>
+            </a:r>
+            <a:endParaRPr lang="ja-JP" altLang="en-US">
+              <a:solidFill>
+                <a:srgbClr val="1F2937"/>
+              </a:solidFill>
+              <a:latin typeface="Noto Sans JP" pitchFamily="34" charset="0"/>
+              <a:ea typeface="Noto Sans JP" pitchFamily="34" charset="-122"/>
+              <a:cs typeface="Noto Sans JP" pitchFamily="34" charset="-120"/>
+            </a:endParaRPr>
+          </a:p>
+          <a:p>
+            <a:pPr marL="0" indent="0" algn="l">
+              <a:buNone/>
+            </a:pPr>
+            <a:r>
+              <a:rPr lang="ja-JP" altLang="en-US">
+                <a:solidFill>
+                  <a:srgbClr val="1F2937"/>
+                </a:solidFill>
+                <a:latin typeface="Noto Sans JP" pitchFamily="34" charset="0"/>
+                <a:ea typeface="Noto Sans JP" pitchFamily="34" charset="-122"/>
+                <a:cs typeface="Noto Sans JP" pitchFamily="34" charset="-120"/>
+              </a:rPr>
+              <a:t>　→ 全社の申請が1か所に蓄積される</a:t>
+            </a:r>
+            <a:endParaRPr lang="en-US" altLang="ja-JP">
+              <a:solidFill>
+                <a:srgbClr val="1F2937"/>
+              </a:solidFill>
+              <a:latin typeface="Noto Sans JP" pitchFamily="34" charset="0"/>
+              <a:ea typeface="Noto Sans JP" pitchFamily="34" charset="-122"/>
+              <a:cs typeface="Noto Sans JP" pitchFamily="34" charset="-120"/>
+            </a:endParaRPr>
+          </a:p>
+          <a:p>
+            <a:pPr marL="0" indent="0" algn="l">
+              <a:buNone/>
+            </a:pPr>
+            <a:endParaRPr lang="ja-JP" altLang="en-US">
+              <a:solidFill>
+                <a:srgbClr val="1F2937"/>
+              </a:solidFill>
+              <a:latin typeface="Noto Sans JP" pitchFamily="34" charset="0"/>
+              <a:ea typeface="Noto Sans JP" pitchFamily="34" charset="-122"/>
+              <a:cs typeface="Noto Sans JP" pitchFamily="34" charset="-120"/>
+            </a:endParaRPr>
+          </a:p>
+          <a:p>
+            <a:pPr marL="0" indent="0" algn="l">
+              <a:buNone/>
+            </a:pPr>
+            <a:r>
+              <a:t>・「開始して承認を待機」で上司にTeams承認カード送信</a:t>
+            </a:r>
+            <a:endParaRPr lang="en-US" altLang="ja-JP">
+              <a:solidFill>
+                <a:srgbClr val="1F2937"/>
+              </a:solidFill>
+              <a:latin typeface="Noto Sans JP" pitchFamily="34" charset="0"/>
+              <a:ea typeface="Noto Sans JP" pitchFamily="34" charset="-122"/>
+              <a:cs typeface="Noto Sans JP" pitchFamily="34" charset="-120"/>
+            </a:endParaRPr>
+          </a:p>
+          <a:p>
+            <a:pPr marL="0" indent="0" algn="l">
+              <a:buNone/>
+            </a:pPr>
+            <a:r>
+              <a:rPr lang="ja-JP" altLang="en-US">
+                <a:solidFill>
+                  <a:srgbClr val="1F2937"/>
+                </a:solidFill>
+                <a:latin typeface="Noto Sans JP" pitchFamily="34" charset="0"/>
+                <a:ea typeface="Noto Sans JP" pitchFamily="34" charset="-122"/>
+                <a:cs typeface="Noto Sans JP" pitchFamily="34" charset="-120"/>
+              </a:rPr>
+              <a:t>　→ フローは上司が押すまでじっと待機</a:t>
+            </a:r>
+            <a:endParaRPr lang="en-US" altLang="ja-JP">
+              <a:solidFill>
+                <a:srgbClr val="1F2937"/>
+              </a:solidFill>
+              <a:latin typeface="Noto Sans JP" pitchFamily="34" charset="0"/>
+              <a:ea typeface="Noto Sans JP" pitchFamily="34" charset="-122"/>
+              <a:cs typeface="Noto Sans JP" pitchFamily="34" charset="-120"/>
+            </a:endParaRPr>
+          </a:p>
+          <a:p>
+            <a:pPr marL="0" indent="0" algn="l">
+              <a:buNone/>
+            </a:pPr>
+            <a:endParaRPr lang="ja-JP" altLang="en-US" b="1">
+              <a:solidFill>
+                <a:srgbClr val="1F2937"/>
+              </a:solidFill>
+              <a:latin typeface="Noto Sans JP" pitchFamily="34" charset="0"/>
+              <a:ea typeface="Noto Sans JP" pitchFamily="34" charset="-122"/>
+              <a:cs typeface="Noto Sans JP" pitchFamily="34" charset="-120"/>
+            </a:endParaRPr>
+          </a:p>
+          <a:p>
+            <a:pPr marL="0" indent="0" algn="l">
+              <a:buNone/>
+            </a:pPr>
+            <a:endParaRPr lang="ja-JP" altLang="en-US" b="1" dirty="0">
+              <a:solidFill>
+                <a:srgbClr val="1F2937"/>
+              </a:solidFill>
+              <a:latin typeface="Noto Sans JP" pitchFamily="34" charset="0"/>
+              <a:ea typeface="Noto Sans JP" pitchFamily="34" charset="-122"/>
+              <a:cs typeface="Noto Sans JP" pitchFamily="34" charset="-120"/>
+            </a:endParaRPr>
+          </a:p>
+        </p:txBody>
+      </p:sp>
+      <p:pic>
+        <p:nvPicPr>
+          <p:cNvPr id="11" name="図 10" descr="Submitted&#10;&#10;AI 生成コンテンツは誤りを含む可能性があります。">
+            <a:extLst>
+              <a:ext uri="{FF2B5EF4-FFF2-40B4-BE49-F238E27FC236}">
+                <a16:creationId xmlns:a16="http://schemas.microsoft.com/office/drawing/2014/main" id="{0DD0D0D2-FD45-AE74-8E14-81FC75DD9F8F}"/>
+              </a:ext>
+            </a:extLst>
+          </p:cNvPr>
+          <p:cNvPicPr>
+            <a:picLocks noChangeAspect="1"/>
+          </p:cNvPicPr>
+          <p:nvPr/>
+        </p:nvPicPr>
+        <p:blipFill>
+          <a:blip r:embed="rId2"/>
+          <a:stretch>
+            <a:fillRect/>
+          </a:stretch>
+        </p:blipFill>
+        <p:spPr>
+          <a:xfrm>
+            <a:off x="7007936" y="1794289"/>
+            <a:ext cx="4115374" cy="4210638"/>
+          </a:xfrm>
+          <a:prstGeom prst="rect">
+            <a:avLst/>
+          </a:prstGeom>
+          <a:ln>
+            <a:noFill/>
+          </a:ln>
+          <a:effectLst>
+            <a:outerShdw blurRad="190500" algn="tl" rotWithShape="0">
+              <a:srgbClr val="000000">
+                <a:alpha val="70000"/>
+              </a:srgbClr>
+            </a:outerShdw>
+          </a:effectLst>
+        </p:spPr>
+      </p:pic>
+      <p:pic>
+        <p:nvPicPr>
+          <p:cNvPr id="14" name="図 13" descr="A hand holding a document with Japanese characters and a form with checkboxes and numbers.&#10;&#10;AI 生成コンテンツは誤りを含む可能性があります。">
+            <a:extLst>
+              <a:ext uri="{FF2B5EF4-FFF2-40B4-BE49-F238E27FC236}">
+                <a16:creationId xmlns:a16="http://schemas.microsoft.com/office/drawing/2014/main" id="{59479EB1-0E7C-C3B6-9DC4-512C3E02CC01}"/>
+              </a:ext>
+            </a:extLst>
+          </p:cNvPr>
+          <p:cNvPicPr>
+            <a:picLocks noChangeAspect="1"/>
+          </p:cNvPicPr>
+          <p:nvPr/>
+        </p:nvPicPr>
+        <p:blipFill>
+          <a:blip r:embed="rId3"/>
+          <a:stretch>
+            <a:fillRect/>
+          </a:stretch>
+        </p:blipFill>
+        <p:spPr>
+          <a:xfrm>
+            <a:off x="10490911" y="3675016"/>
+            <a:ext cx="1639567" cy="1490184"/>
+          </a:xfrm>
+          <a:prstGeom prst="rect">
+            <a:avLst/>
+          </a:prstGeom>
+        </p:spPr>
+      </p:pic>
+      <p:pic>
+        <p:nvPicPr>
+          <p:cNvPr id="16" name="図 15" descr="The image depicts a child in a blue shirt, sitting at a desk, looking confused and holding a smartphone, with an open email notification and a question mark above his head.&#10;&#10;AI 生成コンテンツは誤りを含む可能性があります。">
+            <a:extLst>
+              <a:ext uri="{FF2B5EF4-FFF2-40B4-BE49-F238E27FC236}">
+                <a16:creationId xmlns:a16="http://schemas.microsoft.com/office/drawing/2014/main" id="{F06833EB-62C0-688B-7E01-15829AD707AB}"/>
+              </a:ext>
+            </a:extLst>
+          </p:cNvPr>
+          <p:cNvPicPr>
+            <a:picLocks noChangeAspect="1"/>
+          </p:cNvPicPr>
+          <p:nvPr/>
+        </p:nvPicPr>
+        <p:blipFill>
+          <a:blip r:embed="rId4"/>
+          <a:stretch>
+            <a:fillRect/>
+          </a:stretch>
+        </p:blipFill>
+        <p:spPr>
+          <a:xfrm>
+            <a:off x="10494656" y="4994690"/>
+            <a:ext cx="1490185" cy="1490185"/>
+          </a:xfrm>
+          <a:prstGeom prst="rect">
+            <a:avLst/>
+          </a:prstGeom>
+        </p:spPr>
+      </p:pic>
+    </p:spTree>
+  </p:cSld>
+  <p:clrMapOvr>
+    <a:masterClrMapping/>
+  </p:clrMapOvr>
+</p:sld>
+</file>
+
+<file path=ppt/slides/slide14.xml><?xml version="1.0" encoding="utf-8"?>
+<p:sld xmlns:a="http://schemas.openxmlformats.org/drawingml/2006/main" xmlns:r="http://schemas.openxmlformats.org/officeDocument/2006/relationships" xmlns:p="http://schemas.openxmlformats.org/presentationml/2006/main">
+  <p:cSld>
+    <p:spTree>
+      <p:nvGrpSpPr>
+        <p:cNvPr id="1" name=""/>
+        <p:cNvGrpSpPr/>
+        <p:nvPr/>
+      </p:nvGrpSpPr>
+      <p:grpSpPr>
+        <a:xfrm>
+          <a:off x="0" y="0"/>
+          <a:ext cx="0" cy="0"/>
+          <a:chOff x="0" y="0"/>
+          <a:chExt cx="0" cy="0"/>
+        </a:xfrm>
+      </p:grpSpPr>
+      <p:sp>
+        <p:nvSpPr>
+          <p:cNvPr id="2" name="Shape 0"/>
+          <p:cNvSpPr/>
+          <p:nvPr/>
+        </p:nvSpPr>
+        <p:spPr>
+          <a:xfrm>
+            <a:off x="0" y="0"/>
+            <a:ext cx="12191695" cy="6858000"/>
+          </a:xfrm>
+          <a:prstGeom prst="rect">
+            <a:avLst/>
+          </a:prstGeom>
+          <a:solidFill>
+            <a:srgbClr val="F3F4F6"/>
+          </a:solidFill>
+          <a:ln w="12700">
+            <a:solidFill>
+              <a:srgbClr val="FFFFFF">
+                <a:alpha val="0"/>
+              </a:srgbClr>
+            </a:solidFill>
+            <a:prstDash val="solid"/>
+          </a:ln>
+        </p:spPr>
+        <p:txBody>
+          <a:bodyPr/>
+          <a:lstStyle/>
+          <a:p>
+            <a:endParaRPr lang="ja-JP" altLang="en-US"/>
+          </a:p>
+        </p:txBody>
+      </p:sp>
+      <p:sp>
+        <p:nvSpPr>
+          <p:cNvPr id="3" name="Shape 1"/>
+          <p:cNvSpPr/>
+          <p:nvPr/>
+        </p:nvSpPr>
+        <p:spPr>
+          <a:xfrm>
+            <a:off x="0" y="0"/>
+            <a:ext cx="12191695" cy="6858000"/>
+          </a:xfrm>
+          <a:prstGeom prst="rect">
+            <a:avLst/>
+          </a:prstGeom>
+          <a:solidFill>
+            <a:srgbClr val="FFFFFF"/>
+          </a:solidFill>
+          <a:ln w="12700">
+            <a:solidFill>
+              <a:srgbClr val="FFFFFF">
+                <a:alpha val="0"/>
+              </a:srgbClr>
+            </a:solidFill>
+            <a:prstDash val="solid"/>
+          </a:ln>
+          <a:effectLst>
+            <a:outerShdw blurRad="63500" dist="38100" dir="16200000" algn="bl" rotWithShape="0">
+              <a:srgbClr val="000000">
+                <a:alpha val="10000"/>
+              </a:srgbClr>
+            </a:outerShdw>
+          </a:effectLst>
+        </p:spPr>
+        <p:txBody>
+          <a:bodyPr/>
+          <a:lstStyle/>
+          <a:p>
+            <a:endParaRPr lang="ja-JP" altLang="en-US"/>
+          </a:p>
+        </p:txBody>
+      </p:sp>
+      <p:sp>
+        <p:nvSpPr>
+          <p:cNvPr id="4" name="Shape 2"/>
+          <p:cNvSpPr/>
+          <p:nvPr/>
+        </p:nvSpPr>
+        <p:spPr>
+          <a:xfrm>
+            <a:off x="0" y="0"/>
+            <a:ext cx="12191695" cy="1485900"/>
+          </a:xfrm>
+          <a:prstGeom prst="rect">
+            <a:avLst/>
+          </a:prstGeom>
+          <a:solidFill>
+            <a:srgbClr val="FFFFFF"/>
+          </a:solidFill>
+          <a:ln/>
+        </p:spPr>
+        <p:txBody>
+          <a:bodyPr/>
+          <a:lstStyle/>
+          <a:p>
+            <a:endParaRPr lang="ja-JP" altLang="en-US"/>
+          </a:p>
+        </p:txBody>
+      </p:sp>
+      <p:sp>
+        <p:nvSpPr>
+          <p:cNvPr id="5" name="Shape 3"/>
+          <p:cNvSpPr/>
+          <p:nvPr/>
+        </p:nvSpPr>
+        <p:spPr>
+          <a:xfrm>
+            <a:off x="0" y="1476756"/>
+            <a:ext cx="12191695" cy="9144"/>
+          </a:xfrm>
+          <a:prstGeom prst="rect">
+            <a:avLst/>
+          </a:prstGeom>
+          <a:solidFill>
+            <a:srgbClr val="F3F4F6"/>
+          </a:solidFill>
+          <a:ln w="12700">
+            <a:solidFill>
+              <a:srgbClr val="F3F4F6">
+                <a:alpha val="0"/>
+              </a:srgbClr>
+            </a:solidFill>
+            <a:prstDash val="solid"/>
+          </a:ln>
+        </p:spPr>
+        <p:txBody>
+          <a:bodyPr/>
+          <a:lstStyle/>
+          <a:p>
+            <a:endParaRPr lang="ja-JP" altLang="en-US"/>
+          </a:p>
+        </p:txBody>
+      </p:sp>
+      <p:sp>
+        <p:nvSpPr>
+          <p:cNvPr id="6" name="Text 4"/>
+          <p:cNvSpPr txBox="1"/>
+          <p:nvPr/>
+        </p:nvSpPr>
+        <p:spPr>
+          <a:xfrm>
+            <a:off x="457200" y="228600"/>
+            <a:ext cx="5600700" cy="267005"/>
+          </a:xfrm>
+          <a:prstGeom prst="rect">
+            <a:avLst/>
+          </a:prstGeom>
+          <a:noFill/>
+          <a:ln/>
+        </p:spPr>
+        <p:txBody>
+          <a:bodyPr wrap="square" lIns="0" tIns="0" rIns="0" bIns="0" rtlCol="0" anchor="ctr"/>
+          <a:lstStyle/>
+          <a:p>
+            <a:pPr marL="0" indent="0" algn="l">
+              <a:buNone/>
+            </a:pPr>
+            <a:r>
+              <a:rPr lang="en-US" sz="1600" b="1" kern="0" spc="150" dirty="0">
+                <a:solidFill>
+                  <a:srgbClr val="6B7280"/>
+                </a:solidFill>
+                <a:latin typeface="Noto Sans JP" pitchFamily="34" charset="0"/>
+                <a:ea typeface="Noto Sans JP" pitchFamily="34" charset="-122"/>
+                <a:cs typeface="Noto Sans JP" pitchFamily="34" charset="-120"/>
+              </a:rPr>
+              <a:t>PA45｜第10回</a:t>
+            </a:r>
+            <a:endParaRPr lang="en-US" sz="1500" dirty="0"/>
+          </a:p>
+        </p:txBody>
+      </p:sp>
+      <p:sp>
+        <p:nvSpPr>
+          <p:cNvPr id="7" name="Text 5"/>
+          <p:cNvSpPr txBox="1"/>
+          <p:nvPr/>
+        </p:nvSpPr>
+        <p:spPr>
+          <a:xfrm>
+            <a:off x="457199" y="533095"/>
+            <a:ext cx="10837817" cy="715061"/>
+          </a:xfrm>
+          <a:prstGeom prst="rect">
+            <a:avLst/>
+          </a:prstGeom>
+          <a:noFill/>
+          <a:ln/>
+        </p:spPr>
+        <p:txBody>
+          <a:bodyPr wrap="square" lIns="0" tIns="0" rIns="0" bIns="0" rtlCol="0" anchor="ctr"/>
+          <a:lstStyle/>
+          <a:p>
+            <a:pPr marL="0" indent="0" algn="l">
+              <a:buNone/>
+            </a:pPr>
+            <a:r>
+              <a:rPr lang="en-US" sz="2800" b="1" dirty="0">
+                <a:solidFill>
+                  <a:srgbClr val="1F2937"/>
+                </a:solidFill>
+                <a:latin typeface="Noto Sans JP" pitchFamily="34" charset="0"/>
+                <a:ea typeface="Noto Sans JP" pitchFamily="34" charset="-122"/>
+                <a:cs typeface="Noto Sans JP" pitchFamily="34" charset="-120"/>
+              </a:rPr>
+              <a:t>フロー解説 ③  結果で更新＆通知</a:t>
+            </a:r>
+            <a:endParaRPr lang="en-US" sz="2800" dirty="0"/>
+          </a:p>
+        </p:txBody>
+      </p:sp>
+      <p:sp>
+        <p:nvSpPr>
+          <p:cNvPr id="8" name="Shape 6"/>
+          <p:cNvSpPr/>
+          <p:nvPr/>
+        </p:nvSpPr>
+        <p:spPr>
+          <a:xfrm>
+            <a:off x="10858500" y="828446"/>
+            <a:ext cx="114300" cy="114300"/>
+          </a:xfrm>
+          <a:prstGeom prst="ellipse">
+            <a:avLst/>
+          </a:prstGeom>
+          <a:solidFill>
+            <a:srgbClr val="0078D4"/>
+          </a:solidFill>
+          <a:ln w="12700">
+            <a:solidFill>
+              <a:srgbClr val="FFFFFF">
+                <a:alpha val="0"/>
+              </a:srgbClr>
+            </a:solidFill>
+            <a:prstDash val="solid"/>
+          </a:ln>
+        </p:spPr>
+        <p:txBody>
+          <a:bodyPr/>
+          <a:lstStyle/>
+          <a:p>
+            <a:endParaRPr lang="ja-JP" altLang="en-US"/>
+          </a:p>
+        </p:txBody>
+      </p:sp>
+      <p:sp>
+        <p:nvSpPr>
+          <p:cNvPr id="9" name="Text 7"/>
+          <p:cNvSpPr txBox="1"/>
+          <p:nvPr/>
+        </p:nvSpPr>
+        <p:spPr>
+          <a:xfrm>
+            <a:off x="11048695" y="752551"/>
+            <a:ext cx="771754" cy="267005"/>
+          </a:xfrm>
+          <a:prstGeom prst="rect">
+            <a:avLst/>
+          </a:prstGeom>
+          <a:noFill/>
+          <a:ln/>
+        </p:spPr>
+        <p:txBody>
+          <a:bodyPr wrap="square" lIns="0" tIns="0" rIns="0" bIns="0" rtlCol="0" anchor="ctr"/>
+          <a:lstStyle/>
+          <a:p>
+            <a:pPr marL="0" indent="0" algn="l">
+              <a:buNone/>
+            </a:pPr>
+            <a:r>
+              <a:rPr lang="en-US" sz="1600" dirty="0">
+                <a:solidFill>
+                  <a:srgbClr val="9CA3AF"/>
+                </a:solidFill>
+                <a:latin typeface="ui-monospace" pitchFamily="34" charset="0"/>
+                <a:ea typeface="ui-monospace" pitchFamily="34" charset="-122"/>
+                <a:cs typeface="ui-monospace" pitchFamily="34" charset="-120"/>
+              </a:rPr>
+              <a:t>Concept</a:t>
+            </a:r>
+            <a:endParaRPr lang="en-US" sz="1500" dirty="0"/>
+          </a:p>
+        </p:txBody>
+      </p:sp>
+      <p:sp>
+        <p:nvSpPr>
+          <p:cNvPr id="13" name="Shape 9"/>
+          <p:cNvSpPr/>
+          <p:nvPr/>
+        </p:nvSpPr>
+        <p:spPr>
+          <a:xfrm>
+            <a:off x="0" y="1523390"/>
+            <a:ext cx="11975897" cy="4914900"/>
+          </a:xfrm>
+          <a:prstGeom prst="rect">
+            <a:avLst/>
+          </a:prstGeom>
+          <a:solidFill>
+            <a:srgbClr val="F9FAFB"/>
+          </a:solidFill>
+          <a:ln w="12700">
+            <a:solidFill>
+              <a:srgbClr val="FFFFFF">
+                <a:alpha val="0"/>
+              </a:srgbClr>
+            </a:solidFill>
+            <a:prstDash val="solid"/>
+          </a:ln>
+        </p:spPr>
+        <p:txBody>
+          <a:bodyPr/>
+          <a:lstStyle/>
+          <a:p>
+            <a:endParaRPr lang="ja-JP" altLang="en-US"/>
+          </a:p>
+        </p:txBody>
+      </p:sp>
+      <p:pic>
+        <p:nvPicPr>
+          <p:cNvPr id="23" name="Image 8" descr="preencoded.png"/>
+          <p:cNvPicPr>
+            <a:picLocks noChangeAspect="1"/>
+          </p:cNvPicPr>
+          <p:nvPr/>
+        </p:nvPicPr>
+        <p:blipFill>
+          <a:blip/>
+          <a:srcRect t="-401" b="-401"/>
+          <a:stretch/>
+        </p:blipFill>
+        <p:spPr>
+          <a:xfrm>
+            <a:off x="0" y="6801307"/>
+            <a:ext cx="12191695" cy="57607"/>
+          </a:xfrm>
+          <a:prstGeom prst="rect">
+            <a:avLst/>
+          </a:prstGeom>
+        </p:spPr>
+      </p:pic>
+      <p:sp>
+        <p:nvSpPr>
+          <p:cNvPr id="39" name="Shape 22"/>
+          <p:cNvSpPr/>
+          <p:nvPr/>
+        </p:nvSpPr>
+        <p:spPr>
+          <a:xfrm>
+            <a:off x="0" y="6400800"/>
+            <a:ext cx="12191695" cy="457200"/>
+          </a:xfrm>
+          <a:prstGeom prst="rect">
+            <a:avLst/>
+          </a:prstGeom>
+          <a:solidFill>
+            <a:srgbClr val="FFFFFF"/>
+          </a:solidFill>
+          <a:ln/>
+        </p:spPr>
+        <p:txBody>
+          <a:bodyPr/>
+          <a:lstStyle/>
+          <a:p>
+            <a:endParaRPr lang="ja-JP" altLang="en-US"/>
+          </a:p>
+        </p:txBody>
+      </p:sp>
+      <p:sp>
+        <p:nvSpPr>
+          <p:cNvPr id="40" name="Shape 23"/>
+          <p:cNvSpPr/>
+          <p:nvPr/>
+        </p:nvSpPr>
+        <p:spPr>
+          <a:xfrm>
+            <a:off x="0" y="6400800"/>
+            <a:ext cx="12191695" cy="9144"/>
+          </a:xfrm>
+          <a:prstGeom prst="rect">
+            <a:avLst/>
+          </a:prstGeom>
+          <a:solidFill>
+            <a:srgbClr val="E5E7EB"/>
+          </a:solidFill>
+          <a:ln w="12700">
+            <a:solidFill>
+              <a:srgbClr val="E5E7EB">
+                <a:alpha val="0"/>
+              </a:srgbClr>
+            </a:solidFill>
+            <a:prstDash val="solid"/>
+          </a:ln>
+        </p:spPr>
+        <p:txBody>
+          <a:bodyPr/>
+          <a:lstStyle/>
+          <a:p>
+            <a:endParaRPr lang="ja-JP" altLang="en-US"/>
+          </a:p>
+        </p:txBody>
+      </p:sp>
+      <p:sp>
+        <p:nvSpPr>
+          <p:cNvPr id="41" name="Text 24"/>
+          <p:cNvSpPr txBox="1"/>
+          <p:nvPr/>
+        </p:nvSpPr>
+        <p:spPr>
+          <a:xfrm>
+            <a:off x="457200" y="6519672"/>
+            <a:ext cx="2573122" cy="228600"/>
+          </a:xfrm>
+          <a:prstGeom prst="rect">
+            <a:avLst/>
+          </a:prstGeom>
+          <a:noFill/>
+          <a:ln/>
+        </p:spPr>
+        <p:txBody>
+          <a:bodyPr wrap="square" lIns="0" tIns="0" rIns="0" bIns="0" rtlCol="0" anchor="ctr"/>
+          <a:lstStyle/>
+          <a:p>
+            <a:pPr marL="0" indent="0" algn="l">
+              <a:buNone/>
+            </a:pPr>
+            <a:r>
+              <a:rPr lang="en-US" sz="1600" dirty="0">
+                <a:solidFill>
+                  <a:srgbClr val="9CA3AF"/>
+                </a:solidFill>
+                <a:latin typeface="Noto Sans JP" pitchFamily="34" charset="0"/>
+                <a:ea typeface="Noto Sans JP" pitchFamily="34" charset="-122"/>
+                <a:cs typeface="Noto Sans JP" pitchFamily="34" charset="-120"/>
+              </a:rPr>
+              <a:t>Power Automate for Beginners</a:t>
+            </a:r>
+            <a:endParaRPr lang="en-US" sz="1200" dirty="0"/>
+          </a:p>
+        </p:txBody>
+      </p:sp>
+      <p:sp>
+        <p:nvSpPr>
+          <p:cNvPr id="42" name="Text 25"/>
+          <p:cNvSpPr txBox="1"/>
+          <p:nvPr/>
+        </p:nvSpPr>
+        <p:spPr>
+          <a:xfrm>
+            <a:off x="10490911" y="6519672"/>
+            <a:ext cx="1484986" cy="228600"/>
+          </a:xfrm>
+          <a:prstGeom prst="rect">
+            <a:avLst/>
+          </a:prstGeom>
+          <a:noFill/>
+          <a:ln/>
+        </p:spPr>
+        <p:txBody>
+          <a:bodyPr wrap="square" lIns="0" tIns="0" rIns="0" bIns="0" rtlCol="0" anchor="ctr"/>
+          <a:lstStyle/>
+          <a:p>
+            <a:pPr marL="0" indent="0" algn="l">
+              <a:buNone/>
+            </a:pPr>
+            <a:r>
+              <a:rPr lang="en-US" sz="1600" dirty="0">
+                <a:solidFill>
+                  <a:srgbClr val="9CA3AF"/>
+                </a:solidFill>
+                <a:latin typeface="Noto Sans JP" pitchFamily="34" charset="0"/>
+                <a:ea typeface="Noto Sans JP" pitchFamily="34" charset="-122"/>
+                <a:cs typeface="Noto Sans JP" pitchFamily="34" charset="-120"/>
+              </a:rPr>
+              <a:t>Copyright © PA45</a:t>
+            </a:r>
+            <a:endParaRPr lang="en-US" sz="1200" dirty="0"/>
+          </a:p>
+        </p:txBody>
+      </p:sp>
+      <p:grpSp>
+        <p:nvGrpSpPr>
+          <p:cNvPr id="47" name="グループ化 46">
+            <a:extLst>
+              <a:ext uri="{FF2B5EF4-FFF2-40B4-BE49-F238E27FC236}">
+                <a16:creationId xmlns:a16="http://schemas.microsoft.com/office/drawing/2014/main" id="{722FBEAE-8CB7-7493-F595-CD1F2E21BD05}"/>
+              </a:ext>
+            </a:extLst>
+          </p:cNvPr>
+          <p:cNvGrpSpPr/>
+          <p:nvPr/>
+        </p:nvGrpSpPr>
+        <p:grpSpPr>
+          <a:xfrm>
+            <a:off x="4603551" y="6322778"/>
+            <a:ext cx="7350682" cy="405017"/>
+            <a:chOff x="5861349" y="604238"/>
+            <a:chExt cx="6035909" cy="405017"/>
+          </a:xfrm>
+        </p:grpSpPr>
+        <p:sp>
+          <p:nvSpPr>
+            <p:cNvPr id="48" name="Shape 31">
+              <a:extLst>
+                <a:ext uri="{FF2B5EF4-FFF2-40B4-BE49-F238E27FC236}">
+                  <a16:creationId xmlns:a16="http://schemas.microsoft.com/office/drawing/2014/main" id="{DD44BB3C-F859-7A5E-7E34-CC1C35ECEA4D}"/>
+                </a:ext>
+              </a:extLst>
+            </p:cNvPr>
+            <p:cNvSpPr/>
+            <p:nvPr/>
+          </p:nvSpPr>
+          <p:spPr>
+            <a:xfrm>
+              <a:off x="6034969" y="604238"/>
+              <a:ext cx="5854549" cy="386057"/>
+            </a:xfrm>
+            <a:prstGeom prst="roundRect">
+              <a:avLst>
+                <a:gd name="adj" fmla="val 342465"/>
+              </a:avLst>
+            </a:prstGeom>
+            <a:solidFill>
+              <a:srgbClr val="EFF6FF"/>
+            </a:solidFill>
+            <a:ln w="12700">
+              <a:solidFill>
+                <a:srgbClr val="FFFFFF">
+                  <a:alpha val="0"/>
+                </a:srgbClr>
+              </a:solidFill>
+              <a:prstDash val="solid"/>
+            </a:ln>
+          </p:spPr>
+          <p:txBody>
+            <a:bodyPr/>
+            <a:lstStyle/>
+            <a:p>
+              <a:endParaRPr lang="ja-JP" altLang="en-US"/>
+            </a:p>
+          </p:txBody>
+        </p:sp>
+        <p:sp>
+          <p:nvSpPr>
+            <p:cNvPr id="49" name="Text 21">
+              <a:extLst>
+                <a:ext uri="{FF2B5EF4-FFF2-40B4-BE49-F238E27FC236}">
+                  <a16:creationId xmlns:a16="http://schemas.microsoft.com/office/drawing/2014/main" id="{A7F44BB1-1667-BB85-557B-D7C1AAD8A0FA}"/>
+                </a:ext>
+              </a:extLst>
+            </p:cNvPr>
+            <p:cNvSpPr txBox="1"/>
+            <p:nvPr/>
+          </p:nvSpPr>
+          <p:spPr>
+            <a:xfrm>
+              <a:off x="6287649" y="612651"/>
+              <a:ext cx="5609609" cy="396593"/>
+            </a:xfrm>
+            <a:prstGeom prst="rect">
+              <a:avLst/>
+            </a:prstGeom>
+            <a:noFill/>
+            <a:ln/>
+          </p:spPr>
+          <p:txBody>
+            <a:bodyPr wrap="square" lIns="0" tIns="0" rIns="0" bIns="0" rtlCol="0" anchor="ctr"/>
+            <a:lstStyle/>
+            <a:p>
+              <a:pPr marL="0" indent="0" algn="l">
+                <a:buNone/>
+              </a:pPr>
+              <a:r>
+                <a:rPr lang="en-US" sz="1400" b="1" dirty="0">
+                  <a:solidFill>
+                    <a:srgbClr val="2563EB"/>
+                  </a:solidFill>
+                  <a:latin typeface="Noto Sans JP" pitchFamily="34" charset="0"/>
+                  <a:ea typeface="Noto Sans JP" pitchFamily="34" charset="-122"/>
+                  <a:cs typeface="Noto Sans JP" pitchFamily="34" charset="-120"/>
+                </a:rPr>
+                <a:t>学んだこと・気づいたことを #</a:t>
+              </a:r>
+              <a:r>
+                <a:rPr lang="en-US" sz="1400" b="1">
+                  <a:solidFill>
+                    <a:srgbClr val="2563EB"/>
+                  </a:solidFill>
+                  <a:latin typeface="Noto Sans JP" pitchFamily="34" charset="0"/>
+                  <a:ea typeface="Noto Sans JP" pitchFamily="34" charset="-122"/>
+                  <a:cs typeface="Noto Sans JP" pitchFamily="34" charset="-120"/>
+                </a:rPr>
+                <a:t>PA45 で</a:t>
+              </a:r>
+              <a:r>
+                <a:rPr lang="ja-JP" altLang="en-US" sz="1400" b="1">
+                  <a:solidFill>
+                    <a:srgbClr val="2563EB"/>
+                  </a:solidFill>
+                  <a:latin typeface="Noto Sans JP" pitchFamily="34" charset="0"/>
+                  <a:ea typeface="Noto Sans JP" pitchFamily="34" charset="-122"/>
+                  <a:cs typeface="Noto Sans JP" pitchFamily="34" charset="-120"/>
+                </a:rPr>
+                <a:t>リアルタイムに</a:t>
+              </a:r>
+              <a:r>
+                <a:rPr lang="en-US" sz="1400" b="1">
+                  <a:solidFill>
+                    <a:srgbClr val="2563EB"/>
+                  </a:solidFill>
+                  <a:latin typeface="Noto Sans JP" pitchFamily="34" charset="0"/>
+                  <a:ea typeface="Noto Sans JP" pitchFamily="34" charset="-122"/>
+                  <a:cs typeface="Noto Sans JP" pitchFamily="34" charset="-120"/>
+                </a:rPr>
+                <a:t>投稿しよう！</a:t>
+              </a:r>
+              <a:r>
+                <a:rPr lang="ja-JP" altLang="en-US" sz="1400" b="1">
+                  <a:solidFill>
+                    <a:srgbClr val="2563EB"/>
+                  </a:solidFill>
+                  <a:latin typeface="Noto Sans JP" pitchFamily="34" charset="0"/>
+                  <a:ea typeface="Noto Sans JP" pitchFamily="34" charset="-122"/>
+                  <a:cs typeface="Noto Sans JP" pitchFamily="34" charset="-120"/>
+                </a:rPr>
+                <a:t>スクショ</a:t>
+              </a:r>
+              <a:r>
+                <a:rPr lang="en-US" altLang="ja-JP" sz="1400" b="1">
+                  <a:solidFill>
+                    <a:srgbClr val="2563EB"/>
+                  </a:solidFill>
+                  <a:latin typeface="Noto Sans JP" pitchFamily="34" charset="0"/>
+                  <a:ea typeface="Noto Sans JP" pitchFamily="34" charset="-122"/>
+                  <a:cs typeface="Noto Sans JP" pitchFamily="34" charset="-120"/>
+                </a:rPr>
+                <a:t>OK</a:t>
+              </a:r>
+              <a:r>
+                <a:rPr lang="ja-JP" altLang="en-US" sz="1400" b="1">
+                  <a:solidFill>
+                    <a:srgbClr val="2563EB"/>
+                  </a:solidFill>
+                  <a:latin typeface="Noto Sans JP" pitchFamily="34" charset="0"/>
+                  <a:ea typeface="Noto Sans JP" pitchFamily="34" charset="-122"/>
+                  <a:cs typeface="Noto Sans JP" pitchFamily="34" charset="-120"/>
+                </a:rPr>
+                <a:t>！</a:t>
+              </a:r>
+              <a:endParaRPr lang="en-US" sz="1400" dirty="0"/>
+            </a:p>
+          </p:txBody>
+        </p:sp>
+        <p:pic>
+          <p:nvPicPr>
+            <p:cNvPr id="50" name="Image 2" descr="preencoded.png">
+              <a:extLst>
+                <a:ext uri="{FF2B5EF4-FFF2-40B4-BE49-F238E27FC236}">
+                  <a16:creationId xmlns:a16="http://schemas.microsoft.com/office/drawing/2014/main" id="{003A3C3D-15E3-1F1A-D918-AB2472E8059D}"/>
+                </a:ext>
+              </a:extLst>
+            </p:cNvPr>
+            <p:cNvPicPr>
+              <a:picLocks noChangeAspect="1"/>
+            </p:cNvPicPr>
+            <p:nvPr/>
+          </p:nvPicPr>
+          <p:blipFill>
+            <a:blip/>
+            <a:srcRect/>
+            <a:stretch/>
+          </p:blipFill>
+          <p:spPr>
+            <a:xfrm>
+              <a:off x="5861349" y="619679"/>
+              <a:ext cx="263236" cy="389576"/>
+            </a:xfrm>
+            <a:prstGeom prst="rect">
+              <a:avLst/>
+            </a:prstGeom>
+          </p:spPr>
+        </p:pic>
+      </p:grpSp>
+      <p:sp>
+        <p:nvSpPr>
+          <p:cNvPr id="51" name="Text 5">
+            <a:extLst>
+              <a:ext uri="{FF2B5EF4-FFF2-40B4-BE49-F238E27FC236}">
+                <a16:creationId xmlns:a16="http://schemas.microsoft.com/office/drawing/2014/main" id="{F34FF253-528E-97DF-BF89-4A55B2E7EBC4}"/>
+              </a:ext>
+            </a:extLst>
+          </p:cNvPr>
+          <p:cNvSpPr txBox="1"/>
+          <p:nvPr/>
+        </p:nvSpPr>
+        <p:spPr>
+          <a:xfrm>
             <a:off x="94417" y="2164046"/>
             <a:ext cx="6915983" cy="3947047"/>
           </a:xfrm>
@@ -6653,7 +7684,7 @@
 </p:sld>
 </file>
 
-<file path=ppt/slides/slide14.xml><?xml version="1.0" encoding="utf-8"?>
+<file path=ppt/slides/slide15.xml><?xml version="1.0" encoding="utf-8"?>
 <p:sld xmlns:a="http://schemas.openxmlformats.org/drawingml/2006/main" xmlns:r="http://schemas.openxmlformats.org/officeDocument/2006/relationships" xmlns:p="http://schemas.openxmlformats.org/presentationml/2006/main">
   <p:cSld>
     <p:spTree>
@@ -7345,7 +8376,7 @@
 </p:sld>
 </file>
 
-<file path=ppt/slides/slide15.xml><?xml version="1.0" encoding="utf-8"?>
+<file path=ppt/slides/slide16.xml><?xml version="1.0" encoding="utf-8"?>
 <p:sld xmlns:a="http://schemas.openxmlformats.org/drawingml/2006/main" xmlns:r="http://schemas.openxmlformats.org/officeDocument/2006/relationships" xmlns:p="http://schemas.openxmlformats.org/presentationml/2006/main">
   <p:cSld>
     <p:spTree>
@@ -8157,7 +9188,7 @@
 </p:sld>
 </file>
 
-<file path=ppt/slides/slide16.xml><?xml version="1.0" encoding="utf-8"?>
+<file path=ppt/slides/slide17.xml><?xml version="1.0" encoding="utf-8"?>
 <p:sld xmlns:a="http://schemas.openxmlformats.org/drawingml/2006/main" xmlns:r="http://schemas.openxmlformats.org/officeDocument/2006/relationships" xmlns:p="http://schemas.openxmlformats.org/presentationml/2006/main">
   <p:cSld name="Slide 13">
     <p:spTree>
@@ -10069,7 +11100,7 @@
 </p:sld>
 </file>
 
-<file path=ppt/slides/slide17.xml><?xml version="1.0" encoding="utf-8"?>
+<file path=ppt/slides/slide18.xml><?xml version="1.0" encoding="utf-8"?>
 <p:sld xmlns:a="http://schemas.openxmlformats.org/drawingml/2006/main" xmlns:r="http://schemas.openxmlformats.org/officeDocument/2006/relationships" xmlns:p="http://schemas.openxmlformats.org/presentationml/2006/main">
   <p:cSld>
     <p:spTree>
@@ -12107,7 +13138,7 @@
         <p:spPr>
           <a:xfrm>
             <a:off x="684391" y="1363842"/>
-            <a:ext cx="11000000" cy="700000"/>
+            <a:ext cx="11269842" cy="700000"/>
           </a:xfrm>
           <a:prstGeom prst="rect">
             <a:avLst/>
@@ -12131,7 +13162,7 @@
                 <a:ea typeface="Noto Sans JP" pitchFamily="34" charset="-122"/>
                 <a:cs typeface="Noto Sans JP" pitchFamily="34" charset="-120"/>
               </a:rPr>
-              <a:t>PA45　　【Forms × SharePoint × 承認 × Teams】</a:t>
+              <a:t>PA45【Forms × SharePoint × 承認 × Teams】</a:t>
             </a:r>
             <a:endParaRPr lang="en-US" sz="3200" dirty="0"/>
           </a:p>
@@ -12146,7 +13177,7 @@
         <p:spPr>
           <a:xfrm>
             <a:off x="684391" y="2865204"/>
-            <a:ext cx="12536294" cy="715061"/>
+            <a:ext cx="12536294" cy="1515680"/>
           </a:xfrm>
           <a:prstGeom prst="rect">
             <a:avLst/>
@@ -12162,7 +13193,7 @@
               <a:buNone/>
             </a:pPr>
             <a:r>
-              <a:rPr lang="en-US" sz="4500" b="1" dirty="0">
+              <a:rPr lang="en-US" sz="3200" b="1" dirty="0">
                 <a:solidFill>
                   <a:srgbClr val="1F2937"/>
                 </a:solidFill>
@@ -12178,7 +13209,7 @@
               <a:buNone/>
             </a:pPr>
             <a:r>
-              <a:rPr lang="en-US" sz="4500" b="1">
+              <a:rPr lang="en-US" sz="3200" b="1">
                 <a:solidFill>
                   <a:srgbClr val="1F2937"/>
                 </a:solidFill>
@@ -12194,7 +13225,7 @@
               <a:buNone/>
             </a:pPr>
             <a:r>
-              <a:rPr lang="en-US" sz="4500" b="1">
+              <a:rPr lang="en-US" sz="3200" b="1">
                 <a:solidFill>
                   <a:srgbClr val="1F2937"/>
                 </a:solidFill>
@@ -12204,7 +13235,7 @@
               </a:rPr>
               <a:t>経費申請の自動化を体験しよう</a:t>
             </a:r>
-            <a:endParaRPr lang="en-US" sz="4500" dirty="0"/>
+            <a:endParaRPr lang="en-US" sz="3200" dirty="0"/>
           </a:p>
         </p:txBody>
       </p:sp>
@@ -20556,7 +21587,7 @@
                 <a:ea typeface="Noto Sans JP" pitchFamily="34" charset="-122"/>
                 <a:cs typeface="Noto Sans JP" pitchFamily="34" charset="-120"/>
               </a:rPr>
-              <a:t>テーマ解説</a:t>
+              <a:t>テーマ解説 (1/2)：申請を受け取って整える</a:t>
             </a:r>
             <a:r>
               <a:rPr lang="en-US" sz="2700" b="1" dirty="0">
@@ -20567,7 +21598,7 @@
                 <a:ea typeface="Noto Sans JP" pitchFamily="34" charset="-122"/>
                 <a:cs typeface="Noto Sans JP" pitchFamily="34" charset="-120"/>
               </a:rPr>
-              <a:t>（仕組みを理解しよう）</a:t>
+              <a:t/>
             </a:r>
             <a:endParaRPr lang="en-US" sz="4500" dirty="0"/>
           </a:p>
@@ -21084,7 +22115,7 @@
                 <a:ea typeface="Noto Sans JP" pitchFamily="34" charset="-122"/>
                 <a:cs typeface="Noto Sans JP" pitchFamily="34" charset="-120"/>
               </a:rPr>
-              <a:t>①Forms「新しい応答が送信されるとき」をトリガーにフローを起動し、</a:t>
+              <a:t>①Forms「新しい応答が送信されるとき」をトリガーに起動。</a:t>
             </a:r>
             <a:endParaRPr lang="en-US" altLang="ja-JP" sz="2000" b="1">
               <a:solidFill>
@@ -21108,7 +22139,7 @@
                 <a:ea typeface="Noto Sans JP" pitchFamily="34" charset="-122"/>
                 <a:cs typeface="Noto Sans JP" pitchFamily="34" charset="-120"/>
               </a:rPr>
-              <a:t>応答の詳細を取得して、</a:t>
+              <a:t/>
             </a:r>
             <a:endParaRPr lang="en-US" altLang="ja-JP" sz="2000" b="1">
               <a:solidFill>
@@ -21124,15 +22155,7 @@
               <a:buNone/>
             </a:pPr>
             <a:r>
-              <a:rPr lang="ja-JP" altLang="en-US" sz="2000" b="1">
-                <a:solidFill>
-                  <a:srgbClr val="1F2937"/>
-                </a:solidFill>
-                <a:latin typeface="Noto Sans JP" pitchFamily="34" charset="0"/>
-                <a:ea typeface="Noto Sans JP" pitchFamily="34" charset="-122"/>
-                <a:cs typeface="Noto Sans JP" pitchFamily="34" charset="-120"/>
-              </a:rPr>
-              <a:t>②SharePoint「項目の作成」で経費申請リストに新規アイテムを登録する。</a:t>
+              <a:t>②「応答の詳細を取得する」で、申請内容（名前・金額・用途・詳細）をひとつずつ取り出す。</a:t>
             </a:r>
             <a:endParaRPr lang="en-US" altLang="ja-JP" sz="2000" b="1">
               <a:solidFill>
@@ -21147,6 +22170,33 @@
             <a:pPr marL="0" indent="0" algn="l">
               <a:buNone/>
             </a:pPr>
+            <a:r>
+              <a:rPr lang="ja-JP" altLang="en-US" sz="2000" b="1">
+                <a:solidFill>
+                  <a:srgbClr val="1F2937"/>
+                </a:solidFill>
+                <a:latin typeface="Noto Sans JP" pitchFamily="34" charset="0"/>
+                <a:ea typeface="Noto Sans JP" pitchFamily="34" charset="-122"/>
+                <a:cs typeface="Noto Sans JP" pitchFamily="34" charset="-120"/>
+              </a:rPr>
+              <a:t/>
+            </a:r>
+            <a:endParaRPr lang="en-US" altLang="ja-JP" sz="2000" b="1">
+              <a:solidFill>
+                <a:srgbClr val="1F2937"/>
+              </a:solidFill>
+              <a:latin typeface="Noto Sans JP" pitchFamily="34" charset="0"/>
+              <a:ea typeface="Noto Sans JP" pitchFamily="34" charset="-122"/>
+              <a:cs typeface="Noto Sans JP" pitchFamily="34" charset="-120"/>
+            </a:endParaRPr>
+          </a:p>
+          <a:p>
+            <a:pPr marL="0" indent="0" algn="l">
+              <a:buNone/>
+            </a:pPr>
+            <a:r>
+              <a:t>③「作成（Compose）」で、金額・用途・詳細をひとまとめの文字列に整形し、</a:t>
+            </a:r>
             <a:endParaRPr lang="ja-JP" altLang="en-US" sz="2000" b="1">
               <a:solidFill>
                 <a:srgbClr val="1F2937"/>
@@ -21169,7 +22219,7 @@
                 <a:ea typeface="Noto Sans JP" pitchFamily="34" charset="-122"/>
                 <a:cs typeface="Noto Sans JP" pitchFamily="34" charset="-120"/>
               </a:rPr>
-              <a:t>③「開始して承認を待機」で承認カードを送り、結果（outcome）を待つ。</a:t>
+              <a:t>   後段のSharePoint Title や承認カードで使い回せるようにする。</a:t>
             </a:r>
           </a:p>
           <a:p>
@@ -21198,7 +22248,7 @@
                 <a:ea typeface="Noto Sans JP" pitchFamily="34" charset="-122"/>
                 <a:cs typeface="Noto Sans JP" pitchFamily="34" charset="-120"/>
               </a:rPr>
-              <a:t>④条件分岐で Approve/Reject を判定し、Status更新＋Teams通知まで自動化するフロー。</a:t>
+              <a:t/>
             </a:r>
             <a:endParaRPr lang="en-US" altLang="ja-JP" sz="2000" b="1">
               <a:solidFill>
@@ -21252,51 +22302,7 @@
       </p:sp>
       <p:pic>
         <p:nvPicPr>
-          <p:cNvPr id="11" name="図 10" descr="The image shows a user interface with a form containing a file input, a checkbox for a property condition, and buttons for posting messages in chat or channel.&#10;&#10;AI 生成コンテンツは誤りを含む可能性があります。">
-            <a:extLst>
-              <a:ext uri="{FF2B5EF4-FFF2-40B4-BE49-F238E27FC236}">
-                <a16:creationId xmlns:a16="http://schemas.microsoft.com/office/drawing/2014/main" id="{A17FFD3D-1303-2BC7-3253-E2DBE5E19F07}"/>
-              </a:ext>
-            </a:extLst>
-          </p:cNvPr>
-          <p:cNvPicPr>
-            <a:picLocks noChangeAspect="1"/>
-          </p:cNvPicPr>
-          <p:nvPr/>
-        </p:nvPicPr>
-        <p:blipFill>
-          <a:blip r:embed="rId2"/>
-          <a:stretch>
-            <a:fillRect/>
-          </a:stretch>
-        </p:blipFill>
-        <p:spPr>
-          <a:xfrm>
-            <a:off x="6575704" y="1709443"/>
-            <a:ext cx="4904373" cy="4568713"/>
-          </a:xfrm>
-          <a:prstGeom prst="rect">
-            <a:avLst/>
-          </a:prstGeom>
-          <a:ln>
-            <a:solidFill>
-              <a:schemeClr val="tx1">
-                <a:lumMod val="65000"/>
-                <a:lumOff val="35000"/>
-              </a:schemeClr>
-            </a:solidFill>
-          </a:ln>
-        </p:spPr>
-      </p:pic>
-      <p:pic>
-        <p:nvPicPr>
-          <p:cNvPr id="12" name="図 11" descr="A cartoon child with a blue shirt is pointing towards an illustration of an open eye with a light bulb.&#10;&#10;AI 生成コンテンツは誤りを含む可能性があります。">
-            <a:extLst>
-              <a:ext uri="{FF2B5EF4-FFF2-40B4-BE49-F238E27FC236}">
-                <a16:creationId xmlns:a16="http://schemas.microsoft.com/office/drawing/2014/main" id="{DCFEA6E0-2BC7-E886-FA98-B0724535F1F3}"/>
-              </a:ext>
-            </a:extLst>
-          </p:cNvPr>
+          <p:cNvPr id="52" name="Picture 51" descr="vol10-flow-1of2.png"/>
           <p:cNvPicPr>
             <a:picLocks noChangeAspect="1"/>
           </p:cNvPicPr>
@@ -21310,8 +22316,8 @@
         </p:blipFill>
         <p:spPr>
           <a:xfrm>
-            <a:off x="9809006" y="4595962"/>
-            <a:ext cx="1363810" cy="1613976"/>
+            <a:off x="8700000" y="2000000"/>
+            <a:ext cx="2700000" cy="4400000"/>
           </a:xfrm>
           <a:prstGeom prst="rect">
             <a:avLst/>
@@ -21327,7 +22333,7 @@
 </file>
 
 <file path=ppt/slides/slide9.xml><?xml version="1.0" encoding="utf-8"?>
-<p:sld xmlns:a="http://schemas.openxmlformats.org/drawingml/2006/main" xmlns:r="http://schemas.openxmlformats.org/officeDocument/2006/relationships" xmlns:p="http://schemas.openxmlformats.org/presentationml/2006/main">
+<p:sld xmlns:a="http://schemas.openxmlformats.org/drawingml/2006/main" xmlns:p="http://schemas.openxmlformats.org/presentationml/2006/main" xmlns:r="http://schemas.openxmlformats.org/officeDocument/2006/relationships">
   <p:cSld>
     <p:spTree>
       <p:nvGrpSpPr>
@@ -21335,14 +22341,7 @@
         <p:cNvGrpSpPr/>
         <p:nvPr/>
       </p:nvGrpSpPr>
-      <p:grpSpPr>
-        <a:xfrm>
-          <a:off x="0" y="0"/>
-          <a:ext cx="0" cy="0"/>
-          <a:chOff x="0" y="0"/>
-          <a:chExt cx="0" cy="0"/>
-        </a:xfrm>
-      </p:grpSpPr>
+      <p:grpSpPr/>
       <p:sp>
         <p:nvSpPr>
           <p:cNvPr id="2" name="Shape 0"/>
@@ -21426,7 +22425,7 @@
         </p:nvSpPr>
         <p:spPr>
           <a:xfrm>
-            <a:off x="305" y="-9144"/>
+            <a:off x="0" y="0"/>
             <a:ext cx="12191695" cy="1485900"/>
           </a:xfrm>
           <a:prstGeom prst="rect">
@@ -21526,8 +22525,8 @@
         </p:nvSpPr>
         <p:spPr>
           <a:xfrm>
-            <a:off x="322110" y="628650"/>
-            <a:ext cx="9601200" cy="715061"/>
+            <a:off x="457200" y="533095"/>
+            <a:ext cx="7781544" cy="715061"/>
           </a:xfrm>
           <a:prstGeom prst="rect">
             <a:avLst/>
@@ -21543,7 +22542,7 @@
               <a:buNone/>
             </a:pPr>
             <a:r>
-              <a:rPr lang="en-US" sz="3600" b="1" dirty="0">
+              <a:rPr lang="en-US" sz="4500" b="1" dirty="0">
                 <a:solidFill>
                   <a:srgbClr val="1F2937"/>
                 </a:solidFill>
@@ -21551,9 +22550,20 @@
                 <a:ea typeface="Noto Sans JP" pitchFamily="34" charset="-122"/>
                 <a:cs typeface="Noto Sans JP" pitchFamily="34" charset="-120"/>
               </a:rPr>
-              <a:t>事前準備 ①  Formsの設問を作る</a:t>
-            </a:r>
-            <a:endParaRPr lang="en-US" sz="3600" dirty="0"/>
+              <a:t>テーマ解説 (2/2)：登録→承認→結果通知</a:t>
+            </a:r>
+            <a:r>
+              <a:rPr lang="en-US" sz="2700" b="1" dirty="0">
+                <a:solidFill>
+                  <a:srgbClr val="6B7280"/>
+                </a:solidFill>
+                <a:latin typeface="Noto Sans JP" pitchFamily="34" charset="0"/>
+                <a:ea typeface="Noto Sans JP" pitchFamily="34" charset="-122"/>
+                <a:cs typeface="Noto Sans JP" pitchFamily="34" charset="-120"/>
+              </a:rPr>
+              <a:t/>
+            </a:r>
+            <a:endParaRPr lang="en-US" sz="4500" dirty="0"/>
           </a:p>
         </p:txBody>
       </p:sp>
@@ -22043,8 +23053,8 @@
         </p:nvSpPr>
         <p:spPr>
           <a:xfrm>
-            <a:off x="204620" y="1781251"/>
-            <a:ext cx="6544523" cy="3947047"/>
+            <a:off x="265580" y="2195490"/>
+            <a:ext cx="5598507" cy="3947047"/>
           </a:xfrm>
           <a:prstGeom prst="rect">
             <a:avLst/>
@@ -22060,7 +23070,7 @@
               <a:buNone/>
             </a:pPr>
             <a:r>
-              <a:rPr lang="ja-JP" altLang="en-US" sz="2000">
+              <a:rPr lang="ja-JP" altLang="en-US" sz="2000" b="1">
                 <a:solidFill>
                   <a:srgbClr val="1F2937"/>
                 </a:solidFill>
@@ -22068,9 +23078,9 @@
                 <a:ea typeface="Noto Sans JP" pitchFamily="34" charset="-122"/>
                 <a:cs typeface="Noto Sans JP" pitchFamily="34" charset="-120"/>
               </a:rPr>
-              <a:t>🎯 目的：申請者がスマホからも入力できる</a:t>
-            </a:r>
-            <a:endParaRPr lang="en-US" altLang="ja-JP" sz="2000">
+              <a:t>④「項目の作成」でSharePoint「経費申請」リストに登録（Status=申請中）。</a:t>
+            </a:r>
+            <a:endParaRPr lang="en-US" altLang="ja-JP" sz="2000" b="1">
               <a:solidFill>
                 <a:srgbClr val="1F2937"/>
               </a:solidFill>
@@ -22083,7 +23093,18 @@
             <a:pPr marL="0" indent="0" algn="l">
               <a:buNone/>
             </a:pPr>
-            <a:endParaRPr lang="en-US" altLang="ja-JP" sz="2000">
+            <a:r>
+              <a:rPr lang="ja-JP" altLang="en-US" sz="2000" b="1">
+                <a:solidFill>
+                  <a:srgbClr val="1F2937"/>
+                </a:solidFill>
+                <a:latin typeface="Noto Sans JP" pitchFamily="34" charset="0"/>
+                <a:ea typeface="Noto Sans JP" pitchFamily="34" charset="-122"/>
+                <a:cs typeface="Noto Sans JP" pitchFamily="34" charset="-120"/>
+              </a:rPr>
+              <a:t/>
+            </a:r>
+            <a:endParaRPr lang="en-US" altLang="ja-JP" sz="2000" b="1">
               <a:solidFill>
                 <a:srgbClr val="1F2937"/>
               </a:solidFill>
@@ -22097,29 +23118,9 @@
               <a:buNone/>
             </a:pPr>
             <a:r>
-              <a:rPr lang="ja-JP" altLang="en-US" sz="2000">
-                <a:solidFill>
-                  <a:srgbClr val="1F2937"/>
-                </a:solidFill>
-                <a:latin typeface="Noto Sans JP" pitchFamily="34" charset="0"/>
-                <a:ea typeface="Noto Sans JP" pitchFamily="34" charset="-122"/>
-                <a:cs typeface="Noto Sans JP" pitchFamily="34" charset="-120"/>
-                <a:hlinkClick r:id="rId2"/>
-              </a:rPr>
-              <a:t>「経費申請フォーム」</a:t>
-            </a:r>
-            <a:r>
-              <a:rPr lang="ja-JP" altLang="en-US" sz="2000">
-                <a:solidFill>
-                  <a:srgbClr val="1F2937"/>
-                </a:solidFill>
-                <a:latin typeface="Noto Sans JP" pitchFamily="34" charset="0"/>
-                <a:ea typeface="Noto Sans JP" pitchFamily="34" charset="-122"/>
-                <a:cs typeface="Noto Sans JP" pitchFamily="34" charset="-120"/>
-              </a:rPr>
-              <a:t>を用意する</a:t>
-            </a:r>
-            <a:endParaRPr lang="en-US" altLang="ja-JP" sz="2000">
+              <a:t>⑤「開始して承認を待機」で上司にTeams承認カードを送信し、結果を待つ。</a:t>
+            </a:r>
+            <a:endParaRPr lang="en-US" altLang="ja-JP" sz="2000" b="1">
               <a:solidFill>
                 <a:srgbClr val="1F2937"/>
               </a:solidFill>
@@ -22132,7 +23133,18 @@
             <a:pPr marL="0" indent="0" algn="l">
               <a:buNone/>
             </a:pPr>
-            <a:endParaRPr lang="en-US" altLang="ja-JP" sz="2000">
+            <a:r>
+              <a:rPr lang="ja-JP" altLang="en-US" sz="2000" b="1">
+                <a:solidFill>
+                  <a:srgbClr val="1F2937"/>
+                </a:solidFill>
+                <a:latin typeface="Noto Sans JP" pitchFamily="34" charset="0"/>
+                <a:ea typeface="Noto Sans JP" pitchFamily="34" charset="-122"/>
+                <a:cs typeface="Noto Sans JP" pitchFamily="34" charset="-120"/>
+              </a:rPr>
+              <a:t/>
+            </a:r>
+            <a:endParaRPr lang="en-US" altLang="ja-JP" sz="2000" b="1">
               <a:solidFill>
                 <a:srgbClr val="1F2937"/>
               </a:solidFill>
@@ -22146,17 +23158,9 @@
               <a:buNone/>
             </a:pPr>
             <a:r>
-              <a:rPr lang="ja-JP" altLang="en-US" sz="2000">
-                <a:solidFill>
-                  <a:srgbClr val="1F2937"/>
-                </a:solidFill>
-                <a:latin typeface="Noto Sans JP" pitchFamily="34" charset="0"/>
-                <a:ea typeface="Noto Sans JP" pitchFamily="34" charset="-122"/>
-                <a:cs typeface="Noto Sans JP" pitchFamily="34" charset="-120"/>
-              </a:rPr>
-              <a:t>・新しいFormsを作成（タイトル：経費申請）</a:t>
-            </a:r>
-            <a:endParaRPr lang="en-US" altLang="ja-JP" sz="2000">
+              <a:t>⑥「条件」で承認結果（outcome）が Approve かを判定。</a:t>
+            </a:r>
+            <a:endParaRPr lang="ja-JP" altLang="en-US" sz="2000" b="1">
               <a:solidFill>
                 <a:srgbClr val="1F2937"/>
               </a:solidFill>
@@ -22170,9 +23174,25 @@
               <a:buNone/>
             </a:pPr>
             <a:r>
-              <a:t>・設問は次の4つだけでOK</a:t>
-            </a:r>
-            <a:endParaRPr lang="ja-JP" altLang="en-US" sz="2000">
+              <a:rPr lang="ja-JP" altLang="en-US" sz="2000" b="1">
+                <a:solidFill>
+                  <a:srgbClr val="1F2937"/>
+                </a:solidFill>
+                <a:latin typeface="Noto Sans JP" pitchFamily="34" charset="0"/>
+                <a:ea typeface="Noto Sans JP" pitchFamily="34" charset="-122"/>
+                <a:cs typeface="Noto Sans JP" pitchFamily="34" charset="-120"/>
+              </a:rPr>
+              <a:t>   - True（承認）：項目をStatus=承認済に更新 → Teamsで通知</a:t>
+            </a:r>
+          </a:p>
+          <a:p>
+            <a:pPr marL="0" indent="0" algn="l">
+              <a:buNone/>
+            </a:pPr>
+            <a:r>
+              <a:t>   - False（却下）：項目をStatus=却下に更新 → Teamsで通知</a:t>
+            </a:r>
+            <a:endParaRPr lang="en-US" altLang="ja-JP" sz="2000" b="1">
               <a:solidFill>
                 <a:srgbClr val="1F2937"/>
               </a:solidFill>
@@ -22186,7 +23206,7 @@
               <a:buNone/>
             </a:pPr>
             <a:r>
-              <a:rPr lang="ja-JP" altLang="en-US" sz="2000">
+              <a:rPr lang="ja-JP" altLang="en-US" sz="2000" b="1">
                 <a:solidFill>
                   <a:srgbClr val="1F2937"/>
                 </a:solidFill>
@@ -22194,17 +23214,9 @@
                 <a:ea typeface="Noto Sans JP" pitchFamily="34" charset="-122"/>
                 <a:cs typeface="Noto Sans JP" pitchFamily="34" charset="-120"/>
               </a:rPr>
-              <a:t>　① お名前（テキスト・短答／必須）</a:t>
-            </a:r>
-          </a:p>
-          <a:p>
-            <a:pPr marL="0" indent="0" algn="l">
-              <a:buNone/>
-            </a:pPr>
-            <a:r>
-              <a:t>　② 金額（数値・必須／オプションで「0以上の数値」制限）</a:t>
-            </a:r>
-            <a:endParaRPr lang="en-US" altLang="ja-JP" sz="2000">
+              <a:t/>
+            </a:r>
+            <a:endParaRPr lang="en-US" altLang="ja-JP" sz="2000" b="1">
               <a:solidFill>
                 <a:srgbClr val="1F2937"/>
               </a:solidFill>
@@ -22217,18 +23229,7 @@
             <a:pPr marL="0" indent="0" algn="l">
               <a:buNone/>
             </a:pPr>
-            <a:r>
-              <a:rPr lang="ja-JP" altLang="en-US" sz="2000">
-                <a:solidFill>
-                  <a:srgbClr val="1F2937"/>
-                </a:solidFill>
-                <a:latin typeface="Noto Sans JP" pitchFamily="34" charset="0"/>
-                <a:ea typeface="Noto Sans JP" pitchFamily="34" charset="-122"/>
-                <a:cs typeface="Noto Sans JP" pitchFamily="34" charset="-120"/>
-              </a:rPr>
-              <a:t>　③ 用途（テキスト・短答／必須）　</a:t>
-            </a:r>
-            <a:endParaRPr lang="en-US" altLang="ja-JP" sz="2000">
+            <a:endParaRPr lang="ja-JP" altLang="en-US" sz="2000" b="1">
               <a:solidFill>
                 <a:srgbClr val="1F2937"/>
               </a:solidFill>
@@ -22241,18 +23242,7 @@
             <a:pPr marL="0" indent="0" algn="l">
               <a:buNone/>
             </a:pPr>
-            <a:r>
-              <a:rPr lang="ja-JP" altLang="en-US" sz="2000">
-                <a:solidFill>
-                  <a:srgbClr val="1F2937"/>
-                </a:solidFill>
-                <a:latin typeface="Noto Sans JP" pitchFamily="34" charset="0"/>
-                <a:ea typeface="Noto Sans JP" pitchFamily="34" charset="-122"/>
-                <a:cs typeface="Noto Sans JP" pitchFamily="34" charset="-120"/>
-              </a:rPr>
-              <a:t>　　例：会議費、消耗品など</a:t>
-            </a:r>
-            <a:endParaRPr lang="en-US" altLang="ja-JP" sz="2000">
+            <a:endParaRPr lang="ja-JP" altLang="en-US" sz="2000" b="1">
               <a:solidFill>
                 <a:srgbClr val="1F2937"/>
               </a:solidFill>
@@ -22265,10 +23255,7 @@
             <a:pPr marL="0" indent="0" algn="l">
               <a:buNone/>
             </a:pPr>
-            <a:r>
-              <a:t>　④ 詳細（テキスト・長答／任意）　申請理由を自由記述</a:t>
-            </a:r>
-            <a:endParaRPr lang="ja-JP" altLang="en-US" sz="2000">
+            <a:endParaRPr lang="ja-JP" altLang="en-US" sz="2000" b="1" dirty="0">
               <a:solidFill>
                 <a:srgbClr val="1F2937"/>
               </a:solidFill>
@@ -22277,75 +23264,30 @@
               <a:cs typeface="Noto Sans JP" pitchFamily="34" charset="-120"/>
             </a:endParaRPr>
           </a:p>
-          <a:p>
-            <a:pPr marL="0" indent="0" algn="l">
-              <a:buNone/>
-            </a:pPr>
-            <a:r>
-              <a:t>・「回答の収集」でリンクをコピーしておく → 後で社内に共有</a:t>
-            </a:r>
-            <a:endParaRPr lang="ja-JP" altLang="en-US" sz="2000">
-              <a:solidFill>
-                <a:srgbClr val="1F2937"/>
-              </a:solidFill>
-              <a:latin typeface="Noto Sans JP" pitchFamily="34" charset="0"/>
-              <a:ea typeface="Noto Sans JP" pitchFamily="34" charset="-122"/>
-              <a:cs typeface="Noto Sans JP" pitchFamily="34" charset="-120"/>
-            </a:endParaRPr>
-          </a:p>
-          <a:p>
-            <a:pPr marL="0" indent="0" algn="l">
-              <a:buNone/>
-            </a:pPr>
-            <a:endParaRPr lang="ja-JP" altLang="en-US" sz="2000" dirty="0">
-              <a:solidFill>
-                <a:srgbClr val="1F2937"/>
-              </a:solidFill>
-              <a:latin typeface="Noto Sans JP" pitchFamily="34" charset="0"/>
-              <a:ea typeface="Noto Sans JP" pitchFamily="34" charset="-122"/>
-              <a:cs typeface="Noto Sans JP" pitchFamily="34" charset="-120"/>
-            </a:endParaRPr>
-          </a:p>
         </p:txBody>
       </p:sp>
       <p:pic>
         <p:nvPicPr>
-          <p:cNvPr id="15" name="図 14" descr="The image shows a form with two proposals, a section for personal names, a field for monetary values, a section for purposes, and a field for additional details.&#10;&#10;AI 生成コンテンツは誤りを含む可能性があります。">
-            <a:extLst>
-              <a:ext uri="{FF2B5EF4-FFF2-40B4-BE49-F238E27FC236}">
-                <a16:creationId xmlns:a16="http://schemas.microsoft.com/office/drawing/2014/main" id="{689B1446-4E1D-9168-07ED-183171FE5DDA}"/>
-              </a:ext>
-            </a:extLst>
-          </p:cNvPr>
+          <p:cNvPr id="52" name="Picture 51" descr="vol10-flow-2of2.png"/>
           <p:cNvPicPr>
             <a:picLocks noChangeAspect="1"/>
           </p:cNvPicPr>
           <p:nvPr/>
         </p:nvPicPr>
         <p:blipFill>
-          <a:blip r:embed="rId3"/>
+          <a:blip r:embed="rId2"/>
           <a:stretch>
             <a:fillRect/>
           </a:stretch>
         </p:blipFill>
         <p:spPr>
           <a:xfrm>
-            <a:off x="7537497" y="644768"/>
-            <a:ext cx="3520006" cy="5457141"/>
-          </a:xfrm>
-          <a:prstGeom prst="rect">
-            <a:avLst/>
-          </a:prstGeom>
-          <a:ln>
-            <a:noFill/>
-          </a:ln>
-          <a:effectLst>
-            <a:outerShdw blurRad="190500" algn="tl" rotWithShape="0">
-              <a:srgbClr val="000000">
-                <a:alpha val="70000"/>
-              </a:srgbClr>
-            </a:outerShdw>
-          </a:effectLst>
+            <a:off x="8400000" y="1500000"/>
+            <a:ext cx="3100000" cy="5200000"/>
+          </a:xfrm>
+          <a:prstGeom prst="rect">
+            <a:avLst/>
+          </a:prstGeom>
         </p:spPr>
       </p:pic>
     </p:spTree>

</xml_diff>

<commit_message>
slides(vol-10): redesign slide 1 (pre-event waiting) to proper layout
メモ書きスタイル(全部1テキストボックスにベタ書き) →
- 上部アクセントバー（PA45 / Vol.10）
- ヒーロー: 20:15 START
- サブタイトル: 第10回｜4つを1本につなぐ総復習
- 3つのpillボックス: PA/Teams起動 / YouTube公開 / 匿名OK
- フッター: Copyright

Co-Authored-By: Claude Opus 4.7 (1M context) <noreply@anthropic.com>
</commit_message>
<xml_diff>
--- a/assets/pa45/P010_PA45_BizReview_20260514.pptx
+++ b/assets/pa45/P010_PA45_BizReview_20260514.pptx
@@ -5,7 +5,7 @@
     <p:sldMasterId id="2147483648" r:id="rId1"/>
   </p:sldMasterIdLst>
   <p:notesMasterIdLst>
-    <p:notesMasterId r:id="rId19"/>
+    <p:notesMasterId r:id="rId20"/>
   </p:notesMasterIdLst>
   <p:sldIdLst>
     <p:sldId id="279" r:id="rId2"/>
@@ -16,16 +16,16 @@
     <p:sldId id="271" r:id="rId7"/>
     <p:sldId id="261" r:id="rId8"/>
     <p:sldId id="280" r:id="rId9"/>
-    <p:sldId id="291" r:id="rId26"/>
-    <p:sldId id="289" r:id="rId10"/>
-    <p:sldId id="290" r:id="rId11"/>
-    <p:sldId id="286" r:id="rId12"/>
-    <p:sldId id="287" r:id="rId13"/>
-    <p:sldId id="288" r:id="rId14"/>
-    <p:sldId id="284" r:id="rId15"/>
-    <p:sldId id="272" r:id="rId16"/>
-    <p:sldId id="268" r:id="rId17"/>
-    <p:sldId id="269" r:id="rId18"/>
+    <p:sldId id="291" r:id="rId10"/>
+    <p:sldId id="289" r:id="rId11"/>
+    <p:sldId id="290" r:id="rId12"/>
+    <p:sldId id="286" r:id="rId13"/>
+    <p:sldId id="287" r:id="rId14"/>
+    <p:sldId id="288" r:id="rId15"/>
+    <p:sldId id="284" r:id="rId16"/>
+    <p:sldId id="272" r:id="rId17"/>
+    <p:sldId id="268" r:id="rId18"/>
+    <p:sldId id="269" r:id="rId19"/>
   </p:sldIdLst>
   <p:sldSz cx="12192000" cy="6858000"/>
   <p:notesSz cx="6858000" cy="12192000"/>
@@ -1647,7 +1647,7 @@
           <a:p>
             <a:fld id="{F7021451-1387-4CA6-816F-3879F97B5CBC}" type="slidenum">
               <a:rPr lang="en-US"/>
-              <a:t>15</a:t>
+              <a:t>16</a:t>
             </a:fld>
             <a:endParaRPr lang="en-US"/>
           </a:p>
@@ -1848,7 +1848,7 @@
           <a:p>
             <a:fld id="{F7021451-1387-4CA6-816F-3879F97B5CBC}" type="slidenum">
               <a:rPr lang="en-US"/>
-              <a:t>16</a:t>
+              <a:t>17</a:t>
             </a:fld>
             <a:endParaRPr lang="en-US"/>
           </a:p>
@@ -2019,7 +2019,7 @@
           <a:p>
             <a:fld id="{F7021451-1387-4CA6-816F-3879F97B5CBC}" type="slidenum">
               <a:rPr lang="en-US"/>
-              <a:t>17</a:t>
+              <a:t>18</a:t>
             </a:fld>
             <a:endParaRPr lang="en-US"/>
           </a:p>
@@ -2395,137 +2395,754 @@
       </p:grpSpPr>
       <p:sp>
         <p:nvSpPr>
-          <p:cNvPr id="2" name="テキスト ボックス 1">
-            <a:extLst>
-              <a:ext uri="{FF2B5EF4-FFF2-40B4-BE49-F238E27FC236}">
-                <a16:creationId xmlns:a16="http://schemas.microsoft.com/office/drawing/2014/main" id="{E7009479-6313-ABD6-833D-A3E138A01A61}"/>
-              </a:ext>
-            </a:extLst>
-          </p:cNvPr>
+          <p:cNvPr id="2" name="Rectangle 1"/>
+          <p:cNvSpPr/>
+          <p:nvPr/>
+        </p:nvSpPr>
+        <p:spPr>
+          <a:xfrm>
+            <a:off x="0" y="0"/>
+            <a:ext cx="12192000" cy="6858000"/>
+          </a:xfrm>
+          <a:prstGeom prst="rect">
+            <a:avLst/>
+          </a:prstGeom>
+          <a:solidFill>
+            <a:srgbClr val="F6F9FF"/>
+          </a:solidFill>
+          <a:ln>
+            <a:noFill/>
+          </a:ln>
+        </p:spPr>
+        <p:style>
+          <a:lnRef idx="1">
+            <a:schemeClr val="accent1"/>
+          </a:lnRef>
+          <a:fillRef idx="3">
+            <a:schemeClr val="accent1"/>
+          </a:fillRef>
+          <a:effectRef idx="2">
+            <a:schemeClr val="accent1"/>
+          </a:effectRef>
+          <a:fontRef idx="minor">
+            <a:schemeClr val="lt1"/>
+          </a:fontRef>
+        </p:style>
+        <p:txBody>
+          <a:bodyPr rtlCol="0" anchor="ctr"/>
+          <a:lstStyle/>
+          <a:p>
+            <a:pPr algn="ctr"/>
+          </a:p>
+        </p:txBody>
+      </p:sp>
+      <p:sp>
+        <p:nvSpPr>
+          <p:cNvPr id="3" name="Rectangle 2"/>
+          <p:cNvSpPr/>
+          <p:nvPr/>
+        </p:nvSpPr>
+        <p:spPr>
+          <a:xfrm>
+            <a:off x="0" y="0"/>
+            <a:ext cx="12192000" cy="380000"/>
+          </a:xfrm>
+          <a:prstGeom prst="rect">
+            <a:avLst/>
+          </a:prstGeom>
+          <a:solidFill>
+            <a:srgbClr val="1E3A8A"/>
+          </a:solidFill>
+          <a:ln>
+            <a:noFill/>
+          </a:ln>
+        </p:spPr>
+        <p:style>
+          <a:lnRef idx="1">
+            <a:schemeClr val="accent1"/>
+          </a:lnRef>
+          <a:fillRef idx="3">
+            <a:schemeClr val="accent1"/>
+          </a:fillRef>
+          <a:effectRef idx="2">
+            <a:schemeClr val="accent1"/>
+          </a:effectRef>
+          <a:fontRef idx="minor">
+            <a:schemeClr val="lt1"/>
+          </a:fontRef>
+        </p:style>
+        <p:txBody>
+          <a:bodyPr rtlCol="0" anchor="ctr"/>
+          <a:lstStyle/>
+          <a:p>
+            <a:pPr algn="ctr"/>
+          </a:p>
+        </p:txBody>
+      </p:sp>
+      <p:sp>
+        <p:nvSpPr>
+          <p:cNvPr id="4" name="TextBox 3"/>
           <p:cNvSpPr txBox="1"/>
           <p:nvPr/>
         </p:nvSpPr>
         <p:spPr>
           <a:xfrm>
-            <a:off x="337457" y="338916"/>
-            <a:ext cx="11765280" cy="5755422"/>
+            <a:off x="457200" y="0"/>
+            <a:ext cx="3500000" cy="380000"/>
           </a:xfrm>
           <a:prstGeom prst="rect">
             <a:avLst/>
           </a:prstGeom>
           <a:noFill/>
-        </p:spPr>
-        <p:txBody>
-          <a:bodyPr wrap="square" rtlCol="0">
+          <a:ln>
+            <a:noFill/>
+          </a:ln>
+        </p:spPr>
+        <p:txBody>
+          <a:bodyPr wrap="square" anchor="ctr" lIns="20000" rIns="20000" tIns="0" bIns="0">
             <a:spAutoFit/>
           </a:bodyPr>
           <a:lstStyle/>
           <a:p>
-            <a:r>
-              <a:rPr kumimoji="1" lang="en-US" altLang="ja-JP" sz="4000"/>
-              <a:t>20:15</a:t>
-            </a:r>
-            <a:r>
-              <a:rPr kumimoji="1" lang="ja-JP" altLang="en-US" sz="4000"/>
-              <a:t>～スタートします</a:t>
-            </a:r>
-            <a:endParaRPr kumimoji="1" lang="en-US" altLang="ja-JP" sz="4000"/>
-          </a:p>
-          <a:p>
-            <a:endParaRPr kumimoji="1" lang="en-US" altLang="ja-JP" sz="4000"/>
-          </a:p>
-          <a:p>
-            <a:r>
-              <a:rPr kumimoji="1" lang="en-US" altLang="ja-JP" sz="4000">
-                <a:solidFill>
-                  <a:srgbClr val="FF0000"/>
-                </a:solidFill>
-              </a:rPr>
-              <a:t>Microsoft Forms</a:t>
-            </a:r>
-            <a:r>
-              <a:rPr kumimoji="1" lang="ja-JP" altLang="en-US" sz="4000"/>
-              <a:t>・</a:t>
-            </a:r>
-            <a:r>
-              <a:rPr kumimoji="1" lang="en-US" altLang="ja-JP" sz="4000">
-                <a:solidFill>
-                  <a:srgbClr val="FF0000"/>
-                </a:solidFill>
-              </a:rPr>
-              <a:t>Teams</a:t>
-            </a:r>
-            <a:r>
-              <a:rPr kumimoji="1" lang="ja-JP" altLang="en-US" sz="4000"/>
-              <a:t> を使いますので</a:t>
-            </a:r>
-            <a:endParaRPr kumimoji="1" lang="en-US" altLang="ja-JP" sz="4000"/>
-          </a:p>
-          <a:p>
-            <a:r>
-              <a:rPr kumimoji="1" lang="ja-JP" altLang="en-US" sz="4000"/>
-              <a:t>ハンズオンされる方は、事前に立ち上げておくと</a:t>
-            </a:r>
-            <a:endParaRPr kumimoji="1" lang="en-US" altLang="ja-JP" sz="4000"/>
-          </a:p>
-          <a:p>
-            <a:r>
-              <a:rPr kumimoji="1" lang="ja-JP" altLang="en-US" sz="4000"/>
-              <a:t>スムーズです！</a:t>
-            </a:r>
-            <a:r>
-              <a:rPr kumimoji="1" lang="en-US" altLang="ja-JP" sz="4000"/>
-              <a:t>(●´ω</a:t>
-            </a:r>
-            <a:r>
-              <a:rPr kumimoji="1" lang="ja-JP" altLang="en-US" sz="4000"/>
-              <a:t>｀●</a:t>
-            </a:r>
-            <a:r>
-              <a:rPr kumimoji="1" lang="en-US" altLang="ja-JP" sz="4000"/>
-              <a:t>)</a:t>
-            </a:r>
-          </a:p>
-          <a:p>
-            <a:endParaRPr kumimoji="1" lang="en-US" altLang="ja-JP" sz="4000"/>
-          </a:p>
-          <a:p>
-            <a:r>
-              <a:rPr kumimoji="1" lang="ja-JP" altLang="en-US" sz="3200"/>
-              <a:t>後日アーカイブ動画を公開予定です。</a:t>
-            </a:r>
-            <a:endParaRPr kumimoji="1" lang="en-US" altLang="ja-JP" sz="3200"/>
-          </a:p>
-          <a:p>
-            <a:r>
-              <a:rPr kumimoji="1" lang="en-US" altLang="ja-JP" sz="3200"/>
-              <a:t>Teams</a:t>
-            </a:r>
-            <a:r>
-              <a:rPr kumimoji="1" lang="ja-JP" altLang="en-US" sz="3200"/>
-              <a:t>表示名が映る場合がありますので、</a:t>
-            </a:r>
-            <a:endParaRPr kumimoji="1" lang="en-US" altLang="ja-JP" sz="3200"/>
-          </a:p>
-          <a:p>
-            <a:r>
-              <a:rPr kumimoji="1" lang="ja-JP" altLang="en-US" sz="3200"/>
-              <a:t>お名前が表示</a:t>
-            </a:r>
-            <a:r>
-              <a:rPr kumimoji="1" lang="en-US" altLang="ja-JP" sz="3200"/>
-              <a:t>NG</a:t>
-            </a:r>
-            <a:r>
-              <a:rPr kumimoji="1" lang="ja-JP" altLang="en-US" sz="3200"/>
-              <a:t>の場合は、匿名での</a:t>
-            </a:r>
-            <a:endParaRPr kumimoji="1" lang="en-US" altLang="ja-JP" sz="3200"/>
-          </a:p>
-          <a:p>
-            <a:r>
-              <a:rPr kumimoji="1" lang="ja-JP" altLang="en-US" sz="3200"/>
-              <a:t>参加をお願い致します。</a:t>
+            <a:pPr algn="l"/>
+            <a:r>
+              <a:rPr sz="1400" b="1">
+                <a:solidFill>
+                  <a:srgbClr val="FFFFFF"/>
+                </a:solidFill>
+                <a:latin typeface="Yu Gothic UI"/>
+              </a:rPr>
+              <a:t>PA45 — Power Automate 45</a:t>
+            </a:r>
+          </a:p>
+        </p:txBody>
+      </p:sp>
+      <p:sp>
+        <p:nvSpPr>
+          <p:cNvPr id="5" name="TextBox 4"/>
+          <p:cNvSpPr txBox="1"/>
+          <p:nvPr/>
+        </p:nvSpPr>
+        <p:spPr>
+          <a:xfrm>
+            <a:off x="8234800" y="0"/>
+            <a:ext cx="3500000" cy="380000"/>
+          </a:xfrm>
+          <a:prstGeom prst="rect">
+            <a:avLst/>
+          </a:prstGeom>
+          <a:noFill/>
+          <a:ln>
+            <a:noFill/>
+          </a:ln>
+        </p:spPr>
+        <p:txBody>
+          <a:bodyPr wrap="square" anchor="ctr" lIns="20000" rIns="20000" tIns="0" bIns="0">
+            <a:spAutoFit/>
+          </a:bodyPr>
+          <a:lstStyle/>
+          <a:p>
+            <a:pPr algn="r"/>
+            <a:r>
+              <a:rPr sz="1400" b="0">
+                <a:solidFill>
+                  <a:srgbClr val="C7D8FF"/>
+                </a:solidFill>
+                <a:latin typeface="Yu Gothic UI"/>
+              </a:rPr>
+              <a:t>第10回 / Vol.10</a:t>
+            </a:r>
+          </a:p>
+        </p:txBody>
+      </p:sp>
+      <p:sp>
+        <p:nvSpPr>
+          <p:cNvPr id="6" name="TextBox 5"/>
+          <p:cNvSpPr txBox="1"/>
+          <p:nvPr/>
+        </p:nvSpPr>
+        <p:spPr>
+          <a:xfrm>
+            <a:off x="0" y="1100000"/>
+            <a:ext cx="12192000" cy="360000"/>
+          </a:xfrm>
+          <a:prstGeom prst="rect">
+            <a:avLst/>
+          </a:prstGeom>
+          <a:noFill/>
+          <a:ln>
+            <a:noFill/>
+          </a:ln>
+        </p:spPr>
+        <p:txBody>
+          <a:bodyPr wrap="square" anchor="ctr" lIns="20000" rIns="20000" tIns="0" bIns="0">
+            <a:spAutoFit/>
+          </a:bodyPr>
+          <a:lstStyle/>
+          <a:p>
+            <a:pPr algn="ctr"/>
+            <a:r>
+              <a:rPr sz="2200" b="0">
+                <a:solidFill>
+                  <a:srgbClr val="475569"/>
+                </a:solidFill>
+                <a:latin typeface="Yu Gothic UI"/>
+              </a:rPr>
+              <a:t>まもなく開始します</a:t>
+            </a:r>
+          </a:p>
+        </p:txBody>
+      </p:sp>
+      <p:sp>
+        <p:nvSpPr>
+          <p:cNvPr id="7" name="TextBox 6"/>
+          <p:cNvSpPr txBox="1"/>
+          <p:nvPr/>
+        </p:nvSpPr>
+        <p:spPr>
+          <a:xfrm>
+            <a:off x="0" y="1700000"/>
+            <a:ext cx="12192000" cy="1700000"/>
+          </a:xfrm>
+          <a:prstGeom prst="rect">
+            <a:avLst/>
+          </a:prstGeom>
+          <a:noFill/>
+          <a:ln>
+            <a:noFill/>
+          </a:ln>
+        </p:spPr>
+        <p:txBody>
+          <a:bodyPr wrap="square" anchor="ctr" lIns="20000" rIns="20000" tIns="0" bIns="0">
+            <a:spAutoFit/>
+          </a:bodyPr>
+          <a:lstStyle/>
+          <a:p>
+            <a:pPr algn="ctr"/>
+            <a:r>
+              <a:rPr sz="9600" b="1">
+                <a:solidFill>
+                  <a:srgbClr val="1E3A8A"/>
+                </a:solidFill>
+                <a:latin typeface="Yu Gothic UI"/>
+              </a:rPr>
+              <a:t>20:15 START</a:t>
+            </a:r>
+          </a:p>
+        </p:txBody>
+      </p:sp>
+      <p:sp>
+        <p:nvSpPr>
+          <p:cNvPr id="8" name="TextBox 7"/>
+          <p:cNvSpPr txBox="1"/>
+          <p:nvPr/>
+        </p:nvSpPr>
+        <p:spPr>
+          <a:xfrm>
+            <a:off x="0" y="3700000"/>
+            <a:ext cx="12192000" cy="500000"/>
+          </a:xfrm>
+          <a:prstGeom prst="rect">
+            <a:avLst/>
+          </a:prstGeom>
+          <a:noFill/>
+          <a:ln>
+            <a:noFill/>
+          </a:ln>
+        </p:spPr>
+        <p:txBody>
+          <a:bodyPr wrap="square" anchor="ctr" lIns="20000" rIns="20000" tIns="0" bIns="0">
+            <a:spAutoFit/>
+          </a:bodyPr>
+          <a:lstStyle/>
+          <a:p>
+            <a:pPr algn="ctr"/>
+            <a:r>
+              <a:rPr sz="2600" b="1">
+                <a:solidFill>
+                  <a:srgbClr val="0F172A"/>
+                </a:solidFill>
+                <a:latin typeface="Yu Gothic UI"/>
+              </a:rPr>
+              <a:t>第10回｜4つを1本につなぐ総復習</a:t>
+            </a:r>
+          </a:p>
+        </p:txBody>
+      </p:sp>
+      <p:sp>
+        <p:nvSpPr>
+          <p:cNvPr id="9" name="TextBox 8"/>
+          <p:cNvSpPr txBox="1"/>
+          <p:nvPr/>
+        </p:nvSpPr>
+        <p:spPr>
+          <a:xfrm>
+            <a:off x="0" y="4250000"/>
+            <a:ext cx="12192000" cy="400000"/>
+          </a:xfrm>
+          <a:prstGeom prst="rect">
+            <a:avLst/>
+          </a:prstGeom>
+          <a:noFill/>
+          <a:ln>
+            <a:noFill/>
+          </a:ln>
+        </p:spPr>
+        <p:txBody>
+          <a:bodyPr wrap="square" anchor="ctr" lIns="20000" rIns="20000" tIns="0" bIns="0">
+            <a:spAutoFit/>
+          </a:bodyPr>
+          <a:lstStyle/>
+          <a:p>
+            <a:pPr algn="ctr"/>
+            <a:r>
+              <a:rPr sz="1600" b="0">
+                <a:solidFill>
+                  <a:srgbClr val="475569"/>
+                </a:solidFill>
+                <a:latin typeface="Yu Gothic UI"/>
+              </a:rPr>
+              <a:t>経費申請の自動化（Forms × SharePoint × 承認 × Teams）</a:t>
+            </a:r>
+          </a:p>
+        </p:txBody>
+      </p:sp>
+      <p:sp>
+        <p:nvSpPr>
+          <p:cNvPr id="10" name="Rounded Rectangle 9"/>
+          <p:cNvSpPr/>
+          <p:nvPr/>
+        </p:nvSpPr>
+        <p:spPr>
+          <a:xfrm>
+            <a:off x="796000" y="5300000"/>
+            <a:ext cx="3400000" cy="650000"/>
+          </a:xfrm>
+          <a:prstGeom prst="roundRect">
+            <a:avLst/>
+          </a:prstGeom>
+          <a:solidFill>
+            <a:srgbClr val="FFFFFF"/>
+          </a:solidFill>
+          <a:ln w="12700">
+            <a:solidFill>
+              <a:srgbClr val="C7D8FF"/>
+            </a:solidFill>
+          </a:ln>
+          <a:effectLst/>
+        </p:spPr>
+        <p:style>
+          <a:lnRef idx="1">
+            <a:schemeClr val="accent1"/>
+          </a:lnRef>
+          <a:fillRef idx="3">
+            <a:schemeClr val="accent1"/>
+          </a:fillRef>
+          <a:effectRef idx="2">
+            <a:schemeClr val="accent1"/>
+          </a:effectRef>
+          <a:fontRef idx="minor">
+            <a:schemeClr val="lt1"/>
+          </a:fontRef>
+        </p:style>
+        <p:txBody>
+          <a:bodyPr rtlCol="0" anchor="ctr"/>
+          <a:lstStyle/>
+          <a:p>
+            <a:pPr algn="ctr"/>
+          </a:p>
+        </p:txBody>
+      </p:sp>
+      <p:sp>
+        <p:nvSpPr>
+          <p:cNvPr id="11" name="TextBox 10"/>
+          <p:cNvSpPr txBox="1"/>
+          <p:nvPr/>
+        </p:nvSpPr>
+        <p:spPr>
+          <a:xfrm>
+            <a:off x="916000" y="5300000"/>
+            <a:ext cx="550000" cy="650000"/>
+          </a:xfrm>
+          <a:prstGeom prst="rect">
+            <a:avLst/>
+          </a:prstGeom>
+          <a:noFill/>
+          <a:ln>
+            <a:noFill/>
+          </a:ln>
+        </p:spPr>
+        <p:txBody>
+          <a:bodyPr wrap="square" anchor="ctr" lIns="20000" rIns="20000" tIns="0" bIns="0">
+            <a:spAutoFit/>
+          </a:bodyPr>
+          <a:lstStyle/>
+          <a:p>
+            <a:pPr algn="ctr"/>
+            <a:r>
+              <a:rPr sz="2200" b="0">
+                <a:solidFill>
+                  <a:srgbClr val="1E3A8A"/>
+                </a:solidFill>
+                <a:latin typeface="Yu Gothic UI"/>
+              </a:rPr>
+              <a:t>📥</a:t>
+            </a:r>
+          </a:p>
+        </p:txBody>
+      </p:sp>
+      <p:sp>
+        <p:nvSpPr>
+          <p:cNvPr id="12" name="TextBox 11"/>
+          <p:cNvSpPr txBox="1"/>
+          <p:nvPr/>
+        </p:nvSpPr>
+        <p:spPr>
+          <a:xfrm>
+            <a:off x="1476000" y="5300000"/>
+            <a:ext cx="2700000" cy="650000"/>
+          </a:xfrm>
+          <a:prstGeom prst="rect">
+            <a:avLst/>
+          </a:prstGeom>
+          <a:noFill/>
+          <a:ln>
+            <a:noFill/>
+          </a:ln>
+        </p:spPr>
+        <p:txBody>
+          <a:bodyPr wrap="square" anchor="ctr">
+            <a:spAutoFit/>
+          </a:bodyPr>
+          <a:lstStyle/>
+          <a:p>
+            <a:pPr algn="l"/>
+            <a:r>
+              <a:rPr sz="1100" b="1">
+                <a:solidFill>
+                  <a:srgbClr val="0F172A"/>
+                </a:solidFill>
+                <a:latin typeface="Yu Gothic UI"/>
+              </a:rPr>
+              <a:t>Power Automate と Teams を</a:t>
+            </a:r>
+          </a:p>
+          <a:p>
+            <a:pPr algn="l"/>
+            <a:r>
+              <a:rPr sz="1000" b="0">
+                <a:solidFill>
+                  <a:srgbClr val="475569"/>
+                </a:solidFill>
+                <a:latin typeface="Yu Gothic UI"/>
+              </a:rPr>
+              <a:t>事前に起動しておくとスムーズ</a:t>
+            </a:r>
+          </a:p>
+        </p:txBody>
+      </p:sp>
+      <p:sp>
+        <p:nvSpPr>
+          <p:cNvPr id="13" name="Rounded Rectangle 12"/>
+          <p:cNvSpPr/>
+          <p:nvPr/>
+        </p:nvSpPr>
+        <p:spPr>
+          <a:xfrm>
+            <a:off x="4396000" y="5300000"/>
+            <a:ext cx="3400000" cy="650000"/>
+          </a:xfrm>
+          <a:prstGeom prst="roundRect">
+            <a:avLst/>
+          </a:prstGeom>
+          <a:solidFill>
+            <a:srgbClr val="FFFFFF"/>
+          </a:solidFill>
+          <a:ln w="12700">
+            <a:solidFill>
+              <a:srgbClr val="C7D8FF"/>
+            </a:solidFill>
+          </a:ln>
+          <a:effectLst/>
+        </p:spPr>
+        <p:style>
+          <a:lnRef idx="1">
+            <a:schemeClr val="accent1"/>
+          </a:lnRef>
+          <a:fillRef idx="3">
+            <a:schemeClr val="accent1"/>
+          </a:fillRef>
+          <a:effectRef idx="2">
+            <a:schemeClr val="accent1"/>
+          </a:effectRef>
+          <a:fontRef idx="minor">
+            <a:schemeClr val="lt1"/>
+          </a:fontRef>
+        </p:style>
+        <p:txBody>
+          <a:bodyPr rtlCol="0" anchor="ctr"/>
+          <a:lstStyle/>
+          <a:p>
+            <a:pPr algn="ctr"/>
+          </a:p>
+        </p:txBody>
+      </p:sp>
+      <p:sp>
+        <p:nvSpPr>
+          <p:cNvPr id="14" name="TextBox 13"/>
+          <p:cNvSpPr txBox="1"/>
+          <p:nvPr/>
+        </p:nvSpPr>
+        <p:spPr>
+          <a:xfrm>
+            <a:off x="4516000" y="5300000"/>
+            <a:ext cx="550000" cy="650000"/>
+          </a:xfrm>
+          <a:prstGeom prst="rect">
+            <a:avLst/>
+          </a:prstGeom>
+          <a:noFill/>
+          <a:ln>
+            <a:noFill/>
+          </a:ln>
+        </p:spPr>
+        <p:txBody>
+          <a:bodyPr wrap="square" anchor="ctr" lIns="20000" rIns="20000" tIns="0" bIns="0">
+            <a:spAutoFit/>
+          </a:bodyPr>
+          <a:lstStyle/>
+          <a:p>
+            <a:pPr algn="ctr"/>
+            <a:r>
+              <a:rPr sz="2200" b="0">
+                <a:solidFill>
+                  <a:srgbClr val="1E3A8A"/>
+                </a:solidFill>
+                <a:latin typeface="Yu Gothic UI"/>
+              </a:rPr>
+              <a:t>🎥</a:t>
+            </a:r>
+          </a:p>
+        </p:txBody>
+      </p:sp>
+      <p:sp>
+        <p:nvSpPr>
+          <p:cNvPr id="15" name="TextBox 14"/>
+          <p:cNvSpPr txBox="1"/>
+          <p:nvPr/>
+        </p:nvSpPr>
+        <p:spPr>
+          <a:xfrm>
+            <a:off x="5076000" y="5300000"/>
+            <a:ext cx="2700000" cy="650000"/>
+          </a:xfrm>
+          <a:prstGeom prst="rect">
+            <a:avLst/>
+          </a:prstGeom>
+          <a:noFill/>
+          <a:ln>
+            <a:noFill/>
+          </a:ln>
+        </p:spPr>
+        <p:txBody>
+          <a:bodyPr wrap="square" anchor="ctr">
+            <a:spAutoFit/>
+          </a:bodyPr>
+          <a:lstStyle/>
+          <a:p>
+            <a:pPr algn="l"/>
+            <a:r>
+              <a:rPr sz="1100" b="1">
+                <a:solidFill>
+                  <a:srgbClr val="0F172A"/>
+                </a:solidFill>
+                <a:latin typeface="Yu Gothic UI"/>
+              </a:rPr>
+              <a:t>後日YouTubeで</a:t>
+            </a:r>
+          </a:p>
+          <a:p>
+            <a:pPr algn="l"/>
+            <a:r>
+              <a:rPr sz="1000" b="0">
+                <a:solidFill>
+                  <a:srgbClr val="475569"/>
+                </a:solidFill>
+                <a:latin typeface="Yu Gothic UI"/>
+              </a:rPr>
+              <a:t>アーカイブ動画を公開予定</a:t>
+            </a:r>
+          </a:p>
+        </p:txBody>
+      </p:sp>
+      <p:sp>
+        <p:nvSpPr>
+          <p:cNvPr id="16" name="Rounded Rectangle 15"/>
+          <p:cNvSpPr/>
+          <p:nvPr/>
+        </p:nvSpPr>
+        <p:spPr>
+          <a:xfrm>
+            <a:off x="7996000" y="5300000"/>
+            <a:ext cx="3400000" cy="650000"/>
+          </a:xfrm>
+          <a:prstGeom prst="roundRect">
+            <a:avLst/>
+          </a:prstGeom>
+          <a:solidFill>
+            <a:srgbClr val="FFFFFF"/>
+          </a:solidFill>
+          <a:ln w="12700">
+            <a:solidFill>
+              <a:srgbClr val="C7D8FF"/>
+            </a:solidFill>
+          </a:ln>
+          <a:effectLst/>
+        </p:spPr>
+        <p:style>
+          <a:lnRef idx="1">
+            <a:schemeClr val="accent1"/>
+          </a:lnRef>
+          <a:fillRef idx="3">
+            <a:schemeClr val="accent1"/>
+          </a:fillRef>
+          <a:effectRef idx="2">
+            <a:schemeClr val="accent1"/>
+          </a:effectRef>
+          <a:fontRef idx="minor">
+            <a:schemeClr val="lt1"/>
+          </a:fontRef>
+        </p:style>
+        <p:txBody>
+          <a:bodyPr rtlCol="0" anchor="ctr"/>
+          <a:lstStyle/>
+          <a:p>
+            <a:pPr algn="ctr"/>
+          </a:p>
+        </p:txBody>
+      </p:sp>
+      <p:sp>
+        <p:nvSpPr>
+          <p:cNvPr id="17" name="TextBox 16"/>
+          <p:cNvSpPr txBox="1"/>
+          <p:nvPr/>
+        </p:nvSpPr>
+        <p:spPr>
+          <a:xfrm>
+            <a:off x="8116000" y="5300000"/>
+            <a:ext cx="550000" cy="650000"/>
+          </a:xfrm>
+          <a:prstGeom prst="rect">
+            <a:avLst/>
+          </a:prstGeom>
+          <a:noFill/>
+          <a:ln>
+            <a:noFill/>
+          </a:ln>
+        </p:spPr>
+        <p:txBody>
+          <a:bodyPr wrap="square" anchor="ctr" lIns="20000" rIns="20000" tIns="0" bIns="0">
+            <a:spAutoFit/>
+          </a:bodyPr>
+          <a:lstStyle/>
+          <a:p>
+            <a:pPr algn="ctr"/>
+            <a:r>
+              <a:rPr sz="2200" b="0">
+                <a:solidFill>
+                  <a:srgbClr val="1E3A8A"/>
+                </a:solidFill>
+                <a:latin typeface="Yu Gothic UI"/>
+              </a:rPr>
+              <a:t>🕵</a:t>
+            </a:r>
+          </a:p>
+        </p:txBody>
+      </p:sp>
+      <p:sp>
+        <p:nvSpPr>
+          <p:cNvPr id="18" name="TextBox 17"/>
+          <p:cNvSpPr txBox="1"/>
+          <p:nvPr/>
+        </p:nvSpPr>
+        <p:spPr>
+          <a:xfrm>
+            <a:off x="8676000" y="5300000"/>
+            <a:ext cx="2700000" cy="650000"/>
+          </a:xfrm>
+          <a:prstGeom prst="rect">
+            <a:avLst/>
+          </a:prstGeom>
+          <a:noFill/>
+          <a:ln>
+            <a:noFill/>
+          </a:ln>
+        </p:spPr>
+        <p:txBody>
+          <a:bodyPr wrap="square" anchor="ctr">
+            <a:spAutoFit/>
+          </a:bodyPr>
+          <a:lstStyle/>
+          <a:p>
+            <a:pPr algn="l"/>
+            <a:r>
+              <a:rPr sz="1100" b="1">
+                <a:solidFill>
+                  <a:srgbClr val="0F172A"/>
+                </a:solidFill>
+                <a:latin typeface="Yu Gothic UI"/>
+              </a:rPr>
+              <a:t>Teams表示名がNGの方は</a:t>
+            </a:r>
+          </a:p>
+          <a:p>
+            <a:pPr algn="l"/>
+            <a:r>
+              <a:rPr sz="1000" b="0">
+                <a:solidFill>
+                  <a:srgbClr val="475569"/>
+                </a:solidFill>
+                <a:latin typeface="Yu Gothic UI"/>
+              </a:rPr>
+              <a:t>匿名参加でOKです</a:t>
+            </a:r>
+          </a:p>
+        </p:txBody>
+      </p:sp>
+      <p:sp>
+        <p:nvSpPr>
+          <p:cNvPr id="19" name="TextBox 18"/>
+          <p:cNvSpPr txBox="1"/>
+          <p:nvPr/>
+        </p:nvSpPr>
+        <p:spPr>
+          <a:xfrm>
+            <a:off x="0" y="6478000"/>
+            <a:ext cx="12192000" cy="360000"/>
+          </a:xfrm>
+          <a:prstGeom prst="rect">
+            <a:avLst/>
+          </a:prstGeom>
+          <a:noFill/>
+          <a:ln>
+            <a:noFill/>
+          </a:ln>
+        </p:spPr>
+        <p:txBody>
+          <a:bodyPr wrap="square" anchor="ctr" lIns="20000" rIns="20000" tIns="0" bIns="0">
+            <a:spAutoFit/>
+          </a:bodyPr>
+          <a:lstStyle/>
+          <a:p>
+            <a:pPr algn="ctr"/>
+            <a:r>
+              <a:rPr sz="1000" b="0">
+                <a:solidFill>
+                  <a:srgbClr val="94A3B8"/>
+                </a:solidFill>
+                <a:latin typeface="Yu Gothic UI"/>
+              </a:rPr>
+              <a:t>Power Automate 45  |  Copyright © PA45</a:t>
             </a:r>
           </a:p>
         </p:txBody>
@@ -2760,7 +3377,7 @@
               <a:buNone/>
             </a:pPr>
             <a:r>
-              <a:rPr lang="en-US" sz="3600" b="1" dirty="0">
+              <a:rPr lang="en-US" sz="2800" b="1" dirty="0">
                 <a:solidFill>
                   <a:srgbClr val="1F2937"/>
                 </a:solidFill>
@@ -2770,7 +3387,7 @@
               </a:rPr>
               <a:t>事前準備 ①  Formsの設問を作る</a:t>
             </a:r>
-            <a:endParaRPr lang="en-US" sz="3600" dirty="0"/>
+            <a:endParaRPr lang="en-US" sz="2800" dirty="0"/>
           </a:p>
         </p:txBody>
       </p:sp>
@@ -3773,7 +4390,7 @@
         </p:nvSpPr>
         <p:spPr>
           <a:xfrm>
-            <a:off x="457200" y="533095"/>
+            <a:off x="371551" y="636536"/>
             <a:ext cx="7781544" cy="715061"/>
           </a:xfrm>
           <a:prstGeom prst="rect">
@@ -4290,7 +4907,7 @@
         </p:nvSpPr>
         <p:spPr>
           <a:xfrm>
-            <a:off x="265580" y="1714500"/>
+            <a:off x="371551" y="1664075"/>
             <a:ext cx="6971243" cy="4428037"/>
           </a:xfrm>
           <a:prstGeom prst="rect">
@@ -4307,22 +4924,20 @@
               <a:buNone/>
             </a:pPr>
             <a:r>
-              <a:rPr lang="ja-JP" altLang="en-US" sz="2000">
+              <a:rPr lang="ja-JP" altLang="en-US" sz="2000" b="1">
                 <a:solidFill>
                   <a:srgbClr val="1F2937"/>
                 </a:solidFill>
-                <a:latin typeface="Noto Sans JP" pitchFamily="34" charset="0"/>
-                <a:ea typeface="Noto Sans JP" pitchFamily="34" charset="-122"/>
+                <a:latin typeface="+mn-ea"/>
                 <a:cs typeface="Noto Sans JP" pitchFamily="34" charset="-120"/>
               </a:rPr>
               <a:t>🎯 目的：申請データを蓄積して、</a:t>
             </a:r>
-            <a:endParaRPr lang="en-US" altLang="ja-JP" sz="2000">
+            <a:endParaRPr lang="en-US" altLang="ja-JP" sz="2000" b="1">
               <a:solidFill>
                 <a:srgbClr val="1F2937"/>
               </a:solidFill>
-              <a:latin typeface="Noto Sans JP" pitchFamily="34" charset="0"/>
-              <a:ea typeface="Noto Sans JP" pitchFamily="34" charset="-122"/>
+              <a:latin typeface="+mn-ea"/>
               <a:cs typeface="Noto Sans JP" pitchFamily="34" charset="-120"/>
             </a:endParaRPr>
           </a:p>
@@ -4331,22 +4946,20 @@
               <a:buNone/>
             </a:pPr>
             <a:r>
-              <a:rPr lang="ja-JP" altLang="en-US" sz="2000">
+              <a:rPr lang="ja-JP" altLang="en-US" sz="2000" b="1">
                 <a:solidFill>
                   <a:srgbClr val="1F2937"/>
                 </a:solidFill>
-                <a:latin typeface="Noto Sans JP" pitchFamily="34" charset="0"/>
-                <a:ea typeface="Noto Sans JP" pitchFamily="34" charset="-122"/>
+                <a:latin typeface="+mn-ea"/>
                 <a:cs typeface="Noto Sans JP" pitchFamily="34" charset="-120"/>
               </a:rPr>
               <a:t>上司も経理もあとから見返せる「台帳」にする</a:t>
             </a:r>
-            <a:endParaRPr lang="en-US" altLang="ja-JP" sz="2000">
+            <a:endParaRPr lang="en-US" altLang="ja-JP" sz="2000" b="1">
               <a:solidFill>
                 <a:srgbClr val="1F2937"/>
               </a:solidFill>
-              <a:latin typeface="Noto Sans JP" pitchFamily="34" charset="0"/>
-              <a:ea typeface="Noto Sans JP" pitchFamily="34" charset="-122"/>
+              <a:latin typeface="+mn-ea"/>
               <a:cs typeface="Noto Sans JP" pitchFamily="34" charset="-120"/>
             </a:endParaRPr>
           </a:p>
@@ -4354,12 +4967,11 @@
             <a:pPr marL="0" indent="0" algn="l">
               <a:buNone/>
             </a:pPr>
-            <a:endParaRPr lang="en-US" altLang="ja-JP" sz="2000">
+            <a:endParaRPr lang="en-US" altLang="ja-JP" sz="2000" b="1">
               <a:solidFill>
                 <a:srgbClr val="1F2937"/>
               </a:solidFill>
-              <a:latin typeface="Noto Sans JP" pitchFamily="34" charset="0"/>
-              <a:ea typeface="Noto Sans JP" pitchFamily="34" charset="-122"/>
+              <a:latin typeface="+mn-ea"/>
               <a:cs typeface="Noto Sans JP" pitchFamily="34" charset="-120"/>
             </a:endParaRPr>
           </a:p>
@@ -4368,22 +4980,20 @@
               <a:buNone/>
             </a:pPr>
             <a:r>
-              <a:rPr lang="ja-JP" altLang="en-US" sz="2000">
+              <a:rPr lang="ja-JP" altLang="en-US" sz="2000" b="1">
                 <a:solidFill>
                   <a:srgbClr val="1F2937"/>
                 </a:solidFill>
-                <a:latin typeface="Noto Sans JP" pitchFamily="34" charset="0"/>
-                <a:ea typeface="Noto Sans JP" pitchFamily="34" charset="-122"/>
+                <a:latin typeface="+mn-ea"/>
                 <a:cs typeface="Noto Sans JP" pitchFamily="34" charset="-120"/>
               </a:rPr>
               <a:t>・SharePointサイト &gt; 新規 &gt; リスト &gt; 空のリストを選択</a:t>
             </a:r>
-            <a:endParaRPr lang="en-US" altLang="ja-JP" sz="2000">
+            <a:endParaRPr lang="en-US" altLang="ja-JP" sz="2000" b="1">
               <a:solidFill>
                 <a:srgbClr val="1F2937"/>
               </a:solidFill>
-              <a:latin typeface="Noto Sans JP" pitchFamily="34" charset="0"/>
-              <a:ea typeface="Noto Sans JP" pitchFamily="34" charset="-122"/>
+              <a:latin typeface="+mn-ea"/>
               <a:cs typeface="Noto Sans JP" pitchFamily="34" charset="-120"/>
             </a:endParaRPr>
           </a:p>
@@ -4391,12 +5001,11 @@
             <a:pPr marL="0" indent="0" algn="l">
               <a:buNone/>
             </a:pPr>
-            <a:endParaRPr lang="en-US" altLang="ja-JP" sz="2000">
+            <a:endParaRPr lang="en-US" altLang="ja-JP" sz="2000" b="1">
               <a:solidFill>
                 <a:srgbClr val="1F2937"/>
               </a:solidFill>
-              <a:latin typeface="Noto Sans JP" pitchFamily="34" charset="0"/>
-              <a:ea typeface="Noto Sans JP" pitchFamily="34" charset="-122"/>
+              <a:latin typeface="+mn-ea"/>
               <a:cs typeface="Noto Sans JP" pitchFamily="34" charset="-120"/>
             </a:endParaRPr>
           </a:p>
@@ -4405,20 +5014,24 @@
               <a:buNone/>
             </a:pPr>
             <a:r>
+              <a:rPr b="1">
+                <a:latin typeface="+mn-ea"/>
+              </a:rPr>
               <a:t>・リスト名：経費申請</a:t>
             </a:r>
-            <a:endParaRPr lang="en-US"/>
-          </a:p>
-          <a:p>
-            <a:pPr marL="0" indent="0" algn="l">
-              <a:buNone/>
-            </a:pPr>
-            <a:endParaRPr lang="ja-JP" altLang="en-US" sz="2000">
+            <a:endParaRPr lang="en-US" b="1">
+              <a:latin typeface="+mn-ea"/>
+            </a:endParaRPr>
+          </a:p>
+          <a:p>
+            <a:pPr marL="0" indent="0" algn="l">
+              <a:buNone/>
+            </a:pPr>
+            <a:endParaRPr lang="ja-JP" altLang="en-US" sz="2000" b="1">
               <a:solidFill>
                 <a:srgbClr val="1F2937"/>
               </a:solidFill>
-              <a:latin typeface="Noto Sans JP" pitchFamily="34" charset="0"/>
-              <a:ea typeface="Noto Sans JP" pitchFamily="34" charset="-122"/>
+              <a:latin typeface="+mn-ea"/>
               <a:cs typeface="Noto Sans JP" pitchFamily="34" charset="-120"/>
             </a:endParaRPr>
           </a:p>
@@ -4427,43 +5040,71 @@
               <a:buNone/>
             </a:pPr>
             <a:r>
-              <a:rPr lang="ja-JP" altLang="en-US" sz="2000">
+              <a:rPr lang="ja-JP" altLang="en-US" sz="2000" b="1">
                 <a:solidFill>
                   <a:srgbClr val="1F2937"/>
                 </a:solidFill>
-                <a:latin typeface="Noto Sans JP" pitchFamily="34" charset="0"/>
-                <a:ea typeface="Noto Sans JP" pitchFamily="34" charset="-122"/>
+                <a:latin typeface="+mn-ea"/>
                 <a:cs typeface="Noto Sans JP" pitchFamily="34" charset="-120"/>
               </a:rPr>
-              <a:t>・列を3つ追加（Title列は最初からあるのでそのまま使用）</a:t>
-            </a:r>
-          </a:p>
-          <a:p>
-            <a:pPr marL="0" indent="0" algn="l">
-              <a:buNone/>
-            </a:pPr>
-            <a:r>
+              <a:t>・列を3つ追加（</a:t>
+            </a:r>
+            <a:r>
+              <a:rPr lang="ja-JP" altLang="en-US" sz="2000" b="1">
+                <a:solidFill>
+                  <a:srgbClr val="1F2937"/>
+                </a:solidFill>
+                <a:latin typeface="+mn-ea"/>
+                <a:cs typeface="Microsoft Sans Serif" panose="020B0604020202020204" pitchFamily="34" charset="0"/>
+              </a:rPr>
+              <a:t>Title</a:t>
+            </a:r>
+            <a:r>
+              <a:rPr lang="ja-JP" altLang="en-US" sz="2000" b="1">
+                <a:solidFill>
+                  <a:srgbClr val="1F2937"/>
+                </a:solidFill>
+                <a:latin typeface="+mn-ea"/>
+                <a:cs typeface="Noto Sans JP" pitchFamily="34" charset="-120"/>
+              </a:rPr>
+              <a:t>列は最初からあるのでそのまま使用）</a:t>
+            </a:r>
+          </a:p>
+          <a:p>
+            <a:pPr marL="0" indent="0" algn="l">
+              <a:buNone/>
+            </a:pPr>
+            <a:r>
+              <a:rPr b="1">
+                <a:latin typeface="+mn-ea"/>
+              </a:rPr>
               <a:t>　① Title（テキスト・既定）　申請の見出し</a:t>
             </a:r>
-            <a:endParaRPr lang="en-US"/>
-          </a:p>
-          <a:p>
-            <a:pPr marL="0" indent="0" algn="l">
-              <a:buNone/>
-            </a:pPr>
-            <a:r>
-              <a:rPr lang="ja-JP" altLang="en-US"/>
+            <a:endParaRPr lang="en-US" b="1">
+              <a:latin typeface="+mn-ea"/>
+            </a:endParaRPr>
+          </a:p>
+          <a:p>
+            <a:pPr marL="0" indent="0" algn="l">
+              <a:buNone/>
+            </a:pPr>
+            <a:r>
+              <a:rPr lang="ja-JP" altLang="en-US" b="1">
+                <a:latin typeface="+mn-ea"/>
+              </a:rPr>
               <a:t>　　</a:t>
             </a:r>
             <a:r>
+              <a:rPr b="1">
+                <a:latin typeface="+mn-ea"/>
+              </a:rPr>
               <a:t>（フローでサマリ文を入れる）</a:t>
             </a:r>
-            <a:endParaRPr lang="en-US" altLang="ja-JP" sz="2000">
+            <a:endParaRPr lang="en-US" altLang="ja-JP" sz="2000" b="1">
               <a:solidFill>
                 <a:srgbClr val="1F2937"/>
               </a:solidFill>
-              <a:latin typeface="Noto Sans JP" pitchFamily="34" charset="0"/>
-              <a:ea typeface="Noto Sans JP" pitchFamily="34" charset="-122"/>
+              <a:latin typeface="+mn-ea"/>
               <a:cs typeface="Noto Sans JP" pitchFamily="34" charset="-120"/>
             </a:endParaRPr>
           </a:p>
@@ -4472,22 +5113,20 @@
               <a:buNone/>
             </a:pPr>
             <a:r>
-              <a:rPr lang="ja-JP" altLang="en-US" sz="2000">
+              <a:rPr lang="ja-JP" altLang="en-US" sz="2000" b="1">
                 <a:solidFill>
                   <a:srgbClr val="1F2937"/>
                 </a:solidFill>
-                <a:latin typeface="Noto Sans JP" pitchFamily="34" charset="0"/>
-                <a:ea typeface="Noto Sans JP" pitchFamily="34" charset="-122"/>
+                <a:latin typeface="+mn-ea"/>
                 <a:cs typeface="Noto Sans JP" pitchFamily="34" charset="-120"/>
               </a:rPr>
               <a:t>　② Detail（複数行テキスト）　Formsの「詳細」を保存</a:t>
             </a:r>
-            <a:endParaRPr lang="en-US" altLang="ja-JP" sz="2000">
+            <a:endParaRPr lang="en-US" altLang="ja-JP" sz="2000" b="1">
               <a:solidFill>
                 <a:srgbClr val="1F2937"/>
               </a:solidFill>
-              <a:latin typeface="Noto Sans JP" pitchFamily="34" charset="0"/>
-              <a:ea typeface="Noto Sans JP" pitchFamily="34" charset="-122"/>
+              <a:latin typeface="+mn-ea"/>
               <a:cs typeface="Noto Sans JP" pitchFamily="34" charset="-120"/>
             </a:endParaRPr>
           </a:p>
@@ -4495,15 +5134,11 @@
             <a:pPr marL="0" indent="0" algn="l">
               <a:buNone/>
             </a:pPr>
-            <a:r>
-              <a:t>　③ Status（選択肢）　「申請中」「承認済」「却下」の3択</a:t>
-            </a:r>
-            <a:endParaRPr lang="ja-JP" altLang="en-US" sz="2000">
+            <a:endParaRPr lang="en-US" altLang="ja-JP" sz="2000" b="1">
               <a:solidFill>
                 <a:srgbClr val="1F2937"/>
               </a:solidFill>
-              <a:latin typeface="Noto Sans JP" pitchFamily="34" charset="0"/>
-              <a:ea typeface="Noto Sans JP" pitchFamily="34" charset="-122"/>
+              <a:latin typeface="+mn-ea"/>
               <a:cs typeface="Noto Sans JP" pitchFamily="34" charset="-120"/>
             </a:endParaRPr>
           </a:p>
@@ -4512,14 +5147,34 @@
               <a:buNone/>
             </a:pPr>
             <a:r>
-              <a:t>・既定値：Status =「申請中」にしておくと安心</a:t>
-            </a:r>
-            <a:endParaRPr lang="ja-JP" altLang="en-US" sz="2000">
+              <a:rPr b="1">
+                <a:latin typeface="+mn-ea"/>
+              </a:rPr>
+              <a:t>　③ Status（選択肢）　「申請中」「承認済」「却下」の3択</a:t>
+            </a:r>
+            <a:endParaRPr lang="ja-JP" altLang="en-US" sz="2000" b="1">
               <a:solidFill>
                 <a:srgbClr val="1F2937"/>
               </a:solidFill>
-              <a:latin typeface="Noto Sans JP" pitchFamily="34" charset="0"/>
-              <a:ea typeface="Noto Sans JP" pitchFamily="34" charset="-122"/>
+              <a:latin typeface="+mn-ea"/>
+              <a:cs typeface="Noto Sans JP" pitchFamily="34" charset="-120"/>
+            </a:endParaRPr>
+          </a:p>
+          <a:p>
+            <a:pPr marL="0" indent="0" algn="l">
+              <a:buNone/>
+            </a:pPr>
+            <a:r>
+              <a:rPr b="1">
+                <a:latin typeface="+mn-ea"/>
+              </a:rPr>
+              <a:t>・既定値：Status =「申請中」にしておくと安心</a:t>
+            </a:r>
+            <a:endParaRPr lang="ja-JP" altLang="en-US" sz="2000" b="1">
+              <a:solidFill>
+                <a:srgbClr val="1F2937"/>
+              </a:solidFill>
+              <a:latin typeface="+mn-ea"/>
               <a:cs typeface="Noto Sans JP" pitchFamily="34" charset="-120"/>
             </a:endParaRPr>
           </a:p>
@@ -4531,8 +5186,7 @@
               <a:solidFill>
                 <a:srgbClr val="1F2937"/>
               </a:solidFill>
-              <a:latin typeface="Noto Sans JP" pitchFamily="34" charset="0"/>
-              <a:ea typeface="Noto Sans JP" pitchFamily="34" charset="-122"/>
+              <a:latin typeface="+mn-ea"/>
               <a:cs typeface="Noto Sans JP" pitchFamily="34" charset="-120"/>
             </a:endParaRPr>
           </a:p>
@@ -4560,8 +5214,8 @@
         </p:blipFill>
         <p:spPr>
           <a:xfrm>
-            <a:off x="7009653" y="1864303"/>
-            <a:ext cx="4810796" cy="3915321"/>
+            <a:off x="7514526" y="1808797"/>
+            <a:ext cx="4439707" cy="3613306"/>
           </a:xfrm>
           <a:prstGeom prst="rect">
             <a:avLst/>
@@ -6347,7 +7001,7 @@
         </p:nvSpPr>
         <p:spPr>
           <a:xfrm>
-            <a:off x="265580" y="2195490"/>
+            <a:off x="207159" y="1948175"/>
             <a:ext cx="7380546" cy="3947047"/>
           </a:xfrm>
           <a:prstGeom prst="rect">
@@ -6364,7 +7018,7 @@
               <a:buNone/>
             </a:pPr>
             <a:r>
-              <a:rPr lang="ja-JP" altLang="en-US">
+              <a:rPr lang="ja-JP" altLang="en-US" sz="2000">
                 <a:solidFill>
                   <a:srgbClr val="1F2937"/>
                 </a:solidFill>
@@ -6374,7 +7028,7 @@
               </a:rPr>
               <a:t>🎯 目的：申請をデータとして残しつつ、上司の判断を仰ぐ</a:t>
             </a:r>
-            <a:endParaRPr lang="en-US" altLang="ja-JP">
+            <a:endParaRPr lang="en-US" altLang="ja-JP" sz="2000">
               <a:solidFill>
                 <a:srgbClr val="1F2937"/>
               </a:solidFill>
@@ -6387,7 +7041,7 @@
             <a:pPr marL="0" indent="0" algn="l">
               <a:buNone/>
             </a:pPr>
-            <a:endParaRPr lang="en-US" altLang="ja-JP">
+            <a:endParaRPr lang="en-US" altLang="ja-JP" sz="2000">
               <a:solidFill>
                 <a:srgbClr val="1F2937"/>
               </a:solidFill>
@@ -6401,9 +7055,10 @@
               <a:buNone/>
             </a:pPr>
             <a:r>
+              <a:rPr sz="2000"/>
               <a:t>・「項目の作成」でSP「経費申請」リストに登録</a:t>
             </a:r>
-            <a:endParaRPr lang="en-US" altLang="ja-JP">
+            <a:endParaRPr lang="en-US" altLang="ja-JP" sz="2000">
               <a:solidFill>
                 <a:srgbClr val="1F2937"/>
               </a:solidFill>
@@ -6417,9 +7072,10 @@
               <a:buNone/>
             </a:pPr>
             <a:r>
+              <a:rPr sz="2000"/>
               <a:t>　Title=サマリ / Detail=詳細 / Status=申請中</a:t>
             </a:r>
-            <a:endParaRPr lang="ja-JP" altLang="en-US">
+            <a:endParaRPr lang="ja-JP" altLang="en-US" sz="2000">
               <a:solidFill>
                 <a:srgbClr val="1F2937"/>
               </a:solidFill>
@@ -6433,7 +7089,7 @@
               <a:buNone/>
             </a:pPr>
             <a:r>
-              <a:rPr lang="ja-JP" altLang="en-US">
+              <a:rPr lang="ja-JP" altLang="en-US" sz="2000">
                 <a:solidFill>
                   <a:srgbClr val="1F2937"/>
                 </a:solidFill>
@@ -6443,7 +7099,7 @@
               </a:rPr>
               <a:t>　→ 全社の申請が1か所に蓄積される</a:t>
             </a:r>
-            <a:endParaRPr lang="en-US" altLang="ja-JP">
+            <a:endParaRPr lang="en-US" altLang="ja-JP" sz="2000">
               <a:solidFill>
                 <a:srgbClr val="1F2937"/>
               </a:solidFill>
@@ -6456,7 +7112,7 @@
             <a:pPr marL="0" indent="0" algn="l">
               <a:buNone/>
             </a:pPr>
-            <a:endParaRPr lang="ja-JP" altLang="en-US">
+            <a:endParaRPr lang="ja-JP" altLang="en-US" sz="2000">
               <a:solidFill>
                 <a:srgbClr val="1F2937"/>
               </a:solidFill>
@@ -6470,9 +7126,10 @@
               <a:buNone/>
             </a:pPr>
             <a:r>
+              <a:rPr sz="2000"/>
               <a:t>・「開始して承認を待機」で上司にTeams承認カード送信</a:t>
             </a:r>
-            <a:endParaRPr lang="en-US" altLang="ja-JP">
+            <a:endParaRPr lang="en-US" altLang="ja-JP" sz="2000">
               <a:solidFill>
                 <a:srgbClr val="1F2937"/>
               </a:solidFill>
@@ -6486,7 +7143,7 @@
               <a:buNone/>
             </a:pPr>
             <a:r>
-              <a:rPr lang="ja-JP" altLang="en-US">
+              <a:rPr lang="ja-JP" altLang="en-US" sz="2000">
                 <a:solidFill>
                   <a:srgbClr val="1F2937"/>
                 </a:solidFill>
@@ -6496,7 +7153,7 @@
               </a:rPr>
               <a:t>　→ フローは上司が押すまでじっと待機</a:t>
             </a:r>
-            <a:endParaRPr lang="en-US" altLang="ja-JP">
+            <a:endParaRPr lang="en-US" altLang="ja-JP" sz="2000">
               <a:solidFill>
                 <a:srgbClr val="1F2937"/>
               </a:solidFill>
@@ -6509,7 +7166,7 @@
             <a:pPr marL="0" indent="0" algn="l">
               <a:buNone/>
             </a:pPr>
-            <a:endParaRPr lang="ja-JP" altLang="en-US" b="1">
+            <a:endParaRPr lang="ja-JP" altLang="en-US" sz="2000" b="1">
               <a:solidFill>
                 <a:srgbClr val="1F2937"/>
               </a:solidFill>
@@ -6522,7 +7179,7 @@
             <a:pPr marL="0" indent="0" algn="l">
               <a:buNone/>
             </a:pPr>
-            <a:endParaRPr lang="ja-JP" altLang="en-US" b="1" dirty="0">
+            <a:endParaRPr lang="ja-JP" altLang="en-US" sz="2000" b="1" dirty="0">
               <a:solidFill>
                 <a:srgbClr val="1F2937"/>
               </a:solidFill>
@@ -6555,7 +7212,7 @@
         </p:blipFill>
         <p:spPr>
           <a:xfrm>
-            <a:off x="7007936" y="1794289"/>
+            <a:off x="7195320" y="1760009"/>
             <a:ext cx="4115374" cy="4210638"/>
           </a:xfrm>
           <a:prstGeom prst="rect">
@@ -6595,7 +7252,7 @@
         </p:blipFill>
         <p:spPr>
           <a:xfrm>
-            <a:off x="10490911" y="3675016"/>
+            <a:off x="10345274" y="2596920"/>
             <a:ext cx="1639567" cy="1490184"/>
           </a:xfrm>
           <a:prstGeom prst="rect">
@@ -8840,7 +9497,7 @@
         <p:spPr>
           <a:xfrm>
             <a:off x="2381098" y="2124151"/>
-            <a:ext cx="9063416" cy="685800"/>
+            <a:ext cx="9544202" cy="685800"/>
           </a:xfrm>
           <a:prstGeom prst="rect">
             <a:avLst/>
@@ -8924,7 +9581,7 @@
         </p:nvSpPr>
         <p:spPr>
           <a:xfrm>
-            <a:off x="2381098" y="3286354"/>
+            <a:off x="2371953" y="3163346"/>
             <a:ext cx="8686800" cy="381305"/>
           </a:xfrm>
           <a:prstGeom prst="rect">
@@ -8963,8 +9620,8 @@
         </p:nvSpPr>
         <p:spPr>
           <a:xfrm>
-            <a:off x="2381097" y="3743554"/>
-            <a:ext cx="9810903" cy="685800"/>
+            <a:off x="2444844" y="3742639"/>
+            <a:ext cx="10172090" cy="685800"/>
           </a:xfrm>
           <a:prstGeom prst="rect">
             <a:avLst/>
@@ -8991,7 +9648,48 @@
                 <a:ea typeface="Noto Sans JP" pitchFamily="34" charset="-122"/>
                 <a:cs typeface="Noto Sans JP" pitchFamily="34" charset="-120"/>
               </a:rPr>
-              <a:t>条件分岐で日本語「承認」と比較するとハマります。outcomeは英語Approve/Rejectで比較すること。</a:t>
+              <a:t>条件分岐で日本語「承認」</a:t>
+            </a:r>
+            <a:r>
+              <a:rPr lang="en-US" sz="1800">
+                <a:solidFill>
+                  <a:srgbClr val="4B5563"/>
+                </a:solidFill>
+                <a:latin typeface="Noto Sans JP" pitchFamily="34" charset="0"/>
+                <a:ea typeface="Noto Sans JP" pitchFamily="34" charset="-122"/>
+                <a:cs typeface="Noto Sans JP" pitchFamily="34" charset="-120"/>
+              </a:rPr>
+              <a:t>と比較するとハマります。</a:t>
+            </a:r>
+          </a:p>
+          <a:p>
+            <a:pPr marL="0" indent="0" algn="l">
+              <a:lnSpc>
+                <a:spcPct val="150000"/>
+              </a:lnSpc>
+              <a:buNone/>
+            </a:pPr>
+            <a:r>
+              <a:rPr lang="en-US" sz="1800">
+                <a:solidFill>
+                  <a:srgbClr val="4B5563"/>
+                </a:solidFill>
+                <a:latin typeface="Noto Sans JP" pitchFamily="34" charset="0"/>
+                <a:ea typeface="Noto Sans JP" pitchFamily="34" charset="-122"/>
+                <a:cs typeface="Noto Sans JP" pitchFamily="34" charset="-120"/>
+              </a:rPr>
+              <a:t>outcome</a:t>
+            </a:r>
+            <a:r>
+              <a:rPr lang="en-US" sz="1800" dirty="0">
+                <a:solidFill>
+                  <a:srgbClr val="4B5563"/>
+                </a:solidFill>
+                <a:latin typeface="Noto Sans JP" pitchFamily="34" charset="0"/>
+                <a:ea typeface="Noto Sans JP" pitchFamily="34" charset="-122"/>
+                <a:cs typeface="Noto Sans JP" pitchFamily="34" charset="-120"/>
+              </a:rPr>
+              <a:t>は英語Approve/Rejectで比較すること。</a:t>
             </a:r>
             <a:endParaRPr lang="en-US" sz="1800" dirty="0"/>
           </a:p>
@@ -9458,7 +10156,7 @@
         </p:nvSpPr>
         <p:spPr>
           <a:xfrm>
-            <a:off x="1428292" y="2138930"/>
+            <a:off x="1582868" y="2181647"/>
             <a:ext cx="2781605" cy="399021"/>
           </a:xfrm>
           <a:prstGeom prst="rect">
@@ -9562,7 +10260,7 @@
         </p:nvSpPr>
         <p:spPr>
           <a:xfrm>
-            <a:off x="421292" y="3873215"/>
+            <a:off x="619049" y="3858372"/>
             <a:ext cx="3594761" cy="1002424"/>
           </a:xfrm>
           <a:prstGeom prst="rect">
@@ -9950,7 +10648,7 @@
         </p:nvSpPr>
         <p:spPr>
           <a:xfrm>
-            <a:off x="4457241" y="3031102"/>
+            <a:off x="4416094" y="3038477"/>
             <a:ext cx="3829965" cy="503999"/>
           </a:xfrm>
           <a:prstGeom prst="rect">
@@ -10006,7 +10704,7 @@
         </p:nvSpPr>
         <p:spPr>
           <a:xfrm>
-            <a:off x="4312056" y="3873215"/>
+            <a:off x="4509813" y="3873215"/>
             <a:ext cx="3594761" cy="1105967"/>
           </a:xfrm>
           <a:prstGeom prst="rect">
@@ -10454,7 +11152,7 @@
         </p:nvSpPr>
         <p:spPr>
           <a:xfrm>
-            <a:off x="8318854" y="3885659"/>
+            <a:off x="8516611" y="3885659"/>
             <a:ext cx="3467202" cy="1415952"/>
           </a:xfrm>
           <a:prstGeom prst="rect">
@@ -14009,56 +14707,6 @@
           </a:p>
         </p:txBody>
       </p:sp>
-      <p:pic>
-        <p:nvPicPr>
-          <p:cNvPr id="5" name="Image 0" descr="preencoded.png"/>
-          <p:cNvPicPr>
-            <a:picLocks noChangeAspect="1"/>
-          </p:cNvPicPr>
-          <p:nvPr/>
-        </p:nvPicPr>
-        <p:blipFill>
-          <a:blip r:embed="rId3">
-            <a:alphaModFix amt="50000"/>
-          </a:blip>
-          <a:srcRect/>
-          <a:stretch/>
-        </p:blipFill>
-        <p:spPr>
-          <a:xfrm>
-            <a:off x="10362895" y="-495605"/>
-            <a:ext cx="3657600" cy="3657600"/>
-          </a:xfrm>
-          <a:prstGeom prst="rect">
-            <a:avLst/>
-          </a:prstGeom>
-        </p:spPr>
-      </p:pic>
-      <p:pic>
-        <p:nvPicPr>
-          <p:cNvPr id="6" name="Image 1" descr="preencoded.png"/>
-          <p:cNvPicPr>
-            <a:picLocks noChangeAspect="1"/>
-          </p:cNvPicPr>
-          <p:nvPr/>
-        </p:nvPicPr>
-        <p:blipFill>
-          <a:blip r:embed="rId4">
-            <a:alphaModFix amt="50000"/>
-          </a:blip>
-          <a:srcRect/>
-          <a:stretch/>
-        </p:blipFill>
-        <p:spPr>
-          <a:xfrm>
-            <a:off x="-1828800" y="4419295"/>
-            <a:ext cx="3657600" cy="3657600"/>
-          </a:xfrm>
-          <a:prstGeom prst="rect">
-            <a:avLst/>
-          </a:prstGeom>
-        </p:spPr>
-      </p:pic>
       <p:sp>
         <p:nvSpPr>
           <p:cNvPr id="7" name="Text 3"/>
@@ -14124,7 +14772,7 @@
           <p:nvPr/>
         </p:nvPicPr>
         <p:blipFill>
-          <a:blip r:embed="rId5"/>
+          <a:blip r:embed="rId3"/>
           <a:srcRect l="-8" r="-8"/>
           <a:stretch/>
         </p:blipFill>
@@ -14183,7 +14831,7 @@
           <p:nvPr/>
         </p:nvPicPr>
         <p:blipFill>
-          <a:blip r:embed="rId6"/>
+          <a:blip r:embed="rId4"/>
           <a:srcRect l="-107" r="-107"/>
           <a:stretch/>
         </p:blipFill>
@@ -14318,7 +14966,7 @@
           <p:nvPr/>
         </p:nvPicPr>
         <p:blipFill>
-          <a:blip r:embed="rId5"/>
+          <a:blip r:embed="rId3"/>
           <a:srcRect l="-8" r="-8"/>
           <a:stretch/>
         </p:blipFill>
@@ -14377,7 +15025,7 @@
           <p:nvPr/>
         </p:nvPicPr>
         <p:blipFill>
-          <a:blip r:embed="rId7"/>
+          <a:blip r:embed="rId5"/>
           <a:srcRect l="-90" r="-90"/>
           <a:stretch/>
         </p:blipFill>
@@ -14512,7 +15160,7 @@
           <p:nvPr/>
         </p:nvPicPr>
         <p:blipFill>
-          <a:blip r:embed="rId5"/>
+          <a:blip r:embed="rId3"/>
           <a:srcRect l="-8" r="-8"/>
           <a:stretch/>
         </p:blipFill>
@@ -14571,7 +15219,7 @@
           <p:nvPr/>
         </p:nvPicPr>
         <p:blipFill>
-          <a:blip r:embed="rId8"/>
+          <a:blip r:embed="rId6"/>
           <a:srcRect l="-90" r="-90"/>
           <a:stretch/>
         </p:blipFill>
@@ -14706,7 +15354,7 @@
           <p:nvPr/>
         </p:nvPicPr>
         <p:blipFill>
-          <a:blip r:embed="rId9"/>
+          <a:blip r:embed="rId7"/>
           <a:srcRect t="-40" b="-40"/>
           <a:stretch/>
         </p:blipFill>
@@ -14804,7 +15452,7 @@
           <p:nvPr/>
         </p:nvPicPr>
         <p:blipFill>
-          <a:blip r:embed="rId10"/>
+          <a:blip r:embed="rId8"/>
           <a:srcRect l="-1648" r="-1648"/>
           <a:stretch/>
         </p:blipFill>
@@ -15189,7 +15837,7 @@
           <p:nvPr/>
         </p:nvPicPr>
         <p:blipFill>
-          <a:blip r:embed="rId11"/>
+          <a:blip r:embed="rId9"/>
           <a:srcRect t="-1" b="-1"/>
           <a:stretch/>
         </p:blipFill>
@@ -15391,7 +16039,7 @@
             <p:nvPr/>
           </p:nvPicPr>
           <p:blipFill>
-            <a:blip r:embed="rId12"/>
+            <a:blip r:embed="rId10"/>
             <a:srcRect/>
             <a:stretch/>
           </p:blipFill>
@@ -18660,7 +19308,18 @@
                 <a:ea typeface="BIZ UDGothic" pitchFamily="34" charset="-122"/>
                 <a:cs typeface="BIZ UDGothic" pitchFamily="34" charset="-120"/>
               </a:rPr>
-              <a:t>Power Automate 初心者支援が専門</a:t>
+              <a:t>Power </a:t>
+            </a:r>
+            <a:r>
+              <a:rPr lang="en-US" sz="1600" b="1">
+                <a:solidFill>
+                  <a:srgbClr val="1F2937"/>
+                </a:solidFill>
+                <a:latin typeface="BIZ UDGothic" pitchFamily="34" charset="0"/>
+                <a:ea typeface="BIZ UDGothic" pitchFamily="34" charset="-122"/>
+                <a:cs typeface="BIZ UDGothic" pitchFamily="34" charset="-120"/>
+              </a:rPr>
+              <a:t>Automate 支援が専門</a:t>
             </a:r>
             <a:endParaRPr lang="en-US" sz="1600" dirty="0"/>
           </a:p>
@@ -21562,8 +22221,8 @@
         </p:nvSpPr>
         <p:spPr>
           <a:xfrm>
-            <a:off x="457200" y="533095"/>
-            <a:ext cx="7781544" cy="715061"/>
+            <a:off x="457199" y="533095"/>
+            <a:ext cx="10852951" cy="715061"/>
           </a:xfrm>
           <a:prstGeom prst="rect">
             <a:avLst/>
@@ -21579,7 +22238,7 @@
               <a:buNone/>
             </a:pPr>
             <a:r>
-              <a:rPr lang="en-US" sz="4500" b="1" dirty="0">
+              <a:rPr lang="en-US" sz="3600" b="1" dirty="0">
                 <a:solidFill>
                   <a:srgbClr val="1F2937"/>
                 </a:solidFill>
@@ -21589,18 +22248,7 @@
               </a:rPr>
               <a:t>テーマ解説 (1/2)：申請を受け取って整える</a:t>
             </a:r>
-            <a:r>
-              <a:rPr lang="en-US" sz="2700" b="1" dirty="0">
-                <a:solidFill>
-                  <a:srgbClr val="6B7280"/>
-                </a:solidFill>
-                <a:latin typeface="Noto Sans JP" pitchFamily="34" charset="0"/>
-                <a:ea typeface="Noto Sans JP" pitchFamily="34" charset="-122"/>
-                <a:cs typeface="Noto Sans JP" pitchFamily="34" charset="-120"/>
-              </a:rPr>
-              <a:t/>
-            </a:r>
-            <a:endParaRPr lang="en-US" sz="4500" dirty="0"/>
+            <a:endParaRPr lang="en-US" sz="3600" dirty="0"/>
           </a:p>
         </p:txBody>
       </p:sp>
@@ -22130,17 +22778,6 @@
             <a:pPr marL="0" indent="0" algn="l">
               <a:buNone/>
             </a:pPr>
-            <a:r>
-              <a:rPr lang="ja-JP" altLang="en-US" sz="2000" b="1">
-                <a:solidFill>
-                  <a:srgbClr val="1F2937"/>
-                </a:solidFill>
-                <a:latin typeface="Noto Sans JP" pitchFamily="34" charset="0"/>
-                <a:ea typeface="Noto Sans JP" pitchFamily="34" charset="-122"/>
-                <a:cs typeface="Noto Sans JP" pitchFamily="34" charset="-120"/>
-              </a:rPr>
-              <a:t/>
-            </a:r>
             <a:endParaRPr lang="en-US" altLang="ja-JP" sz="2000" b="1">
               <a:solidFill>
                 <a:srgbClr val="1F2937"/>
@@ -22170,17 +22807,6 @@
             <a:pPr marL="0" indent="0" algn="l">
               <a:buNone/>
             </a:pPr>
-            <a:r>
-              <a:rPr lang="ja-JP" altLang="en-US" sz="2000" b="1">
-                <a:solidFill>
-                  <a:srgbClr val="1F2937"/>
-                </a:solidFill>
-                <a:latin typeface="Noto Sans JP" pitchFamily="34" charset="0"/>
-                <a:ea typeface="Noto Sans JP" pitchFamily="34" charset="-122"/>
-                <a:cs typeface="Noto Sans JP" pitchFamily="34" charset="-120"/>
-              </a:rPr>
-              <a:t/>
-            </a:r>
             <a:endParaRPr lang="en-US" altLang="ja-JP" sz="2000" b="1">
               <a:solidFill>
                 <a:srgbClr val="1F2937"/>
@@ -22239,17 +22865,6 @@
             <a:pPr marL="0" indent="0" algn="l">
               <a:buNone/>
             </a:pPr>
-            <a:r>
-              <a:rPr lang="ja-JP" altLang="en-US" sz="2000" b="1">
-                <a:solidFill>
-                  <a:srgbClr val="1F2937"/>
-                </a:solidFill>
-                <a:latin typeface="Noto Sans JP" pitchFamily="34" charset="0"/>
-                <a:ea typeface="Noto Sans JP" pitchFamily="34" charset="-122"/>
-                <a:cs typeface="Noto Sans JP" pitchFamily="34" charset="-120"/>
-              </a:rPr>
-              <a:t/>
-            </a:r>
             <a:endParaRPr lang="en-US" altLang="ja-JP" sz="2000" b="1">
               <a:solidFill>
                 <a:srgbClr val="1F2937"/>
@@ -22309,7 +22924,7 @@
           <p:nvPr/>
         </p:nvPicPr>
         <p:blipFill>
-          <a:blip r:embed="rId3"/>
+          <a:blip r:embed="rId2"/>
           <a:stretch>
             <a:fillRect/>
           </a:stretch>
@@ -22333,7 +22948,7 @@
 </file>
 
 <file path=ppt/slides/slide9.xml><?xml version="1.0" encoding="utf-8"?>
-<p:sld xmlns:a="http://schemas.openxmlformats.org/drawingml/2006/main" xmlns:p="http://schemas.openxmlformats.org/presentationml/2006/main" xmlns:r="http://schemas.openxmlformats.org/officeDocument/2006/relationships">
+<p:sld xmlns:a="http://schemas.openxmlformats.org/drawingml/2006/main" xmlns:r="http://schemas.openxmlformats.org/officeDocument/2006/relationships" xmlns:p="http://schemas.openxmlformats.org/presentationml/2006/main">
   <p:cSld>
     <p:spTree>
       <p:nvGrpSpPr>
@@ -22341,7 +22956,14 @@
         <p:cNvGrpSpPr/>
         <p:nvPr/>
       </p:nvGrpSpPr>
-      <p:grpSpPr/>
+      <p:grpSpPr>
+        <a:xfrm>
+          <a:off x="0" y="0"/>
+          <a:ext cx="0" cy="0"/>
+          <a:chOff x="0" y="0"/>
+          <a:chExt cx="0" cy="0"/>
+        </a:xfrm>
+      </p:grpSpPr>
       <p:sp>
         <p:nvSpPr>
           <p:cNvPr id="2" name="Shape 0"/>
@@ -22525,8 +23147,8 @@
         </p:nvSpPr>
         <p:spPr>
           <a:xfrm>
-            <a:off x="457200" y="533095"/>
-            <a:ext cx="7781544" cy="715061"/>
+            <a:off x="457199" y="533095"/>
+            <a:ext cx="10815277" cy="715061"/>
           </a:xfrm>
           <a:prstGeom prst="rect">
             <a:avLst/>
@@ -22542,7 +23164,7 @@
               <a:buNone/>
             </a:pPr>
             <a:r>
-              <a:rPr lang="en-US" sz="4500" b="1" dirty="0">
+              <a:rPr lang="en-US" sz="2800" b="1" dirty="0">
                 <a:solidFill>
                   <a:srgbClr val="1F2937"/>
                 </a:solidFill>
@@ -22552,18 +23174,7 @@
               </a:rPr>
               <a:t>テーマ解説 (2/2)：登録→承認→結果通知</a:t>
             </a:r>
-            <a:r>
-              <a:rPr lang="en-US" sz="2700" b="1" dirty="0">
-                <a:solidFill>
-                  <a:srgbClr val="6B7280"/>
-                </a:solidFill>
-                <a:latin typeface="Noto Sans JP" pitchFamily="34" charset="0"/>
-                <a:ea typeface="Noto Sans JP" pitchFamily="34" charset="-122"/>
-                <a:cs typeface="Noto Sans JP" pitchFamily="34" charset="-120"/>
-              </a:rPr>
-              <a:t/>
-            </a:r>
-            <a:endParaRPr lang="en-US" sz="4500" dirty="0"/>
+            <a:endParaRPr lang="en-US" sz="2800" dirty="0"/>
           </a:p>
         </p:txBody>
       </p:sp>
@@ -23053,8 +23664,8 @@
         </p:nvSpPr>
         <p:spPr>
           <a:xfrm>
-            <a:off x="265580" y="2195490"/>
-            <a:ext cx="5598507" cy="3947047"/>
+            <a:off x="265579" y="2229307"/>
+            <a:ext cx="6248431" cy="3913230"/>
           </a:xfrm>
           <a:prstGeom prst="rect">
             <a:avLst/>
@@ -23093,17 +23704,6 @@
             <a:pPr marL="0" indent="0" algn="l">
               <a:buNone/>
             </a:pPr>
-            <a:r>
-              <a:rPr lang="ja-JP" altLang="en-US" sz="2000" b="1">
-                <a:solidFill>
-                  <a:srgbClr val="1F2937"/>
-                </a:solidFill>
-                <a:latin typeface="Noto Sans JP" pitchFamily="34" charset="0"/>
-                <a:ea typeface="Noto Sans JP" pitchFamily="34" charset="-122"/>
-                <a:cs typeface="Noto Sans JP" pitchFamily="34" charset="-120"/>
-              </a:rPr>
-              <a:t/>
-            </a:r>
             <a:endParaRPr lang="en-US" altLang="ja-JP" sz="2000" b="1">
               <a:solidFill>
                 <a:srgbClr val="1F2937"/>
@@ -23118,6 +23718,7 @@
               <a:buNone/>
             </a:pPr>
             <a:r>
+              <a:rPr b="1"/>
               <a:t>⑤「開始して承認を待機」で上司にTeams承認カードを送信し、結果を待つ。</a:t>
             </a:r>
             <a:endParaRPr lang="en-US" altLang="ja-JP" sz="2000" b="1">
@@ -23133,17 +23734,6 @@
             <a:pPr marL="0" indent="0" algn="l">
               <a:buNone/>
             </a:pPr>
-            <a:r>
-              <a:rPr lang="ja-JP" altLang="en-US" sz="2000" b="1">
-                <a:solidFill>
-                  <a:srgbClr val="1F2937"/>
-                </a:solidFill>
-                <a:latin typeface="Noto Sans JP" pitchFamily="34" charset="0"/>
-                <a:ea typeface="Noto Sans JP" pitchFamily="34" charset="-122"/>
-                <a:cs typeface="Noto Sans JP" pitchFamily="34" charset="-120"/>
-              </a:rPr>
-              <a:t/>
-            </a:r>
             <a:endParaRPr lang="en-US" altLang="ja-JP" sz="2000" b="1">
               <a:solidFill>
                 <a:srgbClr val="1F2937"/>
@@ -23158,6 +23748,7 @@
               <a:buNone/>
             </a:pPr>
             <a:r>
+              <a:rPr b="1"/>
               <a:t>⑥「条件」で承認結果（outcome）が Approve かを判定。</a:t>
             </a:r>
             <a:endParaRPr lang="ja-JP" altLang="en-US" sz="2000" b="1">
@@ -23184,14 +23775,6 @@
               </a:rPr>
               <a:t>   - True（承認）：項目をStatus=承認済に更新 → Teamsで通知</a:t>
             </a:r>
-          </a:p>
-          <a:p>
-            <a:pPr marL="0" indent="0" algn="l">
-              <a:buNone/>
-            </a:pPr>
-            <a:r>
-              <a:t>   - False（却下）：項目をStatus=却下に更新 → Teamsで通知</a:t>
-            </a:r>
             <a:endParaRPr lang="en-US" altLang="ja-JP" sz="2000" b="1">
               <a:solidFill>
                 <a:srgbClr val="1F2937"/>
@@ -23205,30 +23788,6 @@
             <a:pPr marL="0" indent="0" algn="l">
               <a:buNone/>
             </a:pPr>
-            <a:r>
-              <a:rPr lang="ja-JP" altLang="en-US" sz="2000" b="1">
-                <a:solidFill>
-                  <a:srgbClr val="1F2937"/>
-                </a:solidFill>
-                <a:latin typeface="Noto Sans JP" pitchFamily="34" charset="0"/>
-                <a:ea typeface="Noto Sans JP" pitchFamily="34" charset="-122"/>
-                <a:cs typeface="Noto Sans JP" pitchFamily="34" charset="-120"/>
-              </a:rPr>
-              <a:t/>
-            </a:r>
-            <a:endParaRPr lang="en-US" altLang="ja-JP" sz="2000" b="1">
-              <a:solidFill>
-                <a:srgbClr val="1F2937"/>
-              </a:solidFill>
-              <a:latin typeface="Noto Sans JP" pitchFamily="34" charset="0"/>
-              <a:ea typeface="Noto Sans JP" pitchFamily="34" charset="-122"/>
-              <a:cs typeface="Noto Sans JP" pitchFamily="34" charset="-120"/>
-            </a:endParaRPr>
-          </a:p>
-          <a:p>
-            <a:pPr marL="0" indent="0" algn="l">
-              <a:buNone/>
-            </a:pPr>
             <a:endParaRPr lang="ja-JP" altLang="en-US" sz="2000" b="1">
               <a:solidFill>
                 <a:srgbClr val="1F2937"/>
@@ -23242,7 +23801,11 @@
             <a:pPr marL="0" indent="0" algn="l">
               <a:buNone/>
             </a:pPr>
-            <a:endParaRPr lang="ja-JP" altLang="en-US" sz="2000" b="1">
+            <a:r>
+              <a:rPr sz="2000" b="1"/>
+              <a:t>   - False（却下）：項目をStatus=却下に更新 → Teamsで通知</a:t>
+            </a:r>
+            <a:endParaRPr lang="ja-JP" altLang="en-US" sz="2400" b="1">
               <a:solidFill>
                 <a:srgbClr val="1F2937"/>
               </a:solidFill>
@@ -23282,8 +23845,8 @@
         </p:blipFill>
         <p:spPr>
           <a:xfrm>
-            <a:off x="8400000" y="1500000"/>
-            <a:ext cx="3100000" cy="5200000"/>
+            <a:off x="6846474" y="1765289"/>
+            <a:ext cx="4202221" cy="4356121"/>
           </a:xfrm>
           <a:prstGeom prst="rect">
             <a:avLst/>

</xml_diff>